<commit_message>
docs(review3): panel deck - team's edit to the closing slide
</commit_message>
<xml_diff>
--- a/docs/Review3_Panel_Presentation.pptx
+++ b/docs/Review3_Panel_Presentation.pptx
@@ -4,33 +4,36 @@
   <p:sldMasterIdLst>
     <p:sldMasterId id="2147483648" r:id="rId1"/>
   </p:sldMasterIdLst>
+  <p:notesMasterIdLst>
+    <p:notesMasterId r:id="rId26"/>
+  </p:notesMasterIdLst>
   <p:sldIdLst>
-    <p:sldId id="256" r:id="rId7"/>
-    <p:sldId id="257" r:id="rId9"/>
-    <p:sldId id="258" r:id="rId10"/>
-    <p:sldId id="259" r:id="rId11"/>
-    <p:sldId id="260" r:id="rId12"/>
-    <p:sldId id="261" r:id="rId13"/>
-    <p:sldId id="262" r:id="rId14"/>
-    <p:sldId id="263" r:id="rId15"/>
-    <p:sldId id="264" r:id="rId16"/>
-    <p:sldId id="265" r:id="rId17"/>
-    <p:sldId id="266" r:id="rId18"/>
-    <p:sldId id="267" r:id="rId19"/>
-    <p:sldId id="268" r:id="rId20"/>
-    <p:sldId id="269" r:id="rId21"/>
-    <p:sldId id="270" r:id="rId22"/>
-    <p:sldId id="271" r:id="rId23"/>
-    <p:sldId id="272" r:id="rId24"/>
-    <p:sldId id="273" r:id="rId25"/>
-    <p:sldId id="274" r:id="rId26"/>
-    <p:sldId id="275" r:id="rId27"/>
-    <p:sldId id="276" r:id="rId28"/>
-    <p:sldId id="277" r:id="rId29"/>
-    <p:sldId id="278" r:id="rId30"/>
-    <p:sldId id="279" r:id="rId31"/>
+    <p:sldId id="256" r:id="rId2"/>
+    <p:sldId id="257" r:id="rId3"/>
+    <p:sldId id="258" r:id="rId4"/>
+    <p:sldId id="259" r:id="rId5"/>
+    <p:sldId id="260" r:id="rId6"/>
+    <p:sldId id="261" r:id="rId7"/>
+    <p:sldId id="262" r:id="rId8"/>
+    <p:sldId id="263" r:id="rId9"/>
+    <p:sldId id="264" r:id="rId10"/>
+    <p:sldId id="265" r:id="rId11"/>
+    <p:sldId id="266" r:id="rId12"/>
+    <p:sldId id="267" r:id="rId13"/>
+    <p:sldId id="268" r:id="rId14"/>
+    <p:sldId id="269" r:id="rId15"/>
+    <p:sldId id="270" r:id="rId16"/>
+    <p:sldId id="271" r:id="rId17"/>
+    <p:sldId id="272" r:id="rId18"/>
+    <p:sldId id="273" r:id="rId19"/>
+    <p:sldId id="274" r:id="rId20"/>
+    <p:sldId id="275" r:id="rId21"/>
+    <p:sldId id="276" r:id="rId22"/>
+    <p:sldId id="277" r:id="rId23"/>
+    <p:sldId id="278" r:id="rId24"/>
+    <p:sldId id="279" r:id="rId25"/>
   </p:sldIdLst>
-  <p:sldSz cx="12191695" cy="6858000" type="screen4x3"/>
+  <p:sldSz cx="12192000" cy="6858000"/>
   <p:notesSz cx="6858000" cy="9144000"/>
   <p:defaultTextStyle>
     <a:defPPr>
@@ -127,11 +130,27 @@
       </a:defRPr>
     </a:lvl9pPr>
   </p:defaultTextStyle>
+  <p:extLst>
+    <p:ext uri="{EFAFB233-063F-42B5-8137-9DF3F51BA10A}">
+      <p15:sldGuideLst xmlns:p15="http://schemas.microsoft.com/office/powerpoint/2012/main">
+        <p15:guide id="1" orient="horz" pos="2160">
+          <p15:clr>
+            <a:srgbClr val="A4A3A4"/>
+          </p15:clr>
+        </p15:guide>
+        <p15:guide id="2" pos="2880">
+          <p15:clr>
+            <a:srgbClr val="A4A3A4"/>
+          </p15:clr>
+        </p15:guide>
+      </p15:sldGuideLst>
+    </p:ext>
+  </p:extLst>
 </p:presentation>
 </file>
 
 <file path=ppt/notesMasters/notesMaster1.xml><?xml version="1.0" encoding="utf-8"?>
-<p:notesMaster xmlns:a="http://schemas.openxmlformats.org/drawingml/2006/main" xmlns:p="http://schemas.openxmlformats.org/presentationml/2006/main" xmlns:r="http://schemas.openxmlformats.org/officeDocument/2006/relationships">
+<p:notesMaster xmlns:a="http://schemas.openxmlformats.org/drawingml/2006/main" xmlns:r="http://schemas.openxmlformats.org/officeDocument/2006/relationships" xmlns:p="http://schemas.openxmlformats.org/presentationml/2006/main">
   <p:cSld>
     <p:bg>
       <p:bgRef idx="1001">
@@ -152,241 +171,16 @@
           <a:chExt cx="0" cy="0"/>
         </a:xfrm>
       </p:grpSpPr>
-      <p:sp>
-        <p:nvSpPr>
-          <p:cNvPr id="2" name="Header Placeholder 1"/>
-          <p:cNvSpPr>
-            <a:spLocks noGrp="1"/>
-          </p:cNvSpPr>
-          <p:nvPr>
-            <p:ph type="hdr" sz="quarter"/>
-          </p:nvPr>
-        </p:nvSpPr>
-        <p:spPr>
-          <a:xfrm>
-            <a:off x="0" y="0"/>
-            <a:ext cx="2971800" cy="457200"/>
-          </a:xfrm>
-          <a:prstGeom prst="rect">
-            <a:avLst/>
-          </a:prstGeom>
-        </p:spPr>
-        <p:txBody>
-          <a:bodyPr vert="horz" lIns="91440" tIns="45720" rIns="91440" bIns="45720" rtlCol="0"/>
-          <a:lstStyle>
-            <a:lvl1pPr algn="l">
-              <a:defRPr sz="1200"/>
-            </a:lvl1pPr>
-          </a:lstStyle>
-          <a:p>
-            <a:endParaRPr lang="en-US"/>
-          </a:p>
-        </p:txBody>
-      </p:sp>
-      <p:sp>
-        <p:nvSpPr>
-          <p:cNvPr id="3" name="Date Placeholder 2"/>
-          <p:cNvSpPr>
-            <a:spLocks noGrp="1"/>
-          </p:cNvSpPr>
-          <p:nvPr>
-            <p:ph type="dt" idx="1"/>
-          </p:nvPr>
-        </p:nvSpPr>
-        <p:spPr>
-          <a:xfrm>
-            <a:off x="3884613" y="0"/>
-            <a:ext cx="2971800" cy="457200"/>
-          </a:xfrm>
-          <a:prstGeom prst="rect">
-            <a:avLst/>
-          </a:prstGeom>
-        </p:spPr>
-        <p:txBody>
-          <a:bodyPr vert="horz" lIns="91440" tIns="45720" rIns="91440" bIns="45720" rtlCol="0"/>
-          <a:lstStyle>
-            <a:lvl1pPr algn="r">
-              <a:defRPr sz="1200"/>
-            </a:lvl1pPr>
-          </a:lstStyle>
-          <a:p>
-            <a:fld id="{0F89C1C7-3DCD-1040-A9CF-14679D8B5DDD}" type="datetimeFigureOut">
-              <a:rPr lang="en-US" smtClean="0"/>
-              <a:t>10/17/16</a:t>
-            </a:fld>
-            <a:endParaRPr lang="en-US"/>
-          </a:p>
-        </p:txBody>
-      </p:sp>
-      <p:sp>
-        <p:nvSpPr>
-          <p:cNvPr id="4" name="Slide Image Placeholder 3"/>
-          <p:cNvSpPr>
-            <a:spLocks noGrp="1" noRot="1" noChangeAspect="1"/>
-          </p:cNvSpPr>
-          <p:nvPr>
-            <p:ph type="sldImg" idx="2"/>
-          </p:nvPr>
-        </p:nvSpPr>
-        <p:spPr>
-          <a:xfrm>
-            <a:off x="1143000" y="685800"/>
-            <a:ext cx="4572000" cy="3429000"/>
-          </a:xfrm>
-          <a:prstGeom prst="rect">
-            <a:avLst/>
-          </a:prstGeom>
-          <a:noFill/>
-          <a:ln w="12700">
-            <a:solidFill>
-              <a:prstClr val="black"/>
-            </a:solidFill>
-          </a:ln>
-        </p:spPr>
-        <p:txBody>
-          <a:bodyPr vert="horz" lIns="91440" tIns="45720" rIns="91440" bIns="45720" rtlCol="0" anchor="ctr"/>
-          <a:lstStyle/>
-          <a:p>
-            <a:endParaRPr lang="en-US"/>
-          </a:p>
-        </p:txBody>
-      </p:sp>
-      <p:sp>
-        <p:nvSpPr>
-          <p:cNvPr id="5" name="Notes Placeholder 4"/>
-          <p:cNvSpPr>
-            <a:spLocks noGrp="1"/>
-          </p:cNvSpPr>
-          <p:nvPr>
-            <p:ph type="body" sz="quarter" idx="3"/>
-          </p:nvPr>
-        </p:nvSpPr>
-        <p:spPr>
-          <a:xfrm>
-            <a:off x="685800" y="4343400"/>
-            <a:ext cx="5486400" cy="4114800"/>
-          </a:xfrm>
-          <a:prstGeom prst="rect">
-            <a:avLst/>
-          </a:prstGeom>
-        </p:spPr>
-        <p:txBody>
-          <a:bodyPr vert="horz" lIns="91440" tIns="45720" rIns="91440" bIns="45720" rtlCol="0"/>
-          <a:lstStyle/>
-          <a:p>
-            <a:pPr lvl="0"/>
-            <a:r>
-              <a:rPr lang="en-US" smtClean="0"/>
-              <a:t>Click to edit Master text styles</a:t>
-            </a:r>
-          </a:p>
-          <a:p>
-            <a:pPr lvl="1"/>
-            <a:r>
-              <a:rPr lang="en-US" smtClean="0"/>
-              <a:t>Second level</a:t>
-            </a:r>
-          </a:p>
-          <a:p>
-            <a:pPr lvl="2"/>
-            <a:r>
-              <a:rPr lang="en-US" smtClean="0"/>
-              <a:t>Third level</a:t>
-            </a:r>
-          </a:p>
-          <a:p>
-            <a:pPr lvl="3"/>
-            <a:r>
-              <a:rPr lang="en-US" smtClean="0"/>
-              <a:t>Fourth level</a:t>
-            </a:r>
-          </a:p>
-          <a:p>
-            <a:pPr lvl="4"/>
-            <a:r>
-              <a:rPr lang="en-US" smtClean="0"/>
-              <a:t>Fifth level</a:t>
-            </a:r>
-            <a:endParaRPr lang="en-US"/>
-          </a:p>
-        </p:txBody>
-      </p:sp>
-      <p:sp>
-        <p:nvSpPr>
-          <p:cNvPr id="6" name="Footer Placeholder 5"/>
-          <p:cNvSpPr>
-            <a:spLocks noGrp="1"/>
-          </p:cNvSpPr>
-          <p:nvPr>
-            <p:ph type="ftr" sz="quarter" idx="4"/>
-          </p:nvPr>
-        </p:nvSpPr>
-        <p:spPr>
-          <a:xfrm>
-            <a:off x="0" y="8685213"/>
-            <a:ext cx="2971800" cy="457200"/>
-          </a:xfrm>
-          <a:prstGeom prst="rect">
-            <a:avLst/>
-          </a:prstGeom>
-        </p:spPr>
-        <p:txBody>
-          <a:bodyPr vert="horz" lIns="91440" tIns="45720" rIns="91440" bIns="45720" rtlCol="0" anchor="b"/>
-          <a:lstStyle>
-            <a:lvl1pPr algn="l">
-              <a:defRPr sz="1200"/>
-            </a:lvl1pPr>
-          </a:lstStyle>
-          <a:p>
-            <a:endParaRPr lang="en-US"/>
-          </a:p>
-        </p:txBody>
-      </p:sp>
-      <p:sp>
-        <p:nvSpPr>
-          <p:cNvPr id="7" name="Slide Number Placeholder 6"/>
-          <p:cNvSpPr>
-            <a:spLocks noGrp="1"/>
-          </p:cNvSpPr>
-          <p:nvPr>
-            <p:ph type="sldNum" sz="quarter" idx="5"/>
-          </p:nvPr>
-        </p:nvSpPr>
-        <p:spPr>
-          <a:xfrm>
-            <a:off x="3884613" y="8685213"/>
-            <a:ext cx="2971800" cy="457200"/>
-          </a:xfrm>
-          <a:prstGeom prst="rect">
-            <a:avLst/>
-          </a:prstGeom>
-        </p:spPr>
-        <p:txBody>
-          <a:bodyPr vert="horz" lIns="91440" tIns="45720" rIns="91440" bIns="45720" rtlCol="0" anchor="b"/>
-          <a:lstStyle>
-            <a:lvl1pPr algn="r">
-              <a:defRPr sz="1200"/>
-            </a:lvl1pPr>
-          </a:lstStyle>
-          <a:p>
-            <a:fld id="{BB5E49A5-4136-284D-997B-48E1D791AD67}" type="slidenum">
-              <a:rPr lang="en-US" smtClean="0"/>
-              <a:t>‹#›</a:t>
-            </a:fld>
-            <a:endParaRPr lang="en-US"/>
-          </a:p>
-        </p:txBody>
-      </p:sp>
     </p:spTree>
     <p:extLst>
       <p:ext uri="{BB962C8B-B14F-4D97-AF65-F5344CB8AC3E}">
-        <p14:creationId xmlns:p14="http://schemas.microsoft.com/office/powerpoint/2010/main" val="2623252185"/>
+        <p14:creationId xmlns:p14="http://schemas.microsoft.com/office/powerpoint/2010/main" val="78794933"/>
       </p:ext>
     </p:extLst>
   </p:cSld>
   <p:clrMap bg1="lt1" tx1="dk1" bg2="lt2" tx2="dk2" accent1="accent1" accent2="accent2" accent3="accent3" accent4="accent4" accent5="accent5" accent6="accent6" hlink="hlink" folHlink="folHlink"/>
   <p:notesStyle>
-    <a:lvl1pPr marL="0" algn="l" defTabSz="457200" rtl="0" eaLnBrk="1" latinLnBrk="0" hangingPunct="1">
+    <a:lvl1pPr marL="0" algn="l" defTabSz="914400" rtl="0" eaLnBrk="1" latinLnBrk="0" hangingPunct="1">
       <a:defRPr sz="1200" kern="1200">
         <a:solidFill>
           <a:schemeClr val="tx1"/>
@@ -396,7 +190,7 @@
         <a:cs typeface="+mn-cs"/>
       </a:defRPr>
     </a:lvl1pPr>
-    <a:lvl2pPr marL="457200" algn="l" defTabSz="457200" rtl="0" eaLnBrk="1" latinLnBrk="0" hangingPunct="1">
+    <a:lvl2pPr marL="457200" algn="l" defTabSz="914400" rtl="0" eaLnBrk="1" latinLnBrk="0" hangingPunct="1">
       <a:defRPr sz="1200" kern="1200">
         <a:solidFill>
           <a:schemeClr val="tx1"/>
@@ -406,7 +200,7 @@
         <a:cs typeface="+mn-cs"/>
       </a:defRPr>
     </a:lvl2pPr>
-    <a:lvl3pPr marL="914400" algn="l" defTabSz="457200" rtl="0" eaLnBrk="1" latinLnBrk="0" hangingPunct="1">
+    <a:lvl3pPr marL="914400" algn="l" defTabSz="914400" rtl="0" eaLnBrk="1" latinLnBrk="0" hangingPunct="1">
       <a:defRPr sz="1200" kern="1200">
         <a:solidFill>
           <a:schemeClr val="tx1"/>
@@ -416,7 +210,7 @@
         <a:cs typeface="+mn-cs"/>
       </a:defRPr>
     </a:lvl3pPr>
-    <a:lvl4pPr marL="1371600" algn="l" defTabSz="457200" rtl="0" eaLnBrk="1" latinLnBrk="0" hangingPunct="1">
+    <a:lvl4pPr marL="1371600" algn="l" defTabSz="914400" rtl="0" eaLnBrk="1" latinLnBrk="0" hangingPunct="1">
       <a:defRPr sz="1200" kern="1200">
         <a:solidFill>
           <a:schemeClr val="tx1"/>
@@ -426,7 +220,7 @@
         <a:cs typeface="+mn-cs"/>
       </a:defRPr>
     </a:lvl4pPr>
-    <a:lvl5pPr marL="1828800" algn="l" defTabSz="457200" rtl="0" eaLnBrk="1" latinLnBrk="0" hangingPunct="1">
+    <a:lvl5pPr marL="1828800" algn="l" defTabSz="914400" rtl="0" eaLnBrk="1" latinLnBrk="0" hangingPunct="1">
       <a:defRPr sz="1200" kern="1200">
         <a:solidFill>
           <a:schemeClr val="tx1"/>
@@ -436,7 +230,7 @@
         <a:cs typeface="+mn-cs"/>
       </a:defRPr>
     </a:lvl5pPr>
-    <a:lvl6pPr marL="2286000" algn="l" defTabSz="457200" rtl="0" eaLnBrk="1" latinLnBrk="0" hangingPunct="1">
+    <a:lvl6pPr marL="2286000" algn="l" defTabSz="914400" rtl="0" eaLnBrk="1" latinLnBrk="0" hangingPunct="1">
       <a:defRPr sz="1200" kern="1200">
         <a:solidFill>
           <a:schemeClr val="tx1"/>
@@ -446,7 +240,7 @@
         <a:cs typeface="+mn-cs"/>
       </a:defRPr>
     </a:lvl6pPr>
-    <a:lvl7pPr marL="2743200" algn="l" defTabSz="457200" rtl="0" eaLnBrk="1" latinLnBrk="0" hangingPunct="1">
+    <a:lvl7pPr marL="2743200" algn="l" defTabSz="914400" rtl="0" eaLnBrk="1" latinLnBrk="0" hangingPunct="1">
       <a:defRPr sz="1200" kern="1200">
         <a:solidFill>
           <a:schemeClr val="tx1"/>
@@ -456,7 +250,7 @@
         <a:cs typeface="+mn-cs"/>
       </a:defRPr>
     </a:lvl7pPr>
-    <a:lvl8pPr marL="3200400" algn="l" defTabSz="457200" rtl="0" eaLnBrk="1" latinLnBrk="0" hangingPunct="1">
+    <a:lvl8pPr marL="3200400" algn="l" defTabSz="914400" rtl="0" eaLnBrk="1" latinLnBrk="0" hangingPunct="1">
       <a:defRPr sz="1200" kern="1200">
         <a:solidFill>
           <a:schemeClr val="tx1"/>
@@ -466,7 +260,7 @@
         <a:cs typeface="+mn-cs"/>
       </a:defRPr>
     </a:lvl8pPr>
-    <a:lvl9pPr marL="3657600" algn="l" defTabSz="457200" rtl="0" eaLnBrk="1" latinLnBrk="0" hangingPunct="1">
+    <a:lvl9pPr marL="3657600" algn="l" defTabSz="914400" rtl="0" eaLnBrk="1" latinLnBrk="0" hangingPunct="1">
       <a:defRPr sz="1200" kern="1200">
         <a:solidFill>
           <a:schemeClr val="tx1"/>
@@ -481,7 +275,7 @@
 </file>
 
 <file path=ppt/notesSlides/notesSlide1.xml><?xml version="1.0" encoding="utf-8"?>
-<p:notes xmlns:a="http://schemas.openxmlformats.org/drawingml/2006/main" xmlns:p="http://schemas.openxmlformats.org/presentationml/2006/main" xmlns:r="http://schemas.openxmlformats.org/officeDocument/2006/relationships">
+<p:notes xmlns:a="http://schemas.openxmlformats.org/drawingml/2006/main" xmlns:r="http://schemas.openxmlformats.org/officeDocument/2006/relationships" xmlns:p="http://schemas.openxmlformats.org/presentationml/2006/main">
   <p:cSld>
     <p:spTree>
       <p:nvGrpSpPr>
@@ -501,7 +295,7 @@
         <p:nvSpPr>
           <p:cNvPr id="2" name="Slide Image Placeholder 1"/>
           <p:cNvSpPr>
-            <a:spLocks noGrp="1"/>
+            <a:spLocks noGrp="1" noRot="1" noChangeAspect="1"/>
           </p:cNvSpPr>
           <p:nvPr>
             <p:ph type="sldImg" idx="2"/>
@@ -516,7 +310,7 @@
             <a:spLocks noGrp="1"/>
           </p:cNvSpPr>
           <p:nvPr>
-            <p:ph type="body" idx="3" sz="quarter"/>
+            <p:ph type="body" sz="quarter" idx="3"/>
           </p:nvPr>
         </p:nvSpPr>
         <p:spPr/>
@@ -537,7 +331,7 @@
             <a:spLocks noGrp="1"/>
           </p:cNvSpPr>
           <p:nvPr>
-            <p:ph type="sldNum" idx="5" sz="quarter"/>
+            <p:ph type="sldNum" sz="quarter" idx="5"/>
           </p:nvPr>
         </p:nvSpPr>
         <p:spPr/>
@@ -551,7 +345,7 @@
 </file>
 
 <file path=ppt/notesSlides/notesSlide10.xml><?xml version="1.0" encoding="utf-8"?>
-<p:notes xmlns:a="http://schemas.openxmlformats.org/drawingml/2006/main" xmlns:p="http://schemas.openxmlformats.org/presentationml/2006/main" xmlns:r="http://schemas.openxmlformats.org/officeDocument/2006/relationships">
+<p:notes xmlns:a="http://schemas.openxmlformats.org/drawingml/2006/main" xmlns:r="http://schemas.openxmlformats.org/officeDocument/2006/relationships" xmlns:p="http://schemas.openxmlformats.org/presentationml/2006/main">
   <p:cSld>
     <p:spTree>
       <p:nvGrpSpPr>
@@ -571,7 +365,7 @@
         <p:nvSpPr>
           <p:cNvPr id="2" name="Slide Image Placeholder 1"/>
           <p:cNvSpPr>
-            <a:spLocks noGrp="1"/>
+            <a:spLocks noGrp="1" noRot="1" noChangeAspect="1"/>
           </p:cNvSpPr>
           <p:nvPr>
             <p:ph type="sldImg" idx="2"/>
@@ -586,7 +380,7 @@
             <a:spLocks noGrp="1"/>
           </p:cNvSpPr>
           <p:nvPr>
-            <p:ph type="body" idx="3" sz="quarter"/>
+            <p:ph type="body" sz="quarter" idx="3"/>
           </p:nvPr>
         </p:nvSpPr>
         <p:spPr/>
@@ -607,7 +401,7 @@
             <a:spLocks noGrp="1"/>
           </p:cNvSpPr>
           <p:nvPr>
-            <p:ph type="sldNum" idx="5" sz="quarter"/>
+            <p:ph type="sldNum" sz="quarter" idx="5"/>
           </p:nvPr>
         </p:nvSpPr>
         <p:spPr/>
@@ -621,7 +415,7 @@
 </file>
 
 <file path=ppt/notesSlides/notesSlide11.xml><?xml version="1.0" encoding="utf-8"?>
-<p:notes xmlns:a="http://schemas.openxmlformats.org/drawingml/2006/main" xmlns:p="http://schemas.openxmlformats.org/presentationml/2006/main" xmlns:r="http://schemas.openxmlformats.org/officeDocument/2006/relationships">
+<p:notes xmlns:a="http://schemas.openxmlformats.org/drawingml/2006/main" xmlns:r="http://schemas.openxmlformats.org/officeDocument/2006/relationships" xmlns:p="http://schemas.openxmlformats.org/presentationml/2006/main">
   <p:cSld>
     <p:spTree>
       <p:nvGrpSpPr>
@@ -641,7 +435,7 @@
         <p:nvSpPr>
           <p:cNvPr id="2" name="Slide Image Placeholder 1"/>
           <p:cNvSpPr>
-            <a:spLocks noGrp="1"/>
+            <a:spLocks noGrp="1" noRot="1" noChangeAspect="1"/>
           </p:cNvSpPr>
           <p:nvPr>
             <p:ph type="sldImg" idx="2"/>
@@ -656,7 +450,7 @@
             <a:spLocks noGrp="1"/>
           </p:cNvSpPr>
           <p:nvPr>
-            <p:ph type="body" idx="3" sz="quarter"/>
+            <p:ph type="body" sz="quarter" idx="3"/>
           </p:nvPr>
         </p:nvSpPr>
         <p:spPr/>
@@ -677,7 +471,7 @@
             <a:spLocks noGrp="1"/>
           </p:cNvSpPr>
           <p:nvPr>
-            <p:ph type="sldNum" idx="5" sz="quarter"/>
+            <p:ph type="sldNum" sz="quarter" idx="5"/>
           </p:nvPr>
         </p:nvSpPr>
         <p:spPr/>
@@ -691,7 +485,7 @@
 </file>
 
 <file path=ppt/notesSlides/notesSlide12.xml><?xml version="1.0" encoding="utf-8"?>
-<p:notes xmlns:a="http://schemas.openxmlformats.org/drawingml/2006/main" xmlns:p="http://schemas.openxmlformats.org/presentationml/2006/main" xmlns:r="http://schemas.openxmlformats.org/officeDocument/2006/relationships">
+<p:notes xmlns:a="http://schemas.openxmlformats.org/drawingml/2006/main" xmlns:r="http://schemas.openxmlformats.org/officeDocument/2006/relationships" xmlns:p="http://schemas.openxmlformats.org/presentationml/2006/main">
   <p:cSld>
     <p:spTree>
       <p:nvGrpSpPr>
@@ -711,7 +505,7 @@
         <p:nvSpPr>
           <p:cNvPr id="2" name="Slide Image Placeholder 1"/>
           <p:cNvSpPr>
-            <a:spLocks noGrp="1"/>
+            <a:spLocks noGrp="1" noRot="1" noChangeAspect="1"/>
           </p:cNvSpPr>
           <p:nvPr>
             <p:ph type="sldImg" idx="2"/>
@@ -726,7 +520,7 @@
             <a:spLocks noGrp="1"/>
           </p:cNvSpPr>
           <p:nvPr>
-            <p:ph type="body" idx="3" sz="quarter"/>
+            <p:ph type="body" sz="quarter" idx="3"/>
           </p:nvPr>
         </p:nvSpPr>
         <p:spPr/>
@@ -747,7 +541,7 @@
             <a:spLocks noGrp="1"/>
           </p:cNvSpPr>
           <p:nvPr>
-            <p:ph type="sldNum" idx="5" sz="quarter"/>
+            <p:ph type="sldNum" sz="quarter" idx="5"/>
           </p:nvPr>
         </p:nvSpPr>
         <p:spPr/>
@@ -761,7 +555,7 @@
 </file>
 
 <file path=ppt/notesSlides/notesSlide13.xml><?xml version="1.0" encoding="utf-8"?>
-<p:notes xmlns:a="http://schemas.openxmlformats.org/drawingml/2006/main" xmlns:p="http://schemas.openxmlformats.org/presentationml/2006/main" xmlns:r="http://schemas.openxmlformats.org/officeDocument/2006/relationships">
+<p:notes xmlns:a="http://schemas.openxmlformats.org/drawingml/2006/main" xmlns:r="http://schemas.openxmlformats.org/officeDocument/2006/relationships" xmlns:p="http://schemas.openxmlformats.org/presentationml/2006/main">
   <p:cSld>
     <p:spTree>
       <p:nvGrpSpPr>
@@ -781,7 +575,7 @@
         <p:nvSpPr>
           <p:cNvPr id="2" name="Slide Image Placeholder 1"/>
           <p:cNvSpPr>
-            <a:spLocks noGrp="1"/>
+            <a:spLocks noGrp="1" noRot="1" noChangeAspect="1"/>
           </p:cNvSpPr>
           <p:nvPr>
             <p:ph type="sldImg" idx="2"/>
@@ -796,7 +590,7 @@
             <a:spLocks noGrp="1"/>
           </p:cNvSpPr>
           <p:nvPr>
-            <p:ph type="body" idx="3" sz="quarter"/>
+            <p:ph type="body" sz="quarter" idx="3"/>
           </p:nvPr>
         </p:nvSpPr>
         <p:spPr/>
@@ -817,7 +611,7 @@
             <a:spLocks noGrp="1"/>
           </p:cNvSpPr>
           <p:nvPr>
-            <p:ph type="sldNum" idx="5" sz="quarter"/>
+            <p:ph type="sldNum" sz="quarter" idx="5"/>
           </p:nvPr>
         </p:nvSpPr>
         <p:spPr/>
@@ -831,7 +625,7 @@
 </file>
 
 <file path=ppt/notesSlides/notesSlide14.xml><?xml version="1.0" encoding="utf-8"?>
-<p:notes xmlns:a="http://schemas.openxmlformats.org/drawingml/2006/main" xmlns:p="http://schemas.openxmlformats.org/presentationml/2006/main" xmlns:r="http://schemas.openxmlformats.org/officeDocument/2006/relationships">
+<p:notes xmlns:a="http://schemas.openxmlformats.org/drawingml/2006/main" xmlns:r="http://schemas.openxmlformats.org/officeDocument/2006/relationships" xmlns:p="http://schemas.openxmlformats.org/presentationml/2006/main">
   <p:cSld>
     <p:spTree>
       <p:nvGrpSpPr>
@@ -851,7 +645,7 @@
         <p:nvSpPr>
           <p:cNvPr id="2" name="Slide Image Placeholder 1"/>
           <p:cNvSpPr>
-            <a:spLocks noGrp="1"/>
+            <a:spLocks noGrp="1" noRot="1" noChangeAspect="1"/>
           </p:cNvSpPr>
           <p:nvPr>
             <p:ph type="sldImg" idx="2"/>
@@ -866,7 +660,7 @@
             <a:spLocks noGrp="1"/>
           </p:cNvSpPr>
           <p:nvPr>
-            <p:ph type="body" idx="3" sz="quarter"/>
+            <p:ph type="body" sz="quarter" idx="3"/>
           </p:nvPr>
         </p:nvSpPr>
         <p:spPr/>
@@ -887,7 +681,7 @@
             <a:spLocks noGrp="1"/>
           </p:cNvSpPr>
           <p:nvPr>
-            <p:ph type="sldNum" idx="5" sz="quarter"/>
+            <p:ph type="sldNum" sz="quarter" idx="5"/>
           </p:nvPr>
         </p:nvSpPr>
         <p:spPr/>
@@ -901,7 +695,7 @@
 </file>
 
 <file path=ppt/notesSlides/notesSlide15.xml><?xml version="1.0" encoding="utf-8"?>
-<p:notes xmlns:a="http://schemas.openxmlformats.org/drawingml/2006/main" xmlns:p="http://schemas.openxmlformats.org/presentationml/2006/main" xmlns:r="http://schemas.openxmlformats.org/officeDocument/2006/relationships">
+<p:notes xmlns:a="http://schemas.openxmlformats.org/drawingml/2006/main" xmlns:r="http://schemas.openxmlformats.org/officeDocument/2006/relationships" xmlns:p="http://schemas.openxmlformats.org/presentationml/2006/main">
   <p:cSld>
     <p:spTree>
       <p:nvGrpSpPr>
@@ -921,7 +715,7 @@
         <p:nvSpPr>
           <p:cNvPr id="2" name="Slide Image Placeholder 1"/>
           <p:cNvSpPr>
-            <a:spLocks noGrp="1"/>
+            <a:spLocks noGrp="1" noRot="1" noChangeAspect="1"/>
           </p:cNvSpPr>
           <p:nvPr>
             <p:ph type="sldImg" idx="2"/>
@@ -936,7 +730,7 @@
             <a:spLocks noGrp="1"/>
           </p:cNvSpPr>
           <p:nvPr>
-            <p:ph type="body" idx="3" sz="quarter"/>
+            <p:ph type="body" sz="quarter" idx="3"/>
           </p:nvPr>
         </p:nvSpPr>
         <p:spPr/>
@@ -957,7 +751,7 @@
             <a:spLocks noGrp="1"/>
           </p:cNvSpPr>
           <p:nvPr>
-            <p:ph type="sldNum" idx="5" sz="quarter"/>
+            <p:ph type="sldNum" sz="quarter" idx="5"/>
           </p:nvPr>
         </p:nvSpPr>
         <p:spPr/>
@@ -971,7 +765,7 @@
 </file>
 
 <file path=ppt/notesSlides/notesSlide16.xml><?xml version="1.0" encoding="utf-8"?>
-<p:notes xmlns:a="http://schemas.openxmlformats.org/drawingml/2006/main" xmlns:p="http://schemas.openxmlformats.org/presentationml/2006/main" xmlns:r="http://schemas.openxmlformats.org/officeDocument/2006/relationships">
+<p:notes xmlns:a="http://schemas.openxmlformats.org/drawingml/2006/main" xmlns:r="http://schemas.openxmlformats.org/officeDocument/2006/relationships" xmlns:p="http://schemas.openxmlformats.org/presentationml/2006/main">
   <p:cSld>
     <p:spTree>
       <p:nvGrpSpPr>
@@ -991,7 +785,7 @@
         <p:nvSpPr>
           <p:cNvPr id="2" name="Slide Image Placeholder 1"/>
           <p:cNvSpPr>
-            <a:spLocks noGrp="1"/>
+            <a:spLocks noGrp="1" noRot="1" noChangeAspect="1"/>
           </p:cNvSpPr>
           <p:nvPr>
             <p:ph type="sldImg" idx="2"/>
@@ -1006,7 +800,7 @@
             <a:spLocks noGrp="1"/>
           </p:cNvSpPr>
           <p:nvPr>
-            <p:ph type="body" idx="3" sz="quarter"/>
+            <p:ph type="body" sz="quarter" idx="3"/>
           </p:nvPr>
         </p:nvSpPr>
         <p:spPr/>
@@ -1027,7 +821,7 @@
             <a:spLocks noGrp="1"/>
           </p:cNvSpPr>
           <p:nvPr>
-            <p:ph type="sldNum" idx="5" sz="quarter"/>
+            <p:ph type="sldNum" sz="quarter" idx="5"/>
           </p:nvPr>
         </p:nvSpPr>
         <p:spPr/>
@@ -1041,7 +835,7 @@
 </file>
 
 <file path=ppt/notesSlides/notesSlide17.xml><?xml version="1.0" encoding="utf-8"?>
-<p:notes xmlns:a="http://schemas.openxmlformats.org/drawingml/2006/main" xmlns:p="http://schemas.openxmlformats.org/presentationml/2006/main" xmlns:r="http://schemas.openxmlformats.org/officeDocument/2006/relationships">
+<p:notes xmlns:a="http://schemas.openxmlformats.org/drawingml/2006/main" xmlns:r="http://schemas.openxmlformats.org/officeDocument/2006/relationships" xmlns:p="http://schemas.openxmlformats.org/presentationml/2006/main">
   <p:cSld>
     <p:spTree>
       <p:nvGrpSpPr>
@@ -1061,7 +855,7 @@
         <p:nvSpPr>
           <p:cNvPr id="2" name="Slide Image Placeholder 1"/>
           <p:cNvSpPr>
-            <a:spLocks noGrp="1"/>
+            <a:spLocks noGrp="1" noRot="1" noChangeAspect="1"/>
           </p:cNvSpPr>
           <p:nvPr>
             <p:ph type="sldImg" idx="2"/>
@@ -1076,7 +870,7 @@
             <a:spLocks noGrp="1"/>
           </p:cNvSpPr>
           <p:nvPr>
-            <p:ph type="body" idx="3" sz="quarter"/>
+            <p:ph type="body" sz="quarter" idx="3"/>
           </p:nvPr>
         </p:nvSpPr>
         <p:spPr/>
@@ -1097,7 +891,7 @@
             <a:spLocks noGrp="1"/>
           </p:cNvSpPr>
           <p:nvPr>
-            <p:ph type="sldNum" idx="5" sz="quarter"/>
+            <p:ph type="sldNum" sz="quarter" idx="5"/>
           </p:nvPr>
         </p:nvSpPr>
         <p:spPr/>
@@ -1111,7 +905,7 @@
 </file>
 
 <file path=ppt/notesSlides/notesSlide18.xml><?xml version="1.0" encoding="utf-8"?>
-<p:notes xmlns:a="http://schemas.openxmlformats.org/drawingml/2006/main" xmlns:p="http://schemas.openxmlformats.org/presentationml/2006/main" xmlns:r="http://schemas.openxmlformats.org/officeDocument/2006/relationships">
+<p:notes xmlns:a="http://schemas.openxmlformats.org/drawingml/2006/main" xmlns:r="http://schemas.openxmlformats.org/officeDocument/2006/relationships" xmlns:p="http://schemas.openxmlformats.org/presentationml/2006/main">
   <p:cSld>
     <p:spTree>
       <p:nvGrpSpPr>
@@ -1131,7 +925,7 @@
         <p:nvSpPr>
           <p:cNvPr id="2" name="Slide Image Placeholder 1"/>
           <p:cNvSpPr>
-            <a:spLocks noGrp="1"/>
+            <a:spLocks noGrp="1" noRot="1" noChangeAspect="1"/>
           </p:cNvSpPr>
           <p:nvPr>
             <p:ph type="sldImg" idx="2"/>
@@ -1146,7 +940,7 @@
             <a:spLocks noGrp="1"/>
           </p:cNvSpPr>
           <p:nvPr>
-            <p:ph type="body" idx="3" sz="quarter"/>
+            <p:ph type="body" sz="quarter" idx="3"/>
           </p:nvPr>
         </p:nvSpPr>
         <p:spPr/>
@@ -1167,7 +961,7 @@
             <a:spLocks noGrp="1"/>
           </p:cNvSpPr>
           <p:nvPr>
-            <p:ph type="sldNum" idx="5" sz="quarter"/>
+            <p:ph type="sldNum" sz="quarter" idx="5"/>
           </p:nvPr>
         </p:nvSpPr>
         <p:spPr/>
@@ -1181,7 +975,7 @@
 </file>
 
 <file path=ppt/notesSlides/notesSlide19.xml><?xml version="1.0" encoding="utf-8"?>
-<p:notes xmlns:a="http://schemas.openxmlformats.org/drawingml/2006/main" xmlns:p="http://schemas.openxmlformats.org/presentationml/2006/main" xmlns:r="http://schemas.openxmlformats.org/officeDocument/2006/relationships">
+<p:notes xmlns:a="http://schemas.openxmlformats.org/drawingml/2006/main" xmlns:r="http://schemas.openxmlformats.org/officeDocument/2006/relationships" xmlns:p="http://schemas.openxmlformats.org/presentationml/2006/main">
   <p:cSld>
     <p:spTree>
       <p:nvGrpSpPr>
@@ -1201,7 +995,7 @@
         <p:nvSpPr>
           <p:cNvPr id="2" name="Slide Image Placeholder 1"/>
           <p:cNvSpPr>
-            <a:spLocks noGrp="1"/>
+            <a:spLocks noGrp="1" noRot="1" noChangeAspect="1"/>
           </p:cNvSpPr>
           <p:nvPr>
             <p:ph type="sldImg" idx="2"/>
@@ -1216,7 +1010,7 @@
             <a:spLocks noGrp="1"/>
           </p:cNvSpPr>
           <p:nvPr>
-            <p:ph type="body" idx="3" sz="quarter"/>
+            <p:ph type="body" sz="quarter" idx="3"/>
           </p:nvPr>
         </p:nvSpPr>
         <p:spPr/>
@@ -1237,7 +1031,7 @@
             <a:spLocks noGrp="1"/>
           </p:cNvSpPr>
           <p:nvPr>
-            <p:ph type="sldNum" idx="5" sz="quarter"/>
+            <p:ph type="sldNum" sz="quarter" idx="5"/>
           </p:nvPr>
         </p:nvSpPr>
         <p:spPr/>
@@ -1251,7 +1045,7 @@
 </file>
 
 <file path=ppt/notesSlides/notesSlide2.xml><?xml version="1.0" encoding="utf-8"?>
-<p:notes xmlns:a="http://schemas.openxmlformats.org/drawingml/2006/main" xmlns:p="http://schemas.openxmlformats.org/presentationml/2006/main" xmlns:r="http://schemas.openxmlformats.org/officeDocument/2006/relationships">
+<p:notes xmlns:a="http://schemas.openxmlformats.org/drawingml/2006/main" xmlns:r="http://schemas.openxmlformats.org/officeDocument/2006/relationships" xmlns:p="http://schemas.openxmlformats.org/presentationml/2006/main">
   <p:cSld>
     <p:spTree>
       <p:nvGrpSpPr>
@@ -1271,7 +1065,7 @@
         <p:nvSpPr>
           <p:cNvPr id="2" name="Slide Image Placeholder 1"/>
           <p:cNvSpPr>
-            <a:spLocks noGrp="1"/>
+            <a:spLocks noGrp="1" noRot="1" noChangeAspect="1"/>
           </p:cNvSpPr>
           <p:nvPr>
             <p:ph type="sldImg" idx="2"/>
@@ -1286,7 +1080,7 @@
             <a:spLocks noGrp="1"/>
           </p:cNvSpPr>
           <p:nvPr>
-            <p:ph type="body" idx="3" sz="quarter"/>
+            <p:ph type="body" sz="quarter" idx="3"/>
           </p:nvPr>
         </p:nvSpPr>
         <p:spPr/>
@@ -1307,7 +1101,7 @@
             <a:spLocks noGrp="1"/>
           </p:cNvSpPr>
           <p:nvPr>
-            <p:ph type="sldNum" idx="5" sz="quarter"/>
+            <p:ph type="sldNum" sz="quarter" idx="5"/>
           </p:nvPr>
         </p:nvSpPr>
         <p:spPr/>
@@ -1321,7 +1115,7 @@
 </file>
 
 <file path=ppt/notesSlides/notesSlide20.xml><?xml version="1.0" encoding="utf-8"?>
-<p:notes xmlns:a="http://schemas.openxmlformats.org/drawingml/2006/main" xmlns:p="http://schemas.openxmlformats.org/presentationml/2006/main" xmlns:r="http://schemas.openxmlformats.org/officeDocument/2006/relationships">
+<p:notes xmlns:a="http://schemas.openxmlformats.org/drawingml/2006/main" xmlns:r="http://schemas.openxmlformats.org/officeDocument/2006/relationships" xmlns:p="http://schemas.openxmlformats.org/presentationml/2006/main">
   <p:cSld>
     <p:spTree>
       <p:nvGrpSpPr>
@@ -1341,7 +1135,7 @@
         <p:nvSpPr>
           <p:cNvPr id="2" name="Slide Image Placeholder 1"/>
           <p:cNvSpPr>
-            <a:spLocks noGrp="1"/>
+            <a:spLocks noGrp="1" noRot="1" noChangeAspect="1"/>
           </p:cNvSpPr>
           <p:nvPr>
             <p:ph type="sldImg" idx="2"/>
@@ -1356,7 +1150,7 @@
             <a:spLocks noGrp="1"/>
           </p:cNvSpPr>
           <p:nvPr>
-            <p:ph type="body" idx="3" sz="quarter"/>
+            <p:ph type="body" sz="quarter" idx="3"/>
           </p:nvPr>
         </p:nvSpPr>
         <p:spPr/>
@@ -1377,7 +1171,7 @@
             <a:spLocks noGrp="1"/>
           </p:cNvSpPr>
           <p:nvPr>
-            <p:ph type="sldNum" idx="5" sz="quarter"/>
+            <p:ph type="sldNum" sz="quarter" idx="5"/>
           </p:nvPr>
         </p:nvSpPr>
         <p:spPr/>
@@ -1391,7 +1185,7 @@
 </file>
 
 <file path=ppt/notesSlides/notesSlide21.xml><?xml version="1.0" encoding="utf-8"?>
-<p:notes xmlns:a="http://schemas.openxmlformats.org/drawingml/2006/main" xmlns:p="http://schemas.openxmlformats.org/presentationml/2006/main" xmlns:r="http://schemas.openxmlformats.org/officeDocument/2006/relationships">
+<p:notes xmlns:a="http://schemas.openxmlformats.org/drawingml/2006/main" xmlns:r="http://schemas.openxmlformats.org/officeDocument/2006/relationships" xmlns:p="http://schemas.openxmlformats.org/presentationml/2006/main">
   <p:cSld>
     <p:spTree>
       <p:nvGrpSpPr>
@@ -1411,7 +1205,7 @@
         <p:nvSpPr>
           <p:cNvPr id="2" name="Slide Image Placeholder 1"/>
           <p:cNvSpPr>
-            <a:spLocks noGrp="1"/>
+            <a:spLocks noGrp="1" noRot="1" noChangeAspect="1"/>
           </p:cNvSpPr>
           <p:nvPr>
             <p:ph type="sldImg" idx="2"/>
@@ -1426,7 +1220,7 @@
             <a:spLocks noGrp="1"/>
           </p:cNvSpPr>
           <p:nvPr>
-            <p:ph type="body" idx="3" sz="quarter"/>
+            <p:ph type="body" sz="quarter" idx="3"/>
           </p:nvPr>
         </p:nvSpPr>
         <p:spPr/>
@@ -1447,7 +1241,7 @@
             <a:spLocks noGrp="1"/>
           </p:cNvSpPr>
           <p:nvPr>
-            <p:ph type="sldNum" idx="5" sz="quarter"/>
+            <p:ph type="sldNum" sz="quarter" idx="5"/>
           </p:nvPr>
         </p:nvSpPr>
         <p:spPr/>
@@ -1461,7 +1255,7 @@
 </file>
 
 <file path=ppt/notesSlides/notesSlide22.xml><?xml version="1.0" encoding="utf-8"?>
-<p:notes xmlns:a="http://schemas.openxmlformats.org/drawingml/2006/main" xmlns:p="http://schemas.openxmlformats.org/presentationml/2006/main" xmlns:r="http://schemas.openxmlformats.org/officeDocument/2006/relationships">
+<p:notes xmlns:a="http://schemas.openxmlformats.org/drawingml/2006/main" xmlns:r="http://schemas.openxmlformats.org/officeDocument/2006/relationships" xmlns:p="http://schemas.openxmlformats.org/presentationml/2006/main">
   <p:cSld>
     <p:spTree>
       <p:nvGrpSpPr>
@@ -1481,7 +1275,7 @@
         <p:nvSpPr>
           <p:cNvPr id="2" name="Slide Image Placeholder 1"/>
           <p:cNvSpPr>
-            <a:spLocks noGrp="1"/>
+            <a:spLocks noGrp="1" noRot="1" noChangeAspect="1"/>
           </p:cNvSpPr>
           <p:nvPr>
             <p:ph type="sldImg" idx="2"/>
@@ -1496,7 +1290,7 @@
             <a:spLocks noGrp="1"/>
           </p:cNvSpPr>
           <p:nvPr>
-            <p:ph type="body" idx="3" sz="quarter"/>
+            <p:ph type="body" sz="quarter" idx="3"/>
           </p:nvPr>
         </p:nvSpPr>
         <p:spPr/>
@@ -1517,7 +1311,7 @@
             <a:spLocks noGrp="1"/>
           </p:cNvSpPr>
           <p:nvPr>
-            <p:ph type="sldNum" idx="5" sz="quarter"/>
+            <p:ph type="sldNum" sz="quarter" idx="5"/>
           </p:nvPr>
         </p:nvSpPr>
         <p:spPr/>
@@ -1531,7 +1325,7 @@
 </file>
 
 <file path=ppt/notesSlides/notesSlide23.xml><?xml version="1.0" encoding="utf-8"?>
-<p:notes xmlns:a="http://schemas.openxmlformats.org/drawingml/2006/main" xmlns:p="http://schemas.openxmlformats.org/presentationml/2006/main" xmlns:r="http://schemas.openxmlformats.org/officeDocument/2006/relationships">
+<p:notes xmlns:a="http://schemas.openxmlformats.org/drawingml/2006/main" xmlns:r="http://schemas.openxmlformats.org/officeDocument/2006/relationships" xmlns:p="http://schemas.openxmlformats.org/presentationml/2006/main">
   <p:cSld>
     <p:spTree>
       <p:nvGrpSpPr>
@@ -1551,7 +1345,7 @@
         <p:nvSpPr>
           <p:cNvPr id="2" name="Slide Image Placeholder 1"/>
           <p:cNvSpPr>
-            <a:spLocks noGrp="1"/>
+            <a:spLocks noGrp="1" noRot="1" noChangeAspect="1"/>
           </p:cNvSpPr>
           <p:nvPr>
             <p:ph type="sldImg" idx="2"/>
@@ -1566,7 +1360,7 @@
             <a:spLocks noGrp="1"/>
           </p:cNvSpPr>
           <p:nvPr>
-            <p:ph type="body" idx="3" sz="quarter"/>
+            <p:ph type="body" sz="quarter" idx="3"/>
           </p:nvPr>
         </p:nvSpPr>
         <p:spPr/>
@@ -1587,7 +1381,7 @@
             <a:spLocks noGrp="1"/>
           </p:cNvSpPr>
           <p:nvPr>
-            <p:ph type="sldNum" idx="5" sz="quarter"/>
+            <p:ph type="sldNum" sz="quarter" idx="5"/>
           </p:nvPr>
         </p:nvSpPr>
         <p:spPr/>
@@ -1601,7 +1395,7 @@
 </file>
 
 <file path=ppt/notesSlides/notesSlide24.xml><?xml version="1.0" encoding="utf-8"?>
-<p:notes xmlns:a="http://schemas.openxmlformats.org/drawingml/2006/main" xmlns:p="http://schemas.openxmlformats.org/presentationml/2006/main" xmlns:r="http://schemas.openxmlformats.org/officeDocument/2006/relationships">
+<p:notes xmlns:a="http://schemas.openxmlformats.org/drawingml/2006/main" xmlns:r="http://schemas.openxmlformats.org/officeDocument/2006/relationships" xmlns:p="http://schemas.openxmlformats.org/presentationml/2006/main">
   <p:cSld>
     <p:spTree>
       <p:nvGrpSpPr>
@@ -1621,7 +1415,7 @@
         <p:nvSpPr>
           <p:cNvPr id="2" name="Slide Image Placeholder 1"/>
           <p:cNvSpPr>
-            <a:spLocks noGrp="1"/>
+            <a:spLocks noGrp="1" noRot="1" noChangeAspect="1"/>
           </p:cNvSpPr>
           <p:nvPr>
             <p:ph type="sldImg" idx="2"/>
@@ -1636,7 +1430,7 @@
             <a:spLocks noGrp="1"/>
           </p:cNvSpPr>
           <p:nvPr>
-            <p:ph type="body" idx="3" sz="quarter"/>
+            <p:ph type="body" sz="quarter" idx="3"/>
           </p:nvPr>
         </p:nvSpPr>
         <p:spPr/>
@@ -1657,7 +1451,7 @@
             <a:spLocks noGrp="1"/>
           </p:cNvSpPr>
           <p:nvPr>
-            <p:ph type="sldNum" idx="5" sz="quarter"/>
+            <p:ph type="sldNum" sz="quarter" idx="5"/>
           </p:nvPr>
         </p:nvSpPr>
         <p:spPr/>
@@ -1671,7 +1465,7 @@
 </file>
 
 <file path=ppt/notesSlides/notesSlide3.xml><?xml version="1.0" encoding="utf-8"?>
-<p:notes xmlns:a="http://schemas.openxmlformats.org/drawingml/2006/main" xmlns:p="http://schemas.openxmlformats.org/presentationml/2006/main" xmlns:r="http://schemas.openxmlformats.org/officeDocument/2006/relationships">
+<p:notes xmlns:a="http://schemas.openxmlformats.org/drawingml/2006/main" xmlns:r="http://schemas.openxmlformats.org/officeDocument/2006/relationships" xmlns:p="http://schemas.openxmlformats.org/presentationml/2006/main">
   <p:cSld>
     <p:spTree>
       <p:nvGrpSpPr>
@@ -1691,7 +1485,7 @@
         <p:nvSpPr>
           <p:cNvPr id="2" name="Slide Image Placeholder 1"/>
           <p:cNvSpPr>
-            <a:spLocks noGrp="1"/>
+            <a:spLocks noGrp="1" noRot="1" noChangeAspect="1"/>
           </p:cNvSpPr>
           <p:nvPr>
             <p:ph type="sldImg" idx="2"/>
@@ -1706,7 +1500,7 @@
             <a:spLocks noGrp="1"/>
           </p:cNvSpPr>
           <p:nvPr>
-            <p:ph type="body" idx="3" sz="quarter"/>
+            <p:ph type="body" sz="quarter" idx="3"/>
           </p:nvPr>
         </p:nvSpPr>
         <p:spPr/>
@@ -1727,7 +1521,7 @@
             <a:spLocks noGrp="1"/>
           </p:cNvSpPr>
           <p:nvPr>
-            <p:ph type="sldNum" idx="5" sz="quarter"/>
+            <p:ph type="sldNum" sz="quarter" idx="5"/>
           </p:nvPr>
         </p:nvSpPr>
         <p:spPr/>
@@ -1741,7 +1535,7 @@
 </file>
 
 <file path=ppt/notesSlides/notesSlide4.xml><?xml version="1.0" encoding="utf-8"?>
-<p:notes xmlns:a="http://schemas.openxmlformats.org/drawingml/2006/main" xmlns:p="http://schemas.openxmlformats.org/presentationml/2006/main" xmlns:r="http://schemas.openxmlformats.org/officeDocument/2006/relationships">
+<p:notes xmlns:a="http://schemas.openxmlformats.org/drawingml/2006/main" xmlns:r="http://schemas.openxmlformats.org/officeDocument/2006/relationships" xmlns:p="http://schemas.openxmlformats.org/presentationml/2006/main">
   <p:cSld>
     <p:spTree>
       <p:nvGrpSpPr>
@@ -1761,7 +1555,7 @@
         <p:nvSpPr>
           <p:cNvPr id="2" name="Slide Image Placeholder 1"/>
           <p:cNvSpPr>
-            <a:spLocks noGrp="1"/>
+            <a:spLocks noGrp="1" noRot="1" noChangeAspect="1"/>
           </p:cNvSpPr>
           <p:nvPr>
             <p:ph type="sldImg" idx="2"/>
@@ -1776,7 +1570,7 @@
             <a:spLocks noGrp="1"/>
           </p:cNvSpPr>
           <p:nvPr>
-            <p:ph type="body" idx="3" sz="quarter"/>
+            <p:ph type="body" sz="quarter" idx="3"/>
           </p:nvPr>
         </p:nvSpPr>
         <p:spPr/>
@@ -1797,7 +1591,7 @@
             <a:spLocks noGrp="1"/>
           </p:cNvSpPr>
           <p:nvPr>
-            <p:ph type="sldNum" idx="5" sz="quarter"/>
+            <p:ph type="sldNum" sz="quarter" idx="5"/>
           </p:nvPr>
         </p:nvSpPr>
         <p:spPr/>
@@ -1811,7 +1605,7 @@
 </file>
 
 <file path=ppt/notesSlides/notesSlide5.xml><?xml version="1.0" encoding="utf-8"?>
-<p:notes xmlns:a="http://schemas.openxmlformats.org/drawingml/2006/main" xmlns:p="http://schemas.openxmlformats.org/presentationml/2006/main" xmlns:r="http://schemas.openxmlformats.org/officeDocument/2006/relationships">
+<p:notes xmlns:a="http://schemas.openxmlformats.org/drawingml/2006/main" xmlns:r="http://schemas.openxmlformats.org/officeDocument/2006/relationships" xmlns:p="http://schemas.openxmlformats.org/presentationml/2006/main">
   <p:cSld>
     <p:spTree>
       <p:nvGrpSpPr>
@@ -1831,7 +1625,7 @@
         <p:nvSpPr>
           <p:cNvPr id="2" name="Slide Image Placeholder 1"/>
           <p:cNvSpPr>
-            <a:spLocks noGrp="1"/>
+            <a:spLocks noGrp="1" noRot="1" noChangeAspect="1"/>
           </p:cNvSpPr>
           <p:nvPr>
             <p:ph type="sldImg" idx="2"/>
@@ -1846,7 +1640,7 @@
             <a:spLocks noGrp="1"/>
           </p:cNvSpPr>
           <p:nvPr>
-            <p:ph type="body" idx="3" sz="quarter"/>
+            <p:ph type="body" sz="quarter" idx="3"/>
           </p:nvPr>
         </p:nvSpPr>
         <p:spPr/>
@@ -1867,7 +1661,7 @@
             <a:spLocks noGrp="1"/>
           </p:cNvSpPr>
           <p:nvPr>
-            <p:ph type="sldNum" idx="5" sz="quarter"/>
+            <p:ph type="sldNum" sz="quarter" idx="5"/>
           </p:nvPr>
         </p:nvSpPr>
         <p:spPr/>
@@ -1881,7 +1675,7 @@
 </file>
 
 <file path=ppt/notesSlides/notesSlide6.xml><?xml version="1.0" encoding="utf-8"?>
-<p:notes xmlns:a="http://schemas.openxmlformats.org/drawingml/2006/main" xmlns:p="http://schemas.openxmlformats.org/presentationml/2006/main" xmlns:r="http://schemas.openxmlformats.org/officeDocument/2006/relationships">
+<p:notes xmlns:a="http://schemas.openxmlformats.org/drawingml/2006/main" xmlns:r="http://schemas.openxmlformats.org/officeDocument/2006/relationships" xmlns:p="http://schemas.openxmlformats.org/presentationml/2006/main">
   <p:cSld>
     <p:spTree>
       <p:nvGrpSpPr>
@@ -1901,7 +1695,7 @@
         <p:nvSpPr>
           <p:cNvPr id="2" name="Slide Image Placeholder 1"/>
           <p:cNvSpPr>
-            <a:spLocks noGrp="1"/>
+            <a:spLocks noGrp="1" noRot="1" noChangeAspect="1"/>
           </p:cNvSpPr>
           <p:nvPr>
             <p:ph type="sldImg" idx="2"/>
@@ -1916,7 +1710,7 @@
             <a:spLocks noGrp="1"/>
           </p:cNvSpPr>
           <p:nvPr>
-            <p:ph type="body" idx="3" sz="quarter"/>
+            <p:ph type="body" sz="quarter" idx="3"/>
           </p:nvPr>
         </p:nvSpPr>
         <p:spPr/>
@@ -1937,7 +1731,7 @@
             <a:spLocks noGrp="1"/>
           </p:cNvSpPr>
           <p:nvPr>
-            <p:ph type="sldNum" idx="5" sz="quarter"/>
+            <p:ph type="sldNum" sz="quarter" idx="5"/>
           </p:nvPr>
         </p:nvSpPr>
         <p:spPr/>
@@ -1951,7 +1745,7 @@
 </file>
 
 <file path=ppt/notesSlides/notesSlide7.xml><?xml version="1.0" encoding="utf-8"?>
-<p:notes xmlns:a="http://schemas.openxmlformats.org/drawingml/2006/main" xmlns:p="http://schemas.openxmlformats.org/presentationml/2006/main" xmlns:r="http://schemas.openxmlformats.org/officeDocument/2006/relationships">
+<p:notes xmlns:a="http://schemas.openxmlformats.org/drawingml/2006/main" xmlns:r="http://schemas.openxmlformats.org/officeDocument/2006/relationships" xmlns:p="http://schemas.openxmlformats.org/presentationml/2006/main">
   <p:cSld>
     <p:spTree>
       <p:nvGrpSpPr>
@@ -1971,7 +1765,7 @@
         <p:nvSpPr>
           <p:cNvPr id="2" name="Slide Image Placeholder 1"/>
           <p:cNvSpPr>
-            <a:spLocks noGrp="1"/>
+            <a:spLocks noGrp="1" noRot="1" noChangeAspect="1"/>
           </p:cNvSpPr>
           <p:nvPr>
             <p:ph type="sldImg" idx="2"/>
@@ -1986,7 +1780,7 @@
             <a:spLocks noGrp="1"/>
           </p:cNvSpPr>
           <p:nvPr>
-            <p:ph type="body" idx="3" sz="quarter"/>
+            <p:ph type="body" sz="quarter" idx="3"/>
           </p:nvPr>
         </p:nvSpPr>
         <p:spPr/>
@@ -2007,7 +1801,7 @@
             <a:spLocks noGrp="1"/>
           </p:cNvSpPr>
           <p:nvPr>
-            <p:ph type="sldNum" idx="5" sz="quarter"/>
+            <p:ph type="sldNum" sz="quarter" idx="5"/>
           </p:nvPr>
         </p:nvSpPr>
         <p:spPr/>
@@ -2021,7 +1815,7 @@
 </file>
 
 <file path=ppt/notesSlides/notesSlide8.xml><?xml version="1.0" encoding="utf-8"?>
-<p:notes xmlns:a="http://schemas.openxmlformats.org/drawingml/2006/main" xmlns:p="http://schemas.openxmlformats.org/presentationml/2006/main" xmlns:r="http://schemas.openxmlformats.org/officeDocument/2006/relationships">
+<p:notes xmlns:a="http://schemas.openxmlformats.org/drawingml/2006/main" xmlns:r="http://schemas.openxmlformats.org/officeDocument/2006/relationships" xmlns:p="http://schemas.openxmlformats.org/presentationml/2006/main">
   <p:cSld>
     <p:spTree>
       <p:nvGrpSpPr>
@@ -2041,7 +1835,7 @@
         <p:nvSpPr>
           <p:cNvPr id="2" name="Slide Image Placeholder 1"/>
           <p:cNvSpPr>
-            <a:spLocks noGrp="1"/>
+            <a:spLocks noGrp="1" noRot="1" noChangeAspect="1"/>
           </p:cNvSpPr>
           <p:nvPr>
             <p:ph type="sldImg" idx="2"/>
@@ -2056,7 +1850,7 @@
             <a:spLocks noGrp="1"/>
           </p:cNvSpPr>
           <p:nvPr>
-            <p:ph type="body" idx="3" sz="quarter"/>
+            <p:ph type="body" sz="quarter" idx="3"/>
           </p:nvPr>
         </p:nvSpPr>
         <p:spPr/>
@@ -2077,7 +1871,7 @@
             <a:spLocks noGrp="1"/>
           </p:cNvSpPr>
           <p:nvPr>
-            <p:ph type="sldNum" idx="5" sz="quarter"/>
+            <p:ph type="sldNum" sz="quarter" idx="5"/>
           </p:nvPr>
         </p:nvSpPr>
         <p:spPr/>
@@ -2091,7 +1885,7 @@
 </file>
 
 <file path=ppt/notesSlides/notesSlide9.xml><?xml version="1.0" encoding="utf-8"?>
-<p:notes xmlns:a="http://schemas.openxmlformats.org/drawingml/2006/main" xmlns:p="http://schemas.openxmlformats.org/presentationml/2006/main" xmlns:r="http://schemas.openxmlformats.org/officeDocument/2006/relationships">
+<p:notes xmlns:a="http://schemas.openxmlformats.org/drawingml/2006/main" xmlns:r="http://schemas.openxmlformats.org/officeDocument/2006/relationships" xmlns:p="http://schemas.openxmlformats.org/presentationml/2006/main">
   <p:cSld>
     <p:spTree>
       <p:nvGrpSpPr>
@@ -2111,7 +1905,7 @@
         <p:nvSpPr>
           <p:cNvPr id="2" name="Slide Image Placeholder 1"/>
           <p:cNvSpPr>
-            <a:spLocks noGrp="1"/>
+            <a:spLocks noGrp="1" noRot="1" noChangeAspect="1"/>
           </p:cNvSpPr>
           <p:nvPr>
             <p:ph type="sldImg" idx="2"/>
@@ -2126,7 +1920,7 @@
             <a:spLocks noGrp="1"/>
           </p:cNvSpPr>
           <p:nvPr>
-            <p:ph type="body" idx="3" sz="quarter"/>
+            <p:ph type="body" sz="quarter" idx="3"/>
           </p:nvPr>
         </p:nvSpPr>
         <p:spPr/>
@@ -2147,7 +1941,7 @@
             <a:spLocks noGrp="1"/>
           </p:cNvSpPr>
           <p:nvPr>
-            <p:ph type="sldNum" idx="5" sz="quarter"/>
+            <p:ph type="sldNum" sz="quarter" idx="5"/>
           </p:nvPr>
         </p:nvSpPr>
         <p:spPr/>
@@ -2198,10 +1992,9 @@
           <a:lstStyle/>
           <a:p>
             <a:r>
-              <a:rPr lang="en-US" smtClean="0"/>
+              <a:rPr lang="en-US"/>
               <a:t>Click to edit Master title style</a:t>
             </a:r>
-            <a:endParaRPr lang="en-US"/>
           </a:p>
         </p:txBody>
       </p:sp>
@@ -2317,10 +2110,9 @@
           </a:lstStyle>
           <a:p>
             <a:r>
-              <a:rPr lang="en-US" smtClean="0"/>
+              <a:rPr lang="en-US"/>
               <a:t>Click to edit Master subtitle style</a:t>
             </a:r>
-            <a:endParaRPr lang="en-US"/>
           </a:p>
         </p:txBody>
       </p:sp>
@@ -2341,7 +2133,7 @@
           <a:p>
             <a:fld id="{5BCAD085-E8A6-8845-BD4E-CB4CCA059FC4}" type="datetimeFigureOut">
               <a:rPr lang="en-US" smtClean="0"/>
-              <a:t>1/27/13</a:t>
+              <a:t>9/13/2026</a:t>
             </a:fld>
             <a:endParaRPr lang="en-US"/>
           </a:p>
@@ -2435,10 +2227,9 @@
           <a:lstStyle/>
           <a:p>
             <a:r>
-              <a:rPr lang="en-US" smtClean="0"/>
+              <a:rPr lang="en-US"/>
               <a:t>Click to edit Master title style</a:t>
             </a:r>
-            <a:endParaRPr lang="en-US"/>
           </a:p>
         </p:txBody>
       </p:sp>
@@ -2459,38 +2250,37 @@
           <a:p>
             <a:pPr lvl="0"/>
             <a:r>
-              <a:rPr lang="en-US" smtClean="0"/>
+              <a:rPr lang="en-US"/>
               <a:t>Click to edit Master text styles</a:t>
             </a:r>
           </a:p>
           <a:p>
             <a:pPr lvl="1"/>
             <a:r>
-              <a:rPr lang="en-US" smtClean="0"/>
+              <a:rPr lang="en-US"/>
               <a:t>Second level</a:t>
             </a:r>
           </a:p>
           <a:p>
             <a:pPr lvl="2"/>
             <a:r>
-              <a:rPr lang="en-US" smtClean="0"/>
+              <a:rPr lang="en-US"/>
               <a:t>Third level</a:t>
             </a:r>
           </a:p>
           <a:p>
             <a:pPr lvl="3"/>
             <a:r>
-              <a:rPr lang="en-US" smtClean="0"/>
+              <a:rPr lang="en-US"/>
               <a:t>Fourth level</a:t>
             </a:r>
           </a:p>
           <a:p>
             <a:pPr lvl="4"/>
             <a:r>
-              <a:rPr lang="en-US" smtClean="0"/>
+              <a:rPr lang="en-US"/>
               <a:t>Fifth level</a:t>
             </a:r>
-            <a:endParaRPr lang="en-US"/>
           </a:p>
         </p:txBody>
       </p:sp>
@@ -2511,7 +2301,7 @@
           <a:p>
             <a:fld id="{5BCAD085-E8A6-8845-BD4E-CB4CCA059FC4}" type="datetimeFigureOut">
               <a:rPr lang="en-US" smtClean="0"/>
-              <a:t>1/27/13</a:t>
+              <a:t>9/13/2026</a:t>
             </a:fld>
             <a:endParaRPr lang="en-US"/>
           </a:p>
@@ -2610,10 +2400,9 @@
           <a:lstStyle/>
           <a:p>
             <a:r>
-              <a:rPr lang="en-US" smtClean="0"/>
+              <a:rPr lang="en-US"/>
               <a:t>Click to edit Master title style</a:t>
             </a:r>
-            <a:endParaRPr lang="en-US"/>
           </a:p>
         </p:txBody>
       </p:sp>
@@ -2639,38 +2428,37 @@
           <a:p>
             <a:pPr lvl="0"/>
             <a:r>
-              <a:rPr lang="en-US" smtClean="0"/>
+              <a:rPr lang="en-US"/>
               <a:t>Click to edit Master text styles</a:t>
             </a:r>
           </a:p>
           <a:p>
             <a:pPr lvl="1"/>
             <a:r>
-              <a:rPr lang="en-US" smtClean="0"/>
+              <a:rPr lang="en-US"/>
               <a:t>Second level</a:t>
             </a:r>
           </a:p>
           <a:p>
             <a:pPr lvl="2"/>
             <a:r>
-              <a:rPr lang="en-US" smtClean="0"/>
+              <a:rPr lang="en-US"/>
               <a:t>Third level</a:t>
             </a:r>
           </a:p>
           <a:p>
             <a:pPr lvl="3"/>
             <a:r>
-              <a:rPr lang="en-US" smtClean="0"/>
+              <a:rPr lang="en-US"/>
               <a:t>Fourth level</a:t>
             </a:r>
           </a:p>
           <a:p>
             <a:pPr lvl="4"/>
             <a:r>
-              <a:rPr lang="en-US" smtClean="0"/>
+              <a:rPr lang="en-US"/>
               <a:t>Fifth level</a:t>
             </a:r>
-            <a:endParaRPr lang="en-US"/>
           </a:p>
         </p:txBody>
       </p:sp>
@@ -2691,7 +2479,7 @@
           <a:p>
             <a:fld id="{5BCAD085-E8A6-8845-BD4E-CB4CCA059FC4}" type="datetimeFigureOut">
               <a:rPr lang="en-US" smtClean="0"/>
-              <a:t>1/27/13</a:t>
+              <a:t>9/13/2026</a:t>
             </a:fld>
             <a:endParaRPr lang="en-US"/>
           </a:p>
@@ -2785,10 +2573,9 @@
           <a:lstStyle/>
           <a:p>
             <a:r>
-              <a:rPr lang="en-US" smtClean="0"/>
+              <a:rPr lang="en-US"/>
               <a:t>Click to edit Master title style</a:t>
             </a:r>
-            <a:endParaRPr lang="en-US"/>
           </a:p>
         </p:txBody>
       </p:sp>
@@ -2809,38 +2596,37 @@
           <a:p>
             <a:pPr lvl="0"/>
             <a:r>
-              <a:rPr lang="en-US" smtClean="0"/>
+              <a:rPr lang="en-US"/>
               <a:t>Click to edit Master text styles</a:t>
             </a:r>
           </a:p>
           <a:p>
             <a:pPr lvl="1"/>
             <a:r>
-              <a:rPr lang="en-US" smtClean="0"/>
+              <a:rPr lang="en-US"/>
               <a:t>Second level</a:t>
             </a:r>
           </a:p>
           <a:p>
             <a:pPr lvl="2"/>
             <a:r>
-              <a:rPr lang="en-US" smtClean="0"/>
+              <a:rPr lang="en-US"/>
               <a:t>Third level</a:t>
             </a:r>
           </a:p>
           <a:p>
             <a:pPr lvl="3"/>
             <a:r>
-              <a:rPr lang="en-US" smtClean="0"/>
+              <a:rPr lang="en-US"/>
               <a:t>Fourth level</a:t>
             </a:r>
           </a:p>
           <a:p>
             <a:pPr lvl="4"/>
             <a:r>
-              <a:rPr lang="en-US" smtClean="0"/>
+              <a:rPr lang="en-US"/>
               <a:t>Fifth level</a:t>
             </a:r>
-            <a:endParaRPr lang="en-US"/>
           </a:p>
         </p:txBody>
       </p:sp>
@@ -2861,7 +2647,7 @@
           <a:p>
             <a:fld id="{5BCAD085-E8A6-8845-BD4E-CB4CCA059FC4}" type="datetimeFigureOut">
               <a:rPr lang="en-US" smtClean="0"/>
-              <a:t>1/27/13</a:t>
+              <a:t>9/13/2026</a:t>
             </a:fld>
             <a:endParaRPr lang="en-US"/>
           </a:p>
@@ -2964,10 +2750,9 @@
           </a:lstStyle>
           <a:p>
             <a:r>
-              <a:rPr lang="en-US" smtClean="0"/>
+              <a:rPr lang="en-US"/>
               <a:t>Click to edit Master title style</a:t>
             </a:r>
-            <a:endParaRPr lang="en-US"/>
           </a:p>
         </p:txBody>
       </p:sp>
@@ -3084,7 +2869,7 @@
           <a:p>
             <a:pPr lvl="0"/>
             <a:r>
-              <a:rPr lang="en-US" smtClean="0"/>
+              <a:rPr lang="en-US"/>
               <a:t>Click to edit Master text styles</a:t>
             </a:r>
           </a:p>
@@ -3107,7 +2892,7 @@
           <a:p>
             <a:fld id="{5BCAD085-E8A6-8845-BD4E-CB4CCA059FC4}" type="datetimeFigureOut">
               <a:rPr lang="en-US" smtClean="0"/>
-              <a:t>1/27/13</a:t>
+              <a:t>9/13/2026</a:t>
             </a:fld>
             <a:endParaRPr lang="en-US"/>
           </a:p>
@@ -3201,10 +2986,9 @@
           <a:lstStyle/>
           <a:p>
             <a:r>
-              <a:rPr lang="en-US" smtClean="0"/>
+              <a:rPr lang="en-US"/>
               <a:t>Click to edit Master title style</a:t>
             </a:r>
-            <a:endParaRPr lang="en-US"/>
           </a:p>
         </p:txBody>
       </p:sp>
@@ -3258,38 +3042,37 @@
           <a:p>
             <a:pPr lvl="0"/>
             <a:r>
-              <a:rPr lang="en-US" smtClean="0"/>
+              <a:rPr lang="en-US"/>
               <a:t>Click to edit Master text styles</a:t>
             </a:r>
           </a:p>
           <a:p>
             <a:pPr lvl="1"/>
             <a:r>
-              <a:rPr lang="en-US" smtClean="0"/>
+              <a:rPr lang="en-US"/>
               <a:t>Second level</a:t>
             </a:r>
           </a:p>
           <a:p>
             <a:pPr lvl="2"/>
             <a:r>
-              <a:rPr lang="en-US" smtClean="0"/>
+              <a:rPr lang="en-US"/>
               <a:t>Third level</a:t>
             </a:r>
           </a:p>
           <a:p>
             <a:pPr lvl="3"/>
             <a:r>
-              <a:rPr lang="en-US" smtClean="0"/>
+              <a:rPr lang="en-US"/>
               <a:t>Fourth level</a:t>
             </a:r>
           </a:p>
           <a:p>
             <a:pPr lvl="4"/>
             <a:r>
-              <a:rPr lang="en-US" smtClean="0"/>
+              <a:rPr lang="en-US"/>
               <a:t>Fifth level</a:t>
             </a:r>
-            <a:endParaRPr lang="en-US"/>
           </a:p>
         </p:txBody>
       </p:sp>
@@ -3343,38 +3126,37 @@
           <a:p>
             <a:pPr lvl="0"/>
             <a:r>
-              <a:rPr lang="en-US" smtClean="0"/>
+              <a:rPr lang="en-US"/>
               <a:t>Click to edit Master text styles</a:t>
             </a:r>
           </a:p>
           <a:p>
             <a:pPr lvl="1"/>
             <a:r>
-              <a:rPr lang="en-US" smtClean="0"/>
+              <a:rPr lang="en-US"/>
               <a:t>Second level</a:t>
             </a:r>
           </a:p>
           <a:p>
             <a:pPr lvl="2"/>
             <a:r>
-              <a:rPr lang="en-US" smtClean="0"/>
+              <a:rPr lang="en-US"/>
               <a:t>Third level</a:t>
             </a:r>
           </a:p>
           <a:p>
             <a:pPr lvl="3"/>
             <a:r>
-              <a:rPr lang="en-US" smtClean="0"/>
+              <a:rPr lang="en-US"/>
               <a:t>Fourth level</a:t>
             </a:r>
           </a:p>
           <a:p>
             <a:pPr lvl="4"/>
             <a:r>
-              <a:rPr lang="en-US" smtClean="0"/>
+              <a:rPr lang="en-US"/>
               <a:t>Fifth level</a:t>
             </a:r>
-            <a:endParaRPr lang="en-US"/>
           </a:p>
         </p:txBody>
       </p:sp>
@@ -3395,7 +3177,7 @@
           <a:p>
             <a:fld id="{5BCAD085-E8A6-8845-BD4E-CB4CCA059FC4}" type="datetimeFigureOut">
               <a:rPr lang="en-US" smtClean="0"/>
-              <a:t>1/27/13</a:t>
+              <a:t>9/13/2026</a:t>
             </a:fld>
             <a:endParaRPr lang="en-US"/>
           </a:p>
@@ -3493,10 +3275,9 @@
           </a:lstStyle>
           <a:p>
             <a:r>
-              <a:rPr lang="en-US" smtClean="0"/>
+              <a:rPr lang="en-US"/>
               <a:t>Click to edit Master title style</a:t>
             </a:r>
-            <a:endParaRPr lang="en-US"/>
           </a:p>
         </p:txBody>
       </p:sp>
@@ -3559,7 +3340,7 @@
           <a:p>
             <a:pPr lvl="0"/>
             <a:r>
-              <a:rPr lang="en-US" smtClean="0"/>
+              <a:rPr lang="en-US"/>
               <a:t>Click to edit Master text styles</a:t>
             </a:r>
           </a:p>
@@ -3615,38 +3396,37 @@
           <a:p>
             <a:pPr lvl="0"/>
             <a:r>
-              <a:rPr lang="en-US" smtClean="0"/>
+              <a:rPr lang="en-US"/>
               <a:t>Click to edit Master text styles</a:t>
             </a:r>
           </a:p>
           <a:p>
             <a:pPr lvl="1"/>
             <a:r>
-              <a:rPr lang="en-US" smtClean="0"/>
+              <a:rPr lang="en-US"/>
               <a:t>Second level</a:t>
             </a:r>
           </a:p>
           <a:p>
             <a:pPr lvl="2"/>
             <a:r>
-              <a:rPr lang="en-US" smtClean="0"/>
+              <a:rPr lang="en-US"/>
               <a:t>Third level</a:t>
             </a:r>
           </a:p>
           <a:p>
             <a:pPr lvl="3"/>
             <a:r>
-              <a:rPr lang="en-US" smtClean="0"/>
+              <a:rPr lang="en-US"/>
               <a:t>Fourth level</a:t>
             </a:r>
           </a:p>
           <a:p>
             <a:pPr lvl="4"/>
             <a:r>
-              <a:rPr lang="en-US" smtClean="0"/>
+              <a:rPr lang="en-US"/>
               <a:t>Fifth level</a:t>
             </a:r>
-            <a:endParaRPr lang="en-US"/>
           </a:p>
         </p:txBody>
       </p:sp>
@@ -3709,7 +3489,7 @@
           <a:p>
             <a:pPr lvl="0"/>
             <a:r>
-              <a:rPr lang="en-US" smtClean="0"/>
+              <a:rPr lang="en-US"/>
               <a:t>Click to edit Master text styles</a:t>
             </a:r>
           </a:p>
@@ -3765,38 +3545,37 @@
           <a:p>
             <a:pPr lvl="0"/>
             <a:r>
-              <a:rPr lang="en-US" smtClean="0"/>
+              <a:rPr lang="en-US"/>
               <a:t>Click to edit Master text styles</a:t>
             </a:r>
           </a:p>
           <a:p>
             <a:pPr lvl="1"/>
             <a:r>
-              <a:rPr lang="en-US" smtClean="0"/>
+              <a:rPr lang="en-US"/>
               <a:t>Second level</a:t>
             </a:r>
           </a:p>
           <a:p>
             <a:pPr lvl="2"/>
             <a:r>
-              <a:rPr lang="en-US" smtClean="0"/>
+              <a:rPr lang="en-US"/>
               <a:t>Third level</a:t>
             </a:r>
           </a:p>
           <a:p>
             <a:pPr lvl="3"/>
             <a:r>
-              <a:rPr lang="en-US" smtClean="0"/>
+              <a:rPr lang="en-US"/>
               <a:t>Fourth level</a:t>
             </a:r>
           </a:p>
           <a:p>
             <a:pPr lvl="4"/>
             <a:r>
-              <a:rPr lang="en-US" smtClean="0"/>
+              <a:rPr lang="en-US"/>
               <a:t>Fifth level</a:t>
             </a:r>
-            <a:endParaRPr lang="en-US"/>
           </a:p>
         </p:txBody>
       </p:sp>
@@ -3817,7 +3596,7 @@
           <a:p>
             <a:fld id="{5BCAD085-E8A6-8845-BD4E-CB4CCA059FC4}" type="datetimeFigureOut">
               <a:rPr lang="en-US" smtClean="0"/>
-              <a:t>1/27/13</a:t>
+              <a:t>9/13/2026</a:t>
             </a:fld>
             <a:endParaRPr lang="en-US"/>
           </a:p>
@@ -3911,10 +3690,9 @@
           <a:lstStyle/>
           <a:p>
             <a:r>
-              <a:rPr lang="en-US" smtClean="0"/>
+              <a:rPr lang="en-US"/>
               <a:t>Click to edit Master title style</a:t>
             </a:r>
-            <a:endParaRPr lang="en-US"/>
           </a:p>
         </p:txBody>
       </p:sp>
@@ -3935,7 +3713,7 @@
           <a:p>
             <a:fld id="{5BCAD085-E8A6-8845-BD4E-CB4CCA059FC4}" type="datetimeFigureOut">
               <a:rPr lang="en-US" smtClean="0"/>
-              <a:t>1/27/13</a:t>
+              <a:t>9/13/2026</a:t>
             </a:fld>
             <a:endParaRPr lang="en-US"/>
           </a:p>
@@ -4030,7 +3808,7 @@
           <a:p>
             <a:fld id="{5BCAD085-E8A6-8845-BD4E-CB4CCA059FC4}" type="datetimeFigureOut">
               <a:rPr lang="en-US" smtClean="0"/>
-              <a:t>1/27/13</a:t>
+              <a:t>9/13/2026</a:t>
             </a:fld>
             <a:endParaRPr lang="en-US"/>
           </a:p>
@@ -4133,10 +3911,9 @@
           </a:lstStyle>
           <a:p>
             <a:r>
-              <a:rPr lang="en-US" smtClean="0"/>
+              <a:rPr lang="en-US"/>
               <a:t>Click to edit Master title style</a:t>
             </a:r>
-            <a:endParaRPr lang="en-US"/>
           </a:p>
         </p:txBody>
       </p:sp>
@@ -4190,38 +3967,37 @@
           <a:p>
             <a:pPr lvl="0"/>
             <a:r>
-              <a:rPr lang="en-US" smtClean="0"/>
+              <a:rPr lang="en-US"/>
               <a:t>Click to edit Master text styles</a:t>
             </a:r>
           </a:p>
           <a:p>
             <a:pPr lvl="1"/>
             <a:r>
-              <a:rPr lang="en-US" smtClean="0"/>
+              <a:rPr lang="en-US"/>
               <a:t>Second level</a:t>
             </a:r>
           </a:p>
           <a:p>
             <a:pPr lvl="2"/>
             <a:r>
-              <a:rPr lang="en-US" smtClean="0"/>
+              <a:rPr lang="en-US"/>
               <a:t>Third level</a:t>
             </a:r>
           </a:p>
           <a:p>
             <a:pPr lvl="3"/>
             <a:r>
-              <a:rPr lang="en-US" smtClean="0"/>
+              <a:rPr lang="en-US"/>
               <a:t>Fourth level</a:t>
             </a:r>
           </a:p>
           <a:p>
             <a:pPr lvl="4"/>
             <a:r>
-              <a:rPr lang="en-US" smtClean="0"/>
+              <a:rPr lang="en-US"/>
               <a:t>Fifth level</a:t>
             </a:r>
-            <a:endParaRPr lang="en-US"/>
           </a:p>
         </p:txBody>
       </p:sp>
@@ -4284,7 +4060,7 @@
           <a:p>
             <a:pPr lvl="0"/>
             <a:r>
-              <a:rPr lang="en-US" smtClean="0"/>
+              <a:rPr lang="en-US"/>
               <a:t>Click to edit Master text styles</a:t>
             </a:r>
           </a:p>
@@ -4307,7 +4083,7 @@
           <a:p>
             <a:fld id="{5BCAD085-E8A6-8845-BD4E-CB4CCA059FC4}" type="datetimeFigureOut">
               <a:rPr lang="en-US" smtClean="0"/>
-              <a:t>1/27/13</a:t>
+              <a:t>9/13/2026</a:t>
             </a:fld>
             <a:endParaRPr lang="en-US"/>
           </a:p>
@@ -4410,10 +4186,9 @@
           </a:lstStyle>
           <a:p>
             <a:r>
-              <a:rPr lang="en-US" smtClean="0"/>
+              <a:rPr lang="en-US"/>
               <a:t>Click to edit Master title style</a:t>
             </a:r>
-            <a:endParaRPr lang="en-US"/>
           </a:p>
         </p:txBody>
       </p:sp>
@@ -4537,7 +4312,7 @@
           <a:p>
             <a:pPr lvl="0"/>
             <a:r>
-              <a:rPr lang="en-US" smtClean="0"/>
+              <a:rPr lang="en-US"/>
               <a:t>Click to edit Master text styles</a:t>
             </a:r>
           </a:p>
@@ -4560,7 +4335,7 @@
           <a:p>
             <a:fld id="{5BCAD085-E8A6-8845-BD4E-CB4CCA059FC4}" type="datetimeFigureOut">
               <a:rPr lang="en-US" smtClean="0"/>
-              <a:t>1/27/13</a:t>
+              <a:t>9/13/2026</a:t>
             </a:fld>
             <a:endParaRPr lang="en-US"/>
           </a:p>
@@ -4669,10 +4444,9 @@
           <a:lstStyle/>
           <a:p>
             <a:r>
-              <a:rPr lang="en-US" smtClean="0"/>
+              <a:rPr lang="en-US"/>
               <a:t>Click to edit Master title style</a:t>
             </a:r>
-            <a:endParaRPr lang="en-US"/>
           </a:p>
         </p:txBody>
       </p:sp>
@@ -4703,38 +4477,37 @@
           <a:p>
             <a:pPr lvl="0"/>
             <a:r>
-              <a:rPr lang="en-US" smtClean="0"/>
+              <a:rPr lang="en-US"/>
               <a:t>Click to edit Master text styles</a:t>
             </a:r>
           </a:p>
           <a:p>
             <a:pPr lvl="1"/>
             <a:r>
-              <a:rPr lang="en-US" smtClean="0"/>
+              <a:rPr lang="en-US"/>
               <a:t>Second level</a:t>
             </a:r>
           </a:p>
           <a:p>
             <a:pPr lvl="2"/>
             <a:r>
-              <a:rPr lang="en-US" smtClean="0"/>
+              <a:rPr lang="en-US"/>
               <a:t>Third level</a:t>
             </a:r>
           </a:p>
           <a:p>
             <a:pPr lvl="3"/>
             <a:r>
-              <a:rPr lang="en-US" smtClean="0"/>
+              <a:rPr lang="en-US"/>
               <a:t>Fourth level</a:t>
             </a:r>
           </a:p>
           <a:p>
             <a:pPr lvl="4"/>
             <a:r>
-              <a:rPr lang="en-US" smtClean="0"/>
+              <a:rPr lang="en-US"/>
               <a:t>Fifth level</a:t>
             </a:r>
-            <a:endParaRPr lang="en-US"/>
           </a:p>
         </p:txBody>
       </p:sp>
@@ -4773,7 +4546,7 @@
           <a:p>
             <a:fld id="{5BCAD085-E8A6-8845-BD4E-CB4CCA059FC4}" type="datetimeFigureOut">
               <a:rPr lang="en-US" smtClean="0"/>
-              <a:t>1/27/13</a:t>
+              <a:t>9/13/2026</a:t>
             </a:fld>
             <a:endParaRPr lang="en-US"/>
           </a:p>
@@ -5132,7 +4905,7 @@
 </file>
 
 <file path=ppt/slides/slide1.xml><?xml version="1.0" encoding="utf-8"?>
-<p:sld xmlns:a="http://schemas.openxmlformats.org/drawingml/2006/main" xmlns:p="http://schemas.openxmlformats.org/presentationml/2006/main" xmlns:r="http://schemas.openxmlformats.org/officeDocument/2006/relationships">
+<p:sld xmlns:a="http://schemas.openxmlformats.org/drawingml/2006/main" xmlns:r="http://schemas.openxmlformats.org/officeDocument/2006/relationships" xmlns:p="http://schemas.openxmlformats.org/presentationml/2006/main">
   <p:cSld>
     <p:spTree>
       <p:nvGrpSpPr>
@@ -5140,7 +4913,14 @@
         <p:cNvGrpSpPr/>
         <p:nvPr/>
       </p:nvGrpSpPr>
-      <p:grpSpPr/>
+      <p:grpSpPr>
+        <a:xfrm>
+          <a:off x="0" y="0"/>
+          <a:ext cx="0" cy="0"/>
+          <a:chOff x="0" y="0"/>
+          <a:chExt cx="0" cy="0"/>
+        </a:xfrm>
+      </p:grpSpPr>
       <p:sp>
         <p:nvSpPr>
           <p:cNvPr id="2" name="Rectangle 1"/>
@@ -5182,6 +4962,7 @@
           <a:lstStyle/>
           <a:p>
             <a:pPr algn="ctr"/>
+            <a:endParaRPr/>
           </a:p>
         </p:txBody>
       </p:sp>
@@ -5297,6 +5078,7 @@
           <a:lstStyle/>
           <a:p>
             <a:pPr algn="ctr"/>
+            <a:endParaRPr/>
           </a:p>
         </p:txBody>
       </p:sp>
@@ -5380,7 +5162,7 @@
 </file>
 
 <file path=ppt/slides/slide10.xml><?xml version="1.0" encoding="utf-8"?>
-<p:sld xmlns:a="http://schemas.openxmlformats.org/drawingml/2006/main" xmlns:p="http://schemas.openxmlformats.org/presentationml/2006/main" xmlns:r="http://schemas.openxmlformats.org/officeDocument/2006/relationships">
+<p:sld xmlns:a="http://schemas.openxmlformats.org/drawingml/2006/main" xmlns:r="http://schemas.openxmlformats.org/officeDocument/2006/relationships" xmlns:p="http://schemas.openxmlformats.org/presentationml/2006/main">
   <p:cSld>
     <p:spTree>
       <p:nvGrpSpPr>
@@ -5388,7 +5170,14 @@
         <p:cNvGrpSpPr/>
         <p:nvPr/>
       </p:nvGrpSpPr>
-      <p:grpSpPr/>
+      <p:grpSpPr>
+        <a:xfrm>
+          <a:off x="0" y="0"/>
+          <a:ext cx="0" cy="0"/>
+          <a:chOff x="0" y="0"/>
+          <a:chExt cx="0" cy="0"/>
+        </a:xfrm>
+      </p:grpSpPr>
       <p:sp>
         <p:nvSpPr>
           <p:cNvPr id="2" name="Rectangle 1"/>
@@ -5430,6 +5219,7 @@
           <a:lstStyle/>
           <a:p>
             <a:pPr algn="ctr"/>
+            <a:endParaRPr/>
           </a:p>
         </p:txBody>
       </p:sp>
@@ -5529,6 +5319,7 @@
           <a:lstStyle/>
           <a:p>
             <a:pPr algn="ctr"/>
+            <a:endParaRPr/>
           </a:p>
         </p:txBody>
       </p:sp>
@@ -5541,7 +5332,7 @@
           <p:nvPr/>
         </p:nvPicPr>
         <p:blipFill>
-          <a:blip r:embed="rId2"/>
+          <a:blip r:embed="rId3"/>
           <a:stretch>
             <a:fillRect/>
           </a:stretch>
@@ -5565,7 +5356,7 @@
 </file>
 
 <file path=ppt/slides/slide11.xml><?xml version="1.0" encoding="utf-8"?>
-<p:sld xmlns:a="http://schemas.openxmlformats.org/drawingml/2006/main" xmlns:p="http://schemas.openxmlformats.org/presentationml/2006/main" xmlns:r="http://schemas.openxmlformats.org/officeDocument/2006/relationships">
+<p:sld xmlns:a="http://schemas.openxmlformats.org/drawingml/2006/main" xmlns:r="http://schemas.openxmlformats.org/officeDocument/2006/relationships" xmlns:p="http://schemas.openxmlformats.org/presentationml/2006/main">
   <p:cSld>
     <p:spTree>
       <p:nvGrpSpPr>
@@ -5573,7 +5364,14 @@
         <p:cNvGrpSpPr/>
         <p:nvPr/>
       </p:nvGrpSpPr>
-      <p:grpSpPr/>
+      <p:grpSpPr>
+        <a:xfrm>
+          <a:off x="0" y="0"/>
+          <a:ext cx="0" cy="0"/>
+          <a:chOff x="0" y="0"/>
+          <a:chExt cx="0" cy="0"/>
+        </a:xfrm>
+      </p:grpSpPr>
       <p:sp>
         <p:nvSpPr>
           <p:cNvPr id="2" name="Rectangle 1"/>
@@ -5615,6 +5413,7 @@
           <a:lstStyle/>
           <a:p>
             <a:pPr algn="ctr"/>
+            <a:endParaRPr/>
           </a:p>
         </p:txBody>
       </p:sp>
@@ -5714,6 +5513,7 @@
           <a:lstStyle/>
           <a:p>
             <a:pPr algn="ctr"/>
+            <a:endParaRPr/>
           </a:p>
         </p:txBody>
       </p:sp>
@@ -5726,7 +5526,7 @@
           <p:nvPr/>
         </p:nvPicPr>
         <p:blipFill>
-          <a:blip r:embed="rId2"/>
+          <a:blip r:embed="rId3"/>
           <a:stretch>
             <a:fillRect/>
           </a:stretch>
@@ -5750,7 +5550,7 @@
 </file>
 
 <file path=ppt/slides/slide12.xml><?xml version="1.0" encoding="utf-8"?>
-<p:sld xmlns:a="http://schemas.openxmlformats.org/drawingml/2006/main" xmlns:p="http://schemas.openxmlformats.org/presentationml/2006/main" xmlns:r="http://schemas.openxmlformats.org/officeDocument/2006/relationships">
+<p:sld xmlns:a="http://schemas.openxmlformats.org/drawingml/2006/main" xmlns:r="http://schemas.openxmlformats.org/officeDocument/2006/relationships" xmlns:p="http://schemas.openxmlformats.org/presentationml/2006/main">
   <p:cSld>
     <p:spTree>
       <p:nvGrpSpPr>
@@ -5758,7 +5558,14 @@
         <p:cNvGrpSpPr/>
         <p:nvPr/>
       </p:nvGrpSpPr>
-      <p:grpSpPr/>
+      <p:grpSpPr>
+        <a:xfrm>
+          <a:off x="0" y="0"/>
+          <a:ext cx="0" cy="0"/>
+          <a:chOff x="0" y="0"/>
+          <a:chExt cx="0" cy="0"/>
+        </a:xfrm>
+      </p:grpSpPr>
       <p:sp>
         <p:nvSpPr>
           <p:cNvPr id="2" name="Rectangle 1"/>
@@ -5800,6 +5607,7 @@
           <a:lstStyle/>
           <a:p>
             <a:pPr algn="ctr"/>
+            <a:endParaRPr/>
           </a:p>
         </p:txBody>
       </p:sp>
@@ -5899,6 +5707,7 @@
           <a:lstStyle/>
           <a:p>
             <a:pPr algn="ctr"/>
+            <a:endParaRPr/>
           </a:p>
         </p:txBody>
       </p:sp>
@@ -5911,7 +5720,7 @@
           <p:nvPr/>
         </p:nvPicPr>
         <p:blipFill>
-          <a:blip r:embed="rId2"/>
+          <a:blip r:embed="rId3"/>
           <a:stretch>
             <a:fillRect/>
           </a:stretch>
@@ -5935,7 +5744,7 @@
 </file>
 
 <file path=ppt/slides/slide13.xml><?xml version="1.0" encoding="utf-8"?>
-<p:sld xmlns:a="http://schemas.openxmlformats.org/drawingml/2006/main" xmlns:p="http://schemas.openxmlformats.org/presentationml/2006/main" xmlns:r="http://schemas.openxmlformats.org/officeDocument/2006/relationships">
+<p:sld xmlns:a="http://schemas.openxmlformats.org/drawingml/2006/main" xmlns:r="http://schemas.openxmlformats.org/officeDocument/2006/relationships" xmlns:p="http://schemas.openxmlformats.org/presentationml/2006/main">
   <p:cSld>
     <p:spTree>
       <p:nvGrpSpPr>
@@ -5943,7 +5752,14 @@
         <p:cNvGrpSpPr/>
         <p:nvPr/>
       </p:nvGrpSpPr>
-      <p:grpSpPr/>
+      <p:grpSpPr>
+        <a:xfrm>
+          <a:off x="0" y="0"/>
+          <a:ext cx="0" cy="0"/>
+          <a:chOff x="0" y="0"/>
+          <a:chExt cx="0" cy="0"/>
+        </a:xfrm>
+      </p:grpSpPr>
       <p:sp>
         <p:nvSpPr>
           <p:cNvPr id="2" name="Rectangle 1"/>
@@ -5985,6 +5801,7 @@
           <a:lstStyle/>
           <a:p>
             <a:pPr algn="ctr"/>
+            <a:endParaRPr/>
           </a:p>
         </p:txBody>
       </p:sp>
@@ -6084,6 +5901,7 @@
           <a:lstStyle/>
           <a:p>
             <a:pPr algn="ctr"/>
+            <a:endParaRPr/>
           </a:p>
         </p:txBody>
       </p:sp>
@@ -6096,7 +5914,7 @@
           <p:nvPr/>
         </p:nvPicPr>
         <p:blipFill>
-          <a:blip r:embed="rId2"/>
+          <a:blip r:embed="rId3"/>
           <a:stretch>
             <a:fillRect/>
           </a:stretch>
@@ -6120,7 +5938,7 @@
 </file>
 
 <file path=ppt/slides/slide14.xml><?xml version="1.0" encoding="utf-8"?>
-<p:sld xmlns:a="http://schemas.openxmlformats.org/drawingml/2006/main" xmlns:p="http://schemas.openxmlformats.org/presentationml/2006/main" xmlns:r="http://schemas.openxmlformats.org/officeDocument/2006/relationships">
+<p:sld xmlns:a="http://schemas.openxmlformats.org/drawingml/2006/main" xmlns:r="http://schemas.openxmlformats.org/officeDocument/2006/relationships" xmlns:p="http://schemas.openxmlformats.org/presentationml/2006/main">
   <p:cSld>
     <p:spTree>
       <p:nvGrpSpPr>
@@ -6128,7 +5946,14 @@
         <p:cNvGrpSpPr/>
         <p:nvPr/>
       </p:nvGrpSpPr>
-      <p:grpSpPr/>
+      <p:grpSpPr>
+        <a:xfrm>
+          <a:off x="0" y="0"/>
+          <a:ext cx="0" cy="0"/>
+          <a:chOff x="0" y="0"/>
+          <a:chExt cx="0" cy="0"/>
+        </a:xfrm>
+      </p:grpSpPr>
       <p:sp>
         <p:nvSpPr>
           <p:cNvPr id="2" name="Rectangle 1"/>
@@ -6170,6 +5995,7 @@
           <a:lstStyle/>
           <a:p>
             <a:pPr algn="ctr"/>
+            <a:endParaRPr/>
           </a:p>
         </p:txBody>
       </p:sp>
@@ -6269,6 +6095,7 @@
           <a:lstStyle/>
           <a:p>
             <a:pPr algn="ctr"/>
+            <a:endParaRPr/>
           </a:p>
         </p:txBody>
       </p:sp>
@@ -6281,7 +6108,7 @@
           <p:nvPr/>
         </p:nvPicPr>
         <p:blipFill>
-          <a:blip r:embed="rId2"/>
+          <a:blip r:embed="rId3"/>
           <a:stretch>
             <a:fillRect/>
           </a:stretch>
@@ -6305,7 +6132,7 @@
 </file>
 
 <file path=ppt/slides/slide15.xml><?xml version="1.0" encoding="utf-8"?>
-<p:sld xmlns:a="http://schemas.openxmlformats.org/drawingml/2006/main" xmlns:p="http://schemas.openxmlformats.org/presentationml/2006/main" xmlns:r="http://schemas.openxmlformats.org/officeDocument/2006/relationships">
+<p:sld xmlns:a="http://schemas.openxmlformats.org/drawingml/2006/main" xmlns:r="http://schemas.openxmlformats.org/officeDocument/2006/relationships" xmlns:p="http://schemas.openxmlformats.org/presentationml/2006/main">
   <p:cSld>
     <p:spTree>
       <p:nvGrpSpPr>
@@ -6313,7 +6140,14 @@
         <p:cNvGrpSpPr/>
         <p:nvPr/>
       </p:nvGrpSpPr>
-      <p:grpSpPr/>
+      <p:grpSpPr>
+        <a:xfrm>
+          <a:off x="0" y="0"/>
+          <a:ext cx="0" cy="0"/>
+          <a:chOff x="0" y="0"/>
+          <a:chExt cx="0" cy="0"/>
+        </a:xfrm>
+      </p:grpSpPr>
       <p:sp>
         <p:nvSpPr>
           <p:cNvPr id="2" name="Rectangle 1"/>
@@ -6355,6 +6189,7 @@
           <a:lstStyle/>
           <a:p>
             <a:pPr algn="ctr"/>
+            <a:endParaRPr/>
           </a:p>
         </p:txBody>
       </p:sp>
@@ -6454,6 +6289,7 @@
           <a:lstStyle/>
           <a:p>
             <a:pPr algn="ctr"/>
+            <a:endParaRPr/>
           </a:p>
         </p:txBody>
       </p:sp>
@@ -6466,7 +6302,7 @@
           <p:nvPr/>
         </p:nvPicPr>
         <p:blipFill>
-          <a:blip r:embed="rId2"/>
+          <a:blip r:embed="rId3"/>
           <a:stretch>
             <a:fillRect/>
           </a:stretch>
@@ -6490,7 +6326,7 @@
           <p:nvPr/>
         </p:nvPicPr>
         <p:blipFill>
-          <a:blip r:embed="rId3"/>
+          <a:blip r:embed="rId4"/>
           <a:stretch>
             <a:fillRect/>
           </a:stretch>
@@ -6548,6 +6384,7 @@
           <a:lstStyle/>
           <a:p>
             <a:pPr algn="ctr"/>
+            <a:endParaRPr/>
           </a:p>
         </p:txBody>
       </p:sp>
@@ -6649,6 +6486,7 @@
           <a:lstStyle/>
           <a:p>
             <a:pPr algn="ctr"/>
+            <a:endParaRPr/>
           </a:p>
         </p:txBody>
       </p:sp>
@@ -6750,6 +6588,7 @@
           <a:lstStyle/>
           <a:p>
             <a:pPr algn="ctr"/>
+            <a:endParaRPr/>
           </a:p>
         </p:txBody>
       </p:sp>
@@ -6851,6 +6690,7 @@
           <a:lstStyle/>
           <a:p>
             <a:pPr algn="ctr"/>
+            <a:endParaRPr/>
           </a:p>
         </p:txBody>
       </p:sp>
@@ -6918,7 +6758,7 @@
 </file>
 
 <file path=ppt/slides/slide16.xml><?xml version="1.0" encoding="utf-8"?>
-<p:sld xmlns:a="http://schemas.openxmlformats.org/drawingml/2006/main" xmlns:p="http://schemas.openxmlformats.org/presentationml/2006/main" xmlns:r="http://schemas.openxmlformats.org/officeDocument/2006/relationships">
+<p:sld xmlns:a="http://schemas.openxmlformats.org/drawingml/2006/main" xmlns:r="http://schemas.openxmlformats.org/officeDocument/2006/relationships" xmlns:p="http://schemas.openxmlformats.org/presentationml/2006/main">
   <p:cSld>
     <p:spTree>
       <p:nvGrpSpPr>
@@ -6926,7 +6766,14 @@
         <p:cNvGrpSpPr/>
         <p:nvPr/>
       </p:nvGrpSpPr>
-      <p:grpSpPr/>
+      <p:grpSpPr>
+        <a:xfrm>
+          <a:off x="0" y="0"/>
+          <a:ext cx="0" cy="0"/>
+          <a:chOff x="0" y="0"/>
+          <a:chExt cx="0" cy="0"/>
+        </a:xfrm>
+      </p:grpSpPr>
       <p:sp>
         <p:nvSpPr>
           <p:cNvPr id="2" name="Rectangle 1"/>
@@ -6968,6 +6815,7 @@
           <a:lstStyle/>
           <a:p>
             <a:pPr algn="ctr"/>
+            <a:endParaRPr/>
           </a:p>
         </p:txBody>
       </p:sp>
@@ -7067,6 +6915,7 @@
           <a:lstStyle/>
           <a:p>
             <a:pPr algn="ctr"/>
+            <a:endParaRPr/>
           </a:p>
         </p:txBody>
       </p:sp>
@@ -7079,7 +6928,7 @@
           <p:nvPr/>
         </p:nvPicPr>
         <p:blipFill>
-          <a:blip r:embed="rId2"/>
+          <a:blip r:embed="rId3"/>
           <a:stretch>
             <a:fillRect/>
           </a:stretch>
@@ -7103,7 +6952,7 @@
           <p:nvPr/>
         </p:nvPicPr>
         <p:blipFill>
-          <a:blip r:embed="rId3"/>
+          <a:blip r:embed="rId4"/>
           <a:stretch>
             <a:fillRect/>
           </a:stretch>
@@ -7161,6 +7010,7 @@
           <a:lstStyle/>
           <a:p>
             <a:pPr algn="ctr"/>
+            <a:endParaRPr/>
           </a:p>
         </p:txBody>
       </p:sp>
@@ -7228,7 +7078,7 @@
 </file>
 
 <file path=ppt/slides/slide17.xml><?xml version="1.0" encoding="utf-8"?>
-<p:sld xmlns:a="http://schemas.openxmlformats.org/drawingml/2006/main" xmlns:p="http://schemas.openxmlformats.org/presentationml/2006/main" xmlns:r="http://schemas.openxmlformats.org/officeDocument/2006/relationships">
+<p:sld xmlns:a="http://schemas.openxmlformats.org/drawingml/2006/main" xmlns:r="http://schemas.openxmlformats.org/officeDocument/2006/relationships" xmlns:p="http://schemas.openxmlformats.org/presentationml/2006/main">
   <p:cSld>
     <p:spTree>
       <p:nvGrpSpPr>
@@ -7236,7 +7086,14 @@
         <p:cNvGrpSpPr/>
         <p:nvPr/>
       </p:nvGrpSpPr>
-      <p:grpSpPr/>
+      <p:grpSpPr>
+        <a:xfrm>
+          <a:off x="0" y="0"/>
+          <a:ext cx="0" cy="0"/>
+          <a:chOff x="0" y="0"/>
+          <a:chExt cx="0" cy="0"/>
+        </a:xfrm>
+      </p:grpSpPr>
       <p:sp>
         <p:nvSpPr>
           <p:cNvPr id="2" name="Rectangle 1"/>
@@ -7278,6 +7135,7 @@
           <a:lstStyle/>
           <a:p>
             <a:pPr algn="ctr"/>
+            <a:endParaRPr/>
           </a:p>
         </p:txBody>
       </p:sp>
@@ -7377,6 +7235,7 @@
           <a:lstStyle/>
           <a:p>
             <a:pPr algn="ctr"/>
+            <a:endParaRPr/>
           </a:p>
         </p:txBody>
       </p:sp>
@@ -7389,7 +7248,7 @@
           <p:nvPr/>
         </p:nvPicPr>
         <p:blipFill>
-          <a:blip r:embed="rId2"/>
+          <a:blip r:embed="rId3"/>
           <a:stretch>
             <a:fillRect/>
           </a:stretch>
@@ -7447,6 +7306,7 @@
           <a:lstStyle/>
           <a:p>
             <a:pPr algn="ctr"/>
+            <a:endParaRPr/>
           </a:p>
         </p:txBody>
       </p:sp>
@@ -7548,6 +7408,7 @@
           <a:lstStyle/>
           <a:p>
             <a:pPr algn="ctr"/>
+            <a:endParaRPr/>
           </a:p>
         </p:txBody>
       </p:sp>
@@ -7649,6 +7510,7 @@
           <a:lstStyle/>
           <a:p>
             <a:pPr algn="ctr"/>
+            <a:endParaRPr/>
           </a:p>
         </p:txBody>
       </p:sp>
@@ -7755,7 +7617,7 @@
 </file>
 
 <file path=ppt/slides/slide18.xml><?xml version="1.0" encoding="utf-8"?>
-<p:sld xmlns:a="http://schemas.openxmlformats.org/drawingml/2006/main" xmlns:p="http://schemas.openxmlformats.org/presentationml/2006/main" xmlns:r="http://schemas.openxmlformats.org/officeDocument/2006/relationships">
+<p:sld xmlns:a="http://schemas.openxmlformats.org/drawingml/2006/main" xmlns:r="http://schemas.openxmlformats.org/officeDocument/2006/relationships" xmlns:p="http://schemas.openxmlformats.org/presentationml/2006/main">
   <p:cSld>
     <p:spTree>
       <p:nvGrpSpPr>
@@ -7763,7 +7625,14 @@
         <p:cNvGrpSpPr/>
         <p:nvPr/>
       </p:nvGrpSpPr>
-      <p:grpSpPr/>
+      <p:grpSpPr>
+        <a:xfrm>
+          <a:off x="0" y="0"/>
+          <a:ext cx="0" cy="0"/>
+          <a:chOff x="0" y="0"/>
+          <a:chExt cx="0" cy="0"/>
+        </a:xfrm>
+      </p:grpSpPr>
       <p:sp>
         <p:nvSpPr>
           <p:cNvPr id="2" name="Rectangle 1"/>
@@ -7805,6 +7674,7 @@
           <a:lstStyle/>
           <a:p>
             <a:pPr algn="ctr"/>
+            <a:endParaRPr/>
           </a:p>
         </p:txBody>
       </p:sp>
@@ -7904,6 +7774,7 @@
           <a:lstStyle/>
           <a:p>
             <a:pPr algn="ctr"/>
+            <a:endParaRPr/>
           </a:p>
         </p:txBody>
       </p:sp>
@@ -7916,7 +7787,7 @@
           <p:nvPr/>
         </p:nvPicPr>
         <p:blipFill>
-          <a:blip r:embed="rId2"/>
+          <a:blip r:embed="rId3"/>
           <a:stretch>
             <a:fillRect/>
           </a:stretch>
@@ -7940,7 +7811,7 @@
           <p:nvPr/>
         </p:nvPicPr>
         <p:blipFill>
-          <a:blip r:embed="rId3"/>
+          <a:blip r:embed="rId4"/>
           <a:stretch>
             <a:fillRect/>
           </a:stretch>
@@ -7974,10 +7845,34 @@
                 <a:tableStyleId>{5C22544A-7EE6-4342-B048-85BDC9FD1C3A}</a:tableStyleId>
               </a:tblPr>
               <a:tblGrid>
-                <a:gridCol w="1942185"/>
-                <a:gridCol w="1078992"/>
-                <a:gridCol w="1294790"/>
-                <a:gridCol w="1078992"/>
+                <a:gridCol w="1942185">
+                  <a:extLst>
+                    <a:ext uri="{9D8B030D-6E8A-4147-A177-3AD203B41FA5}">
+                      <a16:colId xmlns:a16="http://schemas.microsoft.com/office/drawing/2014/main" val="20000"/>
+                    </a:ext>
+                  </a:extLst>
+                </a:gridCol>
+                <a:gridCol w="1078992">
+                  <a:extLst>
+                    <a:ext uri="{9D8B030D-6E8A-4147-A177-3AD203B41FA5}">
+                      <a16:colId xmlns:a16="http://schemas.microsoft.com/office/drawing/2014/main" val="20001"/>
+                    </a:ext>
+                  </a:extLst>
+                </a:gridCol>
+                <a:gridCol w="1294790">
+                  <a:extLst>
+                    <a:ext uri="{9D8B030D-6E8A-4147-A177-3AD203B41FA5}">
+                      <a16:colId xmlns:a16="http://schemas.microsoft.com/office/drawing/2014/main" val="20002"/>
+                    </a:ext>
+                  </a:extLst>
+                </a:gridCol>
+                <a:gridCol w="1078992">
+                  <a:extLst>
+                    <a:ext uri="{9D8B030D-6E8A-4147-A177-3AD203B41FA5}">
+                      <a16:colId xmlns:a16="http://schemas.microsoft.com/office/drawing/2014/main" val="20003"/>
+                    </a:ext>
+                  </a:extLst>
+                </a:gridCol>
               </a:tblGrid>
               <a:tr h="274320">
                 <a:tc>
@@ -8072,6 +7967,11 @@
                     </a:solidFill>
                   </a:tcPr>
                 </a:tc>
+                <a:extLst>
+                  <a:ext uri="{0D108BD9-81ED-4DB2-BD59-A6C34878D82A}">
+                    <a16:rowId xmlns:a16="http://schemas.microsoft.com/office/drawing/2014/main" val="10000"/>
+                  </a:ext>
+                </a:extLst>
               </a:tr>
               <a:tr h="274320">
                 <a:tc>
@@ -8166,6 +8066,11 @@
                     </a:solidFill>
                   </a:tcPr>
                 </a:tc>
+                <a:extLst>
+                  <a:ext uri="{0D108BD9-81ED-4DB2-BD59-A6C34878D82A}">
+                    <a16:rowId xmlns:a16="http://schemas.microsoft.com/office/drawing/2014/main" val="10001"/>
+                  </a:ext>
+                </a:extLst>
               </a:tr>
               <a:tr h="274320">
                 <a:tc>
@@ -8260,6 +8165,11 @@
                     </a:solidFill>
                   </a:tcPr>
                 </a:tc>
+                <a:extLst>
+                  <a:ext uri="{0D108BD9-81ED-4DB2-BD59-A6C34878D82A}">
+                    <a16:rowId xmlns:a16="http://schemas.microsoft.com/office/drawing/2014/main" val="10002"/>
+                  </a:ext>
+                </a:extLst>
               </a:tr>
               <a:tr h="274320">
                 <a:tc>
@@ -8354,6 +8264,11 @@
                     </a:solidFill>
                   </a:tcPr>
                 </a:tc>
+                <a:extLst>
+                  <a:ext uri="{0D108BD9-81ED-4DB2-BD59-A6C34878D82A}">
+                    <a16:rowId xmlns:a16="http://schemas.microsoft.com/office/drawing/2014/main" val="10003"/>
+                  </a:ext>
+                </a:extLst>
               </a:tr>
             </a:tbl>
           </a:graphicData>
@@ -8402,6 +8317,7 @@
           <a:lstStyle/>
           <a:p>
             <a:pPr algn="ctr"/>
+            <a:endParaRPr/>
           </a:p>
         </p:txBody>
       </p:sp>
@@ -8503,6 +8419,7 @@
           <a:lstStyle/>
           <a:p>
             <a:pPr algn="ctr"/>
+            <a:endParaRPr/>
           </a:p>
         </p:txBody>
       </p:sp>
@@ -8625,7 +8542,7 @@
 </file>
 
 <file path=ppt/slides/slide19.xml><?xml version="1.0" encoding="utf-8"?>
-<p:sld xmlns:a="http://schemas.openxmlformats.org/drawingml/2006/main" xmlns:p="http://schemas.openxmlformats.org/presentationml/2006/main" xmlns:r="http://schemas.openxmlformats.org/officeDocument/2006/relationships">
+<p:sld xmlns:a="http://schemas.openxmlformats.org/drawingml/2006/main" xmlns:r="http://schemas.openxmlformats.org/officeDocument/2006/relationships" xmlns:p="http://schemas.openxmlformats.org/presentationml/2006/main">
   <p:cSld>
     <p:spTree>
       <p:nvGrpSpPr>
@@ -8633,7 +8550,14 @@
         <p:cNvGrpSpPr/>
         <p:nvPr/>
       </p:nvGrpSpPr>
-      <p:grpSpPr/>
+      <p:grpSpPr>
+        <a:xfrm>
+          <a:off x="0" y="0"/>
+          <a:ext cx="0" cy="0"/>
+          <a:chOff x="0" y="0"/>
+          <a:chExt cx="0" cy="0"/>
+        </a:xfrm>
+      </p:grpSpPr>
       <p:sp>
         <p:nvSpPr>
           <p:cNvPr id="2" name="Rectangle 1"/>
@@ -8675,6 +8599,7 @@
           <a:lstStyle/>
           <a:p>
             <a:pPr algn="ctr"/>
+            <a:endParaRPr/>
           </a:p>
         </p:txBody>
       </p:sp>
@@ -8774,6 +8699,7 @@
           <a:lstStyle/>
           <a:p>
             <a:pPr algn="ctr"/>
+            <a:endParaRPr/>
           </a:p>
         </p:txBody>
       </p:sp>
@@ -8786,7 +8712,7 @@
           <p:nvPr/>
         </p:nvPicPr>
         <p:blipFill>
-          <a:blip r:embed="rId2"/>
+          <a:blip r:embed="rId3"/>
           <a:stretch>
             <a:fillRect/>
           </a:stretch>
@@ -8844,6 +8770,7 @@
           <a:lstStyle/>
           <a:p>
             <a:pPr algn="ctr"/>
+            <a:endParaRPr/>
           </a:p>
         </p:txBody>
       </p:sp>
@@ -8911,7 +8838,7 @@
 </file>
 
 <file path=ppt/slides/slide2.xml><?xml version="1.0" encoding="utf-8"?>
-<p:sld xmlns:a="http://schemas.openxmlformats.org/drawingml/2006/main" xmlns:p="http://schemas.openxmlformats.org/presentationml/2006/main" xmlns:r="http://schemas.openxmlformats.org/officeDocument/2006/relationships">
+<p:sld xmlns:a="http://schemas.openxmlformats.org/drawingml/2006/main" xmlns:r="http://schemas.openxmlformats.org/officeDocument/2006/relationships" xmlns:p="http://schemas.openxmlformats.org/presentationml/2006/main">
   <p:cSld>
     <p:spTree>
       <p:nvGrpSpPr>
@@ -8919,7 +8846,14 @@
         <p:cNvGrpSpPr/>
         <p:nvPr/>
       </p:nvGrpSpPr>
-      <p:grpSpPr/>
+      <p:grpSpPr>
+        <a:xfrm>
+          <a:off x="0" y="0"/>
+          <a:ext cx="0" cy="0"/>
+          <a:chOff x="0" y="0"/>
+          <a:chExt cx="0" cy="0"/>
+        </a:xfrm>
+      </p:grpSpPr>
       <p:sp>
         <p:nvSpPr>
           <p:cNvPr id="2" name="Rectangle 1"/>
@@ -8961,6 +8895,7 @@
           <a:lstStyle/>
           <a:p>
             <a:pPr algn="ctr"/>
+            <a:endParaRPr/>
           </a:p>
         </p:txBody>
       </p:sp>
@@ -9060,6 +8995,7 @@
           <a:lstStyle/>
           <a:p>
             <a:pPr algn="ctr"/>
+            <a:endParaRPr/>
           </a:p>
         </p:txBody>
       </p:sp>
@@ -9106,6 +9042,7 @@
           <a:lstStyle/>
           <a:p>
             <a:pPr algn="ctr"/>
+            <a:endParaRPr/>
           </a:p>
         </p:txBody>
       </p:sp>
@@ -9207,6 +9144,7 @@
           <a:lstStyle/>
           <a:p>
             <a:pPr algn="ctr"/>
+            <a:endParaRPr/>
           </a:p>
         </p:txBody>
       </p:sp>
@@ -9308,6 +9246,7 @@
           <a:lstStyle/>
           <a:p>
             <a:pPr algn="ctr"/>
+            <a:endParaRPr/>
           </a:p>
         </p:txBody>
       </p:sp>
@@ -9409,6 +9348,7 @@
           <a:lstStyle/>
           <a:p>
             <a:pPr algn="ctr"/>
+            <a:endParaRPr/>
           </a:p>
         </p:txBody>
       </p:sp>
@@ -9510,6 +9450,7 @@
           <a:lstStyle/>
           <a:p>
             <a:pPr algn="ctr"/>
+            <a:endParaRPr/>
           </a:p>
         </p:txBody>
       </p:sp>
@@ -9611,6 +9552,7 @@
           <a:lstStyle/>
           <a:p>
             <a:pPr algn="ctr"/>
+            <a:endParaRPr/>
           </a:p>
         </p:txBody>
       </p:sp>
@@ -9712,6 +9654,7 @@
           <a:lstStyle/>
           <a:p>
             <a:pPr algn="ctr"/>
+            <a:endParaRPr/>
           </a:p>
         </p:txBody>
       </p:sp>
@@ -9813,6 +9756,7 @@
           <a:lstStyle/>
           <a:p>
             <a:pPr algn="ctr"/>
+            <a:endParaRPr/>
           </a:p>
         </p:txBody>
       </p:sp>
@@ -9919,7 +9863,7 @@
 </file>
 
 <file path=ppt/slides/slide20.xml><?xml version="1.0" encoding="utf-8"?>
-<p:sld xmlns:a="http://schemas.openxmlformats.org/drawingml/2006/main" xmlns:p="http://schemas.openxmlformats.org/presentationml/2006/main" xmlns:r="http://schemas.openxmlformats.org/officeDocument/2006/relationships">
+<p:sld xmlns:a="http://schemas.openxmlformats.org/drawingml/2006/main" xmlns:r="http://schemas.openxmlformats.org/officeDocument/2006/relationships" xmlns:p="http://schemas.openxmlformats.org/presentationml/2006/main">
   <p:cSld>
     <p:spTree>
       <p:nvGrpSpPr>
@@ -9927,7 +9871,14 @@
         <p:cNvGrpSpPr/>
         <p:nvPr/>
       </p:nvGrpSpPr>
-      <p:grpSpPr/>
+      <p:grpSpPr>
+        <a:xfrm>
+          <a:off x="0" y="0"/>
+          <a:ext cx="0" cy="0"/>
+          <a:chOff x="0" y="0"/>
+          <a:chExt cx="0" cy="0"/>
+        </a:xfrm>
+      </p:grpSpPr>
       <p:sp>
         <p:nvSpPr>
           <p:cNvPr id="2" name="Rectangle 1"/>
@@ -9969,6 +9920,7 @@
           <a:lstStyle/>
           <a:p>
             <a:pPr algn="ctr"/>
+            <a:endParaRPr/>
           </a:p>
         </p:txBody>
       </p:sp>
@@ -10068,6 +10020,7 @@
           <a:lstStyle/>
           <a:p>
             <a:pPr algn="ctr"/>
+            <a:endParaRPr/>
           </a:p>
         </p:txBody>
       </p:sp>
@@ -10080,7 +10033,7 @@
           <p:nvPr/>
         </p:nvPicPr>
         <p:blipFill>
-          <a:blip r:embed="rId2"/>
+          <a:blip r:embed="rId3"/>
           <a:stretch>
             <a:fillRect/>
           </a:stretch>
@@ -10104,7 +10057,7 @@
           <p:nvPr/>
         </p:nvPicPr>
         <p:blipFill>
-          <a:blip r:embed="rId3"/>
+          <a:blip r:embed="rId4"/>
           <a:stretch>
             <a:fillRect/>
           </a:stretch>
@@ -10162,6 +10115,7 @@
           <a:lstStyle/>
           <a:p>
             <a:pPr algn="ctr"/>
+            <a:endParaRPr/>
           </a:p>
         </p:txBody>
       </p:sp>
@@ -10295,6 +10249,7 @@
           <a:lstStyle/>
           <a:p>
             <a:pPr algn="ctr"/>
+            <a:endParaRPr/>
           </a:p>
         </p:txBody>
       </p:sp>
@@ -10394,7 +10349,7 @@
 </file>
 
 <file path=ppt/slides/slide21.xml><?xml version="1.0" encoding="utf-8"?>
-<p:sld xmlns:a="http://schemas.openxmlformats.org/drawingml/2006/main" xmlns:p="http://schemas.openxmlformats.org/presentationml/2006/main" xmlns:r="http://schemas.openxmlformats.org/officeDocument/2006/relationships">
+<p:sld xmlns:a="http://schemas.openxmlformats.org/drawingml/2006/main" xmlns:r="http://schemas.openxmlformats.org/officeDocument/2006/relationships" xmlns:p="http://schemas.openxmlformats.org/presentationml/2006/main">
   <p:cSld>
     <p:spTree>
       <p:nvGrpSpPr>
@@ -10402,7 +10357,14 @@
         <p:cNvGrpSpPr/>
         <p:nvPr/>
       </p:nvGrpSpPr>
-      <p:grpSpPr/>
+      <p:grpSpPr>
+        <a:xfrm>
+          <a:off x="0" y="0"/>
+          <a:ext cx="0" cy="0"/>
+          <a:chOff x="0" y="0"/>
+          <a:chExt cx="0" cy="0"/>
+        </a:xfrm>
+      </p:grpSpPr>
       <p:sp>
         <p:nvSpPr>
           <p:cNvPr id="2" name="Rectangle 1"/>
@@ -10444,6 +10406,7 @@
           <a:lstStyle/>
           <a:p>
             <a:pPr algn="ctr"/>
+            <a:endParaRPr/>
           </a:p>
         </p:txBody>
       </p:sp>
@@ -10543,6 +10506,7 @@
           <a:lstStyle/>
           <a:p>
             <a:pPr algn="ctr"/>
+            <a:endParaRPr/>
           </a:p>
         </p:txBody>
       </p:sp>
@@ -10555,7 +10519,7 @@
           <p:nvPr/>
         </p:nvPicPr>
         <p:blipFill>
-          <a:blip r:embed="rId2"/>
+          <a:blip r:embed="rId3"/>
           <a:stretch>
             <a:fillRect/>
           </a:stretch>
@@ -10579,7 +10543,7 @@
 </file>
 
 <file path=ppt/slides/slide22.xml><?xml version="1.0" encoding="utf-8"?>
-<p:sld xmlns:a="http://schemas.openxmlformats.org/drawingml/2006/main" xmlns:p="http://schemas.openxmlformats.org/presentationml/2006/main" xmlns:r="http://schemas.openxmlformats.org/officeDocument/2006/relationships">
+<p:sld xmlns:a="http://schemas.openxmlformats.org/drawingml/2006/main" xmlns:r="http://schemas.openxmlformats.org/officeDocument/2006/relationships" xmlns:p="http://schemas.openxmlformats.org/presentationml/2006/main">
   <p:cSld>
     <p:spTree>
       <p:nvGrpSpPr>
@@ -10587,7 +10551,14 @@
         <p:cNvGrpSpPr/>
         <p:nvPr/>
       </p:nvGrpSpPr>
-      <p:grpSpPr/>
+      <p:grpSpPr>
+        <a:xfrm>
+          <a:off x="0" y="0"/>
+          <a:ext cx="0" cy="0"/>
+          <a:chOff x="0" y="0"/>
+          <a:chExt cx="0" cy="0"/>
+        </a:xfrm>
+      </p:grpSpPr>
       <p:sp>
         <p:nvSpPr>
           <p:cNvPr id="2" name="Rectangle 1"/>
@@ -10629,6 +10600,7 @@
           <a:lstStyle/>
           <a:p>
             <a:pPr algn="ctr"/>
+            <a:endParaRPr/>
           </a:p>
         </p:txBody>
       </p:sp>
@@ -10728,6 +10700,7 @@
           <a:lstStyle/>
           <a:p>
             <a:pPr algn="ctr"/>
+            <a:endParaRPr/>
           </a:p>
         </p:txBody>
       </p:sp>
@@ -10740,7 +10713,7 @@
           <p:nvPr/>
         </p:nvPicPr>
         <p:blipFill>
-          <a:blip r:embed="rId2"/>
+          <a:blip r:embed="rId3"/>
           <a:stretch>
             <a:fillRect/>
           </a:stretch>
@@ -10764,7 +10737,7 @@
 </file>
 
 <file path=ppt/slides/slide23.xml><?xml version="1.0" encoding="utf-8"?>
-<p:sld xmlns:a="http://schemas.openxmlformats.org/drawingml/2006/main" xmlns:p="http://schemas.openxmlformats.org/presentationml/2006/main" xmlns:r="http://schemas.openxmlformats.org/officeDocument/2006/relationships">
+<p:sld xmlns:a="http://schemas.openxmlformats.org/drawingml/2006/main" xmlns:r="http://schemas.openxmlformats.org/officeDocument/2006/relationships" xmlns:p="http://schemas.openxmlformats.org/presentationml/2006/main">
   <p:cSld>
     <p:spTree>
       <p:nvGrpSpPr>
@@ -10772,7 +10745,14 @@
         <p:cNvGrpSpPr/>
         <p:nvPr/>
       </p:nvGrpSpPr>
-      <p:grpSpPr/>
+      <p:grpSpPr>
+        <a:xfrm>
+          <a:off x="0" y="0"/>
+          <a:ext cx="0" cy="0"/>
+          <a:chOff x="0" y="0"/>
+          <a:chExt cx="0" cy="0"/>
+        </a:xfrm>
+      </p:grpSpPr>
       <p:sp>
         <p:nvSpPr>
           <p:cNvPr id="2" name="Rectangle 1"/>
@@ -10814,6 +10794,7 @@
           <a:lstStyle/>
           <a:p>
             <a:pPr algn="ctr"/>
+            <a:endParaRPr/>
           </a:p>
         </p:txBody>
       </p:sp>
@@ -10913,6 +10894,7 @@
           <a:lstStyle/>
           <a:p>
             <a:pPr algn="ctr"/>
+            <a:endParaRPr/>
           </a:p>
         </p:txBody>
       </p:sp>
@@ -10959,6 +10941,7 @@
           <a:lstStyle/>
           <a:p>
             <a:pPr algn="ctr"/>
+            <a:endParaRPr/>
           </a:p>
         </p:txBody>
       </p:sp>
@@ -11124,6 +11107,7 @@
           <a:lstStyle/>
           <a:p>
             <a:pPr algn="ctr"/>
+            <a:endParaRPr/>
           </a:p>
         </p:txBody>
       </p:sp>
@@ -11300,7 +11284,7 @@
 </file>
 
 <file path=ppt/slides/slide24.xml><?xml version="1.0" encoding="utf-8"?>
-<p:sld xmlns:a="http://schemas.openxmlformats.org/drawingml/2006/main" xmlns:p="http://schemas.openxmlformats.org/presentationml/2006/main" xmlns:r="http://schemas.openxmlformats.org/officeDocument/2006/relationships">
+<p:sld xmlns:a="http://schemas.openxmlformats.org/drawingml/2006/main" xmlns:r="http://schemas.openxmlformats.org/officeDocument/2006/relationships" xmlns:p="http://schemas.openxmlformats.org/presentationml/2006/main">
   <p:cSld>
     <p:spTree>
       <p:nvGrpSpPr>
@@ -11308,7 +11292,14 @@
         <p:cNvGrpSpPr/>
         <p:nvPr/>
       </p:nvGrpSpPr>
-      <p:grpSpPr/>
+      <p:grpSpPr>
+        <a:xfrm>
+          <a:off x="0" y="0"/>
+          <a:ext cx="0" cy="0"/>
+          <a:chOff x="0" y="0"/>
+          <a:chExt cx="0" cy="0"/>
+        </a:xfrm>
+      </p:grpSpPr>
       <p:sp>
         <p:nvSpPr>
           <p:cNvPr id="2" name="Rectangle 1"/>
@@ -11350,6 +11341,7 @@
           <a:lstStyle/>
           <a:p>
             <a:pPr algn="ctr"/>
+            <a:endParaRPr/>
           </a:p>
         </p:txBody>
       </p:sp>
@@ -11433,6 +11425,7 @@
           <a:lstStyle/>
           <a:p>
             <a:pPr algn="ctr"/>
+            <a:endParaRPr/>
           </a:p>
         </p:txBody>
       </p:sp>
@@ -11479,6 +11472,7 @@
           <a:lstStyle/>
           <a:p>
             <a:pPr algn="ctr"/>
+            <a:endParaRPr/>
           </a:p>
         </p:txBody>
       </p:sp>
@@ -11564,6 +11558,7 @@
           <a:lstStyle/>
           <a:p>
             <a:pPr algn="ctr"/>
+            <a:endParaRPr/>
           </a:p>
         </p:txBody>
       </p:sp>
@@ -11649,6 +11644,7 @@
           <a:lstStyle/>
           <a:p>
             <a:pPr algn="ctr"/>
+            <a:endParaRPr/>
           </a:p>
         </p:txBody>
       </p:sp>
@@ -11687,61 +11683,6 @@
                 <a:latin typeface="Segoe UI"/>
               </a:rPr>
               <a:t>A random forest places future growth best: +14.89 km² by 2025 and +31.21 km² by 2030 - predictions, not observations.</a:t>
-            </a:r>
-          </a:p>
-        </p:txBody>
-      </p:sp>
-      <p:sp>
-        <p:nvSpPr>
-          <p:cNvPr id="11" name="TextBox 10"/>
-          <p:cNvSpPr txBox="1"/>
-          <p:nvPr/>
-        </p:nvSpPr>
-        <p:spPr>
-          <a:xfrm>
-            <a:off x="640080" y="5486400"/>
-            <a:ext cx="10881360" cy="822960"/>
-          </a:xfrm>
-          <a:prstGeom prst="rect">
-            <a:avLst/>
-          </a:prstGeom>
-          <a:noFill/>
-        </p:spPr>
-        <p:txBody>
-          <a:bodyPr wrap="square">
-            <a:spAutoFit/>
-          </a:bodyPr>
-          <a:lstStyle/>
-          <a:p>
-            <a:pPr algn="l">
-              <a:spcAft>
-                <a:spcPts val="400"/>
-              </a:spcAft>
-            </a:pPr>
-            <a:r>
-              <a:rPr sz="1600" b="1">
-                <a:solidFill>
-                  <a:srgbClr val="101826"/>
-                </a:solidFill>
-                <a:latin typeface="Segoe UI"/>
-              </a:rPr>
-              <a:t>Thank you. Questions are welcome.</a:t>
-            </a:r>
-          </a:p>
-          <a:p>
-            <a:pPr>
-              <a:spcAft>
-                <a:spcPts val="0"/>
-              </a:spcAft>
-            </a:pPr>
-            <a:r>
-              <a:rPr sz="1050" b="0">
-                <a:solidFill>
-                  <a:srgbClr val="5A6474"/>
-                </a:solidFill>
-                <a:latin typeface="Segoe UI"/>
-              </a:rPr>
-              <a:t>AI assistance (Claude, by Anthropic) was used in this project and is acknowledged as the project guidelines require; the team checked and presents every part.</a:t>
             </a:r>
           </a:p>
         </p:txBody>
@@ -11755,7 +11696,7 @@
 </file>
 
 <file path=ppt/slides/slide3.xml><?xml version="1.0" encoding="utf-8"?>
-<p:sld xmlns:a="http://schemas.openxmlformats.org/drawingml/2006/main" xmlns:p="http://schemas.openxmlformats.org/presentationml/2006/main" xmlns:r="http://schemas.openxmlformats.org/officeDocument/2006/relationships">
+<p:sld xmlns:a="http://schemas.openxmlformats.org/drawingml/2006/main" xmlns:r="http://schemas.openxmlformats.org/officeDocument/2006/relationships" xmlns:p="http://schemas.openxmlformats.org/presentationml/2006/main">
   <p:cSld>
     <p:spTree>
       <p:nvGrpSpPr>
@@ -11763,7 +11704,14 @@
         <p:cNvGrpSpPr/>
         <p:nvPr/>
       </p:nvGrpSpPr>
-      <p:grpSpPr/>
+      <p:grpSpPr>
+        <a:xfrm>
+          <a:off x="0" y="0"/>
+          <a:ext cx="0" cy="0"/>
+          <a:chOff x="0" y="0"/>
+          <a:chExt cx="0" cy="0"/>
+        </a:xfrm>
+      </p:grpSpPr>
       <p:sp>
         <p:nvSpPr>
           <p:cNvPr id="2" name="Rectangle 1"/>
@@ -11805,6 +11753,7 @@
           <a:lstStyle/>
           <a:p>
             <a:pPr algn="ctr"/>
+            <a:endParaRPr/>
           </a:p>
         </p:txBody>
       </p:sp>
@@ -11904,6 +11853,7 @@
           <a:lstStyle/>
           <a:p>
             <a:pPr algn="ctr"/>
+            <a:endParaRPr/>
           </a:p>
         </p:txBody>
       </p:sp>
@@ -11950,6 +11900,7 @@
           <a:lstStyle/>
           <a:p>
             <a:pPr algn="ctr"/>
+            <a:endParaRPr/>
           </a:p>
         </p:txBody>
       </p:sp>
@@ -12051,6 +12002,7 @@
           <a:lstStyle/>
           <a:p>
             <a:pPr algn="ctr"/>
+            <a:endParaRPr/>
           </a:p>
         </p:txBody>
       </p:sp>
@@ -12152,6 +12104,7 @@
           <a:lstStyle/>
           <a:p>
             <a:pPr algn="ctr"/>
+            <a:endParaRPr/>
           </a:p>
         </p:txBody>
       </p:sp>
@@ -12219,7 +12172,7 @@
 </file>
 
 <file path=ppt/slides/slide4.xml><?xml version="1.0" encoding="utf-8"?>
-<p:sld xmlns:a="http://schemas.openxmlformats.org/drawingml/2006/main" xmlns:p="http://schemas.openxmlformats.org/presentationml/2006/main" xmlns:r="http://schemas.openxmlformats.org/officeDocument/2006/relationships">
+<p:sld xmlns:a="http://schemas.openxmlformats.org/drawingml/2006/main" xmlns:r="http://schemas.openxmlformats.org/officeDocument/2006/relationships" xmlns:p="http://schemas.openxmlformats.org/presentationml/2006/main">
   <p:cSld>
     <p:spTree>
       <p:nvGrpSpPr>
@@ -12227,7 +12180,14 @@
         <p:cNvGrpSpPr/>
         <p:nvPr/>
       </p:nvGrpSpPr>
-      <p:grpSpPr/>
+      <p:grpSpPr>
+        <a:xfrm>
+          <a:off x="0" y="0"/>
+          <a:ext cx="0" cy="0"/>
+          <a:chOff x="0" y="0"/>
+          <a:chExt cx="0" cy="0"/>
+        </a:xfrm>
+      </p:grpSpPr>
       <p:sp>
         <p:nvSpPr>
           <p:cNvPr id="2" name="Rectangle 1"/>
@@ -12269,6 +12229,7 @@
           <a:lstStyle/>
           <a:p>
             <a:pPr algn="ctr"/>
+            <a:endParaRPr/>
           </a:p>
         </p:txBody>
       </p:sp>
@@ -12368,6 +12329,7 @@
           <a:lstStyle/>
           <a:p>
             <a:pPr algn="ctr"/>
+            <a:endParaRPr/>
           </a:p>
         </p:txBody>
       </p:sp>
@@ -12390,9 +12352,27 @@
                 <a:tableStyleId>{5C22544A-7EE6-4342-B048-85BDC9FD1C3A}</a:tableStyleId>
               </a:tblPr>
               <a:tblGrid>
-                <a:gridCol w="5440680"/>
-                <a:gridCol w="1305763"/>
-                <a:gridCol w="4134916"/>
+                <a:gridCol w="5440680">
+                  <a:extLst>
+                    <a:ext uri="{9D8B030D-6E8A-4147-A177-3AD203B41FA5}">
+                      <a16:colId xmlns:a16="http://schemas.microsoft.com/office/drawing/2014/main" val="20000"/>
+                    </a:ext>
+                  </a:extLst>
+                </a:gridCol>
+                <a:gridCol w="1305763">
+                  <a:extLst>
+                    <a:ext uri="{9D8B030D-6E8A-4147-A177-3AD203B41FA5}">
+                      <a16:colId xmlns:a16="http://schemas.microsoft.com/office/drawing/2014/main" val="20001"/>
+                    </a:ext>
+                  </a:extLst>
+                </a:gridCol>
+                <a:gridCol w="4134916">
+                  <a:extLst>
+                    <a:ext uri="{9D8B030D-6E8A-4147-A177-3AD203B41FA5}">
+                      <a16:colId xmlns:a16="http://schemas.microsoft.com/office/drawing/2014/main" val="20002"/>
+                    </a:ext>
+                  </a:extLst>
+                </a:gridCol>
               </a:tblGrid>
               <a:tr h="274320">
                 <a:tc>
@@ -12464,6 +12444,11 @@
                     </a:solidFill>
                   </a:tcPr>
                 </a:tc>
+                <a:extLst>
+                  <a:ext uri="{0D108BD9-81ED-4DB2-BD59-A6C34878D82A}">
+                    <a16:rowId xmlns:a16="http://schemas.microsoft.com/office/drawing/2014/main" val="10000"/>
+                  </a:ext>
+                </a:extLst>
               </a:tr>
               <a:tr h="274320">
                 <a:tc>
@@ -12535,6 +12520,11 @@
                     </a:solidFill>
                   </a:tcPr>
                 </a:tc>
+                <a:extLst>
+                  <a:ext uri="{0D108BD9-81ED-4DB2-BD59-A6C34878D82A}">
+                    <a16:rowId xmlns:a16="http://schemas.microsoft.com/office/drawing/2014/main" val="10001"/>
+                  </a:ext>
+                </a:extLst>
               </a:tr>
               <a:tr h="274320">
                 <a:tc>
@@ -12606,6 +12596,11 @@
                     </a:solidFill>
                   </a:tcPr>
                 </a:tc>
+                <a:extLst>
+                  <a:ext uri="{0D108BD9-81ED-4DB2-BD59-A6C34878D82A}">
+                    <a16:rowId xmlns:a16="http://schemas.microsoft.com/office/drawing/2014/main" val="10002"/>
+                  </a:ext>
+                </a:extLst>
               </a:tr>
               <a:tr h="274320">
                 <a:tc>
@@ -12677,6 +12672,11 @@
                     </a:solidFill>
                   </a:tcPr>
                 </a:tc>
+                <a:extLst>
+                  <a:ext uri="{0D108BD9-81ED-4DB2-BD59-A6C34878D82A}">
+                    <a16:rowId xmlns:a16="http://schemas.microsoft.com/office/drawing/2014/main" val="10003"/>
+                  </a:ext>
+                </a:extLst>
               </a:tr>
               <a:tr h="274320">
                 <a:tc>
@@ -12748,6 +12748,11 @@
                     </a:solidFill>
                   </a:tcPr>
                 </a:tc>
+                <a:extLst>
+                  <a:ext uri="{0D108BD9-81ED-4DB2-BD59-A6C34878D82A}">
+                    <a16:rowId xmlns:a16="http://schemas.microsoft.com/office/drawing/2014/main" val="10004"/>
+                  </a:ext>
+                </a:extLst>
               </a:tr>
               <a:tr h="274320">
                 <a:tc>
@@ -12819,6 +12824,11 @@
                     </a:solidFill>
                   </a:tcPr>
                 </a:tc>
+                <a:extLst>
+                  <a:ext uri="{0D108BD9-81ED-4DB2-BD59-A6C34878D82A}">
+                    <a16:rowId xmlns:a16="http://schemas.microsoft.com/office/drawing/2014/main" val="10005"/>
+                  </a:ext>
+                </a:extLst>
               </a:tr>
               <a:tr h="274320">
                 <a:tc>
@@ -12890,6 +12900,11 @@
                     </a:solidFill>
                   </a:tcPr>
                 </a:tc>
+                <a:extLst>
+                  <a:ext uri="{0D108BD9-81ED-4DB2-BD59-A6C34878D82A}">
+                    <a16:rowId xmlns:a16="http://schemas.microsoft.com/office/drawing/2014/main" val="10006"/>
+                  </a:ext>
+                </a:extLst>
               </a:tr>
               <a:tr h="274320">
                 <a:tc>
@@ -12961,6 +12976,11 @@
                     </a:solidFill>
                   </a:tcPr>
                 </a:tc>
+                <a:extLst>
+                  <a:ext uri="{0D108BD9-81ED-4DB2-BD59-A6C34878D82A}">
+                    <a16:rowId xmlns:a16="http://schemas.microsoft.com/office/drawing/2014/main" val="10007"/>
+                  </a:ext>
+                </a:extLst>
               </a:tr>
               <a:tr h="274320">
                 <a:tc>
@@ -13032,6 +13052,11 @@
                     </a:solidFill>
                   </a:tcPr>
                 </a:tc>
+                <a:extLst>
+                  <a:ext uri="{0D108BD9-81ED-4DB2-BD59-A6C34878D82A}">
+                    <a16:rowId xmlns:a16="http://schemas.microsoft.com/office/drawing/2014/main" val="10008"/>
+                  </a:ext>
+                </a:extLst>
               </a:tr>
             </a:tbl>
           </a:graphicData>
@@ -13080,6 +13105,7 @@
           <a:lstStyle/>
           <a:p>
             <a:pPr algn="ctr"/>
+            <a:endParaRPr/>
           </a:p>
         </p:txBody>
       </p:sp>
@@ -13181,6 +13207,7 @@
           <a:lstStyle/>
           <a:p>
             <a:pPr algn="ctr"/>
+            <a:endParaRPr/>
           </a:p>
         </p:txBody>
       </p:sp>
@@ -13282,6 +13309,7 @@
           <a:lstStyle/>
           <a:p>
             <a:pPr algn="ctr"/>
+            <a:endParaRPr/>
           </a:p>
         </p:txBody>
       </p:sp>
@@ -13349,7 +13377,7 @@
 </file>
 
 <file path=ppt/slides/slide5.xml><?xml version="1.0" encoding="utf-8"?>
-<p:sld xmlns:a="http://schemas.openxmlformats.org/drawingml/2006/main" xmlns:p="http://schemas.openxmlformats.org/presentationml/2006/main" xmlns:r="http://schemas.openxmlformats.org/officeDocument/2006/relationships">
+<p:sld xmlns:a="http://schemas.openxmlformats.org/drawingml/2006/main" xmlns:r="http://schemas.openxmlformats.org/officeDocument/2006/relationships" xmlns:p="http://schemas.openxmlformats.org/presentationml/2006/main">
   <p:cSld>
     <p:spTree>
       <p:nvGrpSpPr>
@@ -13357,7 +13385,14 @@
         <p:cNvGrpSpPr/>
         <p:nvPr/>
       </p:nvGrpSpPr>
-      <p:grpSpPr/>
+      <p:grpSpPr>
+        <a:xfrm>
+          <a:off x="0" y="0"/>
+          <a:ext cx="0" cy="0"/>
+          <a:chOff x="0" y="0"/>
+          <a:chExt cx="0" cy="0"/>
+        </a:xfrm>
+      </p:grpSpPr>
       <p:sp>
         <p:nvSpPr>
           <p:cNvPr id="2" name="Rectangle 1"/>
@@ -13399,6 +13434,7 @@
           <a:lstStyle/>
           <a:p>
             <a:pPr algn="ctr"/>
+            <a:endParaRPr/>
           </a:p>
         </p:txBody>
       </p:sp>
@@ -13498,6 +13534,7 @@
           <a:lstStyle/>
           <a:p>
             <a:pPr algn="ctr"/>
+            <a:endParaRPr/>
           </a:p>
         </p:txBody>
       </p:sp>
@@ -13510,7 +13547,7 @@
           <p:nvPr/>
         </p:nvPicPr>
         <p:blipFill>
-          <a:blip r:embed="rId2"/>
+          <a:blip r:embed="rId3"/>
           <a:stretch>
             <a:fillRect/>
           </a:stretch>
@@ -13534,7 +13571,7 @@
 </file>
 
 <file path=ppt/slides/slide6.xml><?xml version="1.0" encoding="utf-8"?>
-<p:sld xmlns:a="http://schemas.openxmlformats.org/drawingml/2006/main" xmlns:p="http://schemas.openxmlformats.org/presentationml/2006/main" xmlns:r="http://schemas.openxmlformats.org/officeDocument/2006/relationships">
+<p:sld xmlns:a="http://schemas.openxmlformats.org/drawingml/2006/main" xmlns:r="http://schemas.openxmlformats.org/officeDocument/2006/relationships" xmlns:p="http://schemas.openxmlformats.org/presentationml/2006/main">
   <p:cSld>
     <p:spTree>
       <p:nvGrpSpPr>
@@ -13542,7 +13579,14 @@
         <p:cNvGrpSpPr/>
         <p:nvPr/>
       </p:nvGrpSpPr>
-      <p:grpSpPr/>
+      <p:grpSpPr>
+        <a:xfrm>
+          <a:off x="0" y="0"/>
+          <a:ext cx="0" cy="0"/>
+          <a:chOff x="0" y="0"/>
+          <a:chExt cx="0" cy="0"/>
+        </a:xfrm>
+      </p:grpSpPr>
       <p:sp>
         <p:nvSpPr>
           <p:cNvPr id="2" name="Rectangle 1"/>
@@ -13584,6 +13628,7 @@
           <a:lstStyle/>
           <a:p>
             <a:pPr algn="ctr"/>
+            <a:endParaRPr/>
           </a:p>
         </p:txBody>
       </p:sp>
@@ -13683,6 +13728,7 @@
           <a:lstStyle/>
           <a:p>
             <a:pPr algn="ctr"/>
+            <a:endParaRPr/>
           </a:p>
         </p:txBody>
       </p:sp>
@@ -13705,8 +13751,20 @@
                 <a:tableStyleId>{5C22544A-7EE6-4342-B048-85BDC9FD1C3A}</a:tableStyleId>
               </a:tblPr>
               <a:tblGrid>
-                <a:gridCol w="3968496"/>
-                <a:gridCol w="2432304"/>
+                <a:gridCol w="3968496">
+                  <a:extLst>
+                    <a:ext uri="{9D8B030D-6E8A-4147-A177-3AD203B41FA5}">
+                      <a16:colId xmlns:a16="http://schemas.microsoft.com/office/drawing/2014/main" val="20000"/>
+                    </a:ext>
+                  </a:extLst>
+                </a:gridCol>
+                <a:gridCol w="2432304">
+                  <a:extLst>
+                    <a:ext uri="{9D8B030D-6E8A-4147-A177-3AD203B41FA5}">
+                      <a16:colId xmlns:a16="http://schemas.microsoft.com/office/drawing/2014/main" val="20001"/>
+                    </a:ext>
+                  </a:extLst>
+                </a:gridCol>
               </a:tblGrid>
               <a:tr h="274320">
                 <a:tc>
@@ -13755,6 +13813,11 @@
                     </a:solidFill>
                   </a:tcPr>
                 </a:tc>
+                <a:extLst>
+                  <a:ext uri="{0D108BD9-81ED-4DB2-BD59-A6C34878D82A}">
+                    <a16:rowId xmlns:a16="http://schemas.microsoft.com/office/drawing/2014/main" val="10000"/>
+                  </a:ext>
+                </a:extLst>
               </a:tr>
               <a:tr h="274320">
                 <a:tc>
@@ -13803,6 +13866,11 @@
                     </a:solidFill>
                   </a:tcPr>
                 </a:tc>
+                <a:extLst>
+                  <a:ext uri="{0D108BD9-81ED-4DB2-BD59-A6C34878D82A}">
+                    <a16:rowId xmlns:a16="http://schemas.microsoft.com/office/drawing/2014/main" val="10001"/>
+                  </a:ext>
+                </a:extLst>
               </a:tr>
               <a:tr h="274320">
                 <a:tc>
@@ -13851,6 +13919,11 @@
                     </a:solidFill>
                   </a:tcPr>
                 </a:tc>
+                <a:extLst>
+                  <a:ext uri="{0D108BD9-81ED-4DB2-BD59-A6C34878D82A}">
+                    <a16:rowId xmlns:a16="http://schemas.microsoft.com/office/drawing/2014/main" val="10002"/>
+                  </a:ext>
+                </a:extLst>
               </a:tr>
               <a:tr h="274320">
                 <a:tc>
@@ -13899,6 +13972,11 @@
                     </a:solidFill>
                   </a:tcPr>
                 </a:tc>
+                <a:extLst>
+                  <a:ext uri="{0D108BD9-81ED-4DB2-BD59-A6C34878D82A}">
+                    <a16:rowId xmlns:a16="http://schemas.microsoft.com/office/drawing/2014/main" val="10003"/>
+                  </a:ext>
+                </a:extLst>
               </a:tr>
               <a:tr h="274320">
                 <a:tc>
@@ -13947,6 +14025,11 @@
                     </a:solidFill>
                   </a:tcPr>
                 </a:tc>
+                <a:extLst>
+                  <a:ext uri="{0D108BD9-81ED-4DB2-BD59-A6C34878D82A}">
+                    <a16:rowId xmlns:a16="http://schemas.microsoft.com/office/drawing/2014/main" val="10004"/>
+                  </a:ext>
+                </a:extLst>
               </a:tr>
               <a:tr h="274320">
                 <a:tc>
@@ -13995,6 +14078,11 @@
                     </a:solidFill>
                   </a:tcPr>
                 </a:tc>
+                <a:extLst>
+                  <a:ext uri="{0D108BD9-81ED-4DB2-BD59-A6C34878D82A}">
+                    <a16:rowId xmlns:a16="http://schemas.microsoft.com/office/drawing/2014/main" val="10005"/>
+                  </a:ext>
+                </a:extLst>
               </a:tr>
               <a:tr h="274320">
                 <a:tc>
@@ -14043,6 +14131,11 @@
                     </a:solidFill>
                   </a:tcPr>
                 </a:tc>
+                <a:extLst>
+                  <a:ext uri="{0D108BD9-81ED-4DB2-BD59-A6C34878D82A}">
+                    <a16:rowId xmlns:a16="http://schemas.microsoft.com/office/drawing/2014/main" val="10006"/>
+                  </a:ext>
+                </a:extLst>
               </a:tr>
               <a:tr h="274320">
                 <a:tc>
@@ -14091,6 +14184,11 @@
                     </a:solidFill>
                   </a:tcPr>
                 </a:tc>
+                <a:extLst>
+                  <a:ext uri="{0D108BD9-81ED-4DB2-BD59-A6C34878D82A}">
+                    <a16:rowId xmlns:a16="http://schemas.microsoft.com/office/drawing/2014/main" val="10007"/>
+                  </a:ext>
+                </a:extLst>
               </a:tr>
               <a:tr h="274320">
                 <a:tc>
@@ -14139,6 +14237,11 @@
                     </a:solidFill>
                   </a:tcPr>
                 </a:tc>
+                <a:extLst>
+                  <a:ext uri="{0D108BD9-81ED-4DB2-BD59-A6C34878D82A}">
+                    <a16:rowId xmlns:a16="http://schemas.microsoft.com/office/drawing/2014/main" val="10008"/>
+                  </a:ext>
+                </a:extLst>
               </a:tr>
               <a:tr h="274320">
                 <a:tc>
@@ -14187,6 +14290,11 @@
                     </a:solidFill>
                   </a:tcPr>
                 </a:tc>
+                <a:extLst>
+                  <a:ext uri="{0D108BD9-81ED-4DB2-BD59-A6C34878D82A}">
+                    <a16:rowId xmlns:a16="http://schemas.microsoft.com/office/drawing/2014/main" val="10009"/>
+                  </a:ext>
+                </a:extLst>
               </a:tr>
               <a:tr h="274320">
                 <a:tc>
@@ -14235,6 +14343,11 @@
                     </a:solidFill>
                   </a:tcPr>
                 </a:tc>
+                <a:extLst>
+                  <a:ext uri="{0D108BD9-81ED-4DB2-BD59-A6C34878D82A}">
+                    <a16:rowId xmlns:a16="http://schemas.microsoft.com/office/drawing/2014/main" val="10010"/>
+                  </a:ext>
+                </a:extLst>
               </a:tr>
             </a:tbl>
           </a:graphicData>
@@ -14250,7 +14363,7 @@
         </p:nvGraphicFramePr>
         <p:xfrm>
           <a:off x="7269480" y="1600200"/>
-          <a:ext cx="4251959" cy="1920240"/>
+          <a:ext cx="4251959" cy="2121408"/>
         </p:xfrm>
         <a:graphic>
           <a:graphicData uri="http://schemas.openxmlformats.org/drawingml/2006/table">
@@ -14259,8 +14372,20 @@
                 <a:tableStyleId>{5C22544A-7EE6-4342-B048-85BDC9FD1C3A}</a:tableStyleId>
               </a:tblPr>
               <a:tblGrid>
-                <a:gridCol w="2211019"/>
-                <a:gridCol w="2040940"/>
+                <a:gridCol w="2211019">
+                  <a:extLst>
+                    <a:ext uri="{9D8B030D-6E8A-4147-A177-3AD203B41FA5}">
+                      <a16:colId xmlns:a16="http://schemas.microsoft.com/office/drawing/2014/main" val="20000"/>
+                    </a:ext>
+                  </a:extLst>
+                </a:gridCol>
+                <a:gridCol w="2040940">
+                  <a:extLst>
+                    <a:ext uri="{9D8B030D-6E8A-4147-A177-3AD203B41FA5}">
+                      <a16:colId xmlns:a16="http://schemas.microsoft.com/office/drawing/2014/main" val="20001"/>
+                    </a:ext>
+                  </a:extLst>
+                </a:gridCol>
               </a:tblGrid>
               <a:tr h="274320">
                 <a:tc>
@@ -14309,6 +14434,11 @@
                     </a:solidFill>
                   </a:tcPr>
                 </a:tc>
+                <a:extLst>
+                  <a:ext uri="{0D108BD9-81ED-4DB2-BD59-A6C34878D82A}">
+                    <a16:rowId xmlns:a16="http://schemas.microsoft.com/office/drawing/2014/main" val="10000"/>
+                  </a:ext>
+                </a:extLst>
               </a:tr>
               <a:tr h="274320">
                 <a:tc>
@@ -14357,6 +14487,11 @@
                     </a:solidFill>
                   </a:tcPr>
                 </a:tc>
+                <a:extLst>
+                  <a:ext uri="{0D108BD9-81ED-4DB2-BD59-A6C34878D82A}">
+                    <a16:rowId xmlns:a16="http://schemas.microsoft.com/office/drawing/2014/main" val="10001"/>
+                  </a:ext>
+                </a:extLst>
               </a:tr>
               <a:tr h="274320">
                 <a:tc>
@@ -14405,6 +14540,11 @@
                     </a:solidFill>
                   </a:tcPr>
                 </a:tc>
+                <a:extLst>
+                  <a:ext uri="{0D108BD9-81ED-4DB2-BD59-A6C34878D82A}">
+                    <a16:rowId xmlns:a16="http://schemas.microsoft.com/office/drawing/2014/main" val="10002"/>
+                  </a:ext>
+                </a:extLst>
               </a:tr>
               <a:tr h="274320">
                 <a:tc>
@@ -14453,6 +14593,11 @@
                     </a:solidFill>
                   </a:tcPr>
                 </a:tc>
+                <a:extLst>
+                  <a:ext uri="{0D108BD9-81ED-4DB2-BD59-A6C34878D82A}">
+                    <a16:rowId xmlns:a16="http://schemas.microsoft.com/office/drawing/2014/main" val="10003"/>
+                  </a:ext>
+                </a:extLst>
               </a:tr>
               <a:tr h="274320">
                 <a:tc>
@@ -14501,6 +14646,11 @@
                     </a:solidFill>
                   </a:tcPr>
                 </a:tc>
+                <a:extLst>
+                  <a:ext uri="{0D108BD9-81ED-4DB2-BD59-A6C34878D82A}">
+                    <a16:rowId xmlns:a16="http://schemas.microsoft.com/office/drawing/2014/main" val="10004"/>
+                  </a:ext>
+                </a:extLst>
               </a:tr>
               <a:tr h="274320">
                 <a:tc>
@@ -14549,6 +14699,11 @@
                     </a:solidFill>
                   </a:tcPr>
                 </a:tc>
+                <a:extLst>
+                  <a:ext uri="{0D108BD9-81ED-4DB2-BD59-A6C34878D82A}">
+                    <a16:rowId xmlns:a16="http://schemas.microsoft.com/office/drawing/2014/main" val="10005"/>
+                  </a:ext>
+                </a:extLst>
               </a:tr>
               <a:tr h="274320">
                 <a:tc>
@@ -14597,6 +14752,11 @@
                     </a:solidFill>
                   </a:tcPr>
                 </a:tc>
+                <a:extLst>
+                  <a:ext uri="{0D108BD9-81ED-4DB2-BD59-A6C34878D82A}">
+                    <a16:rowId xmlns:a16="http://schemas.microsoft.com/office/drawing/2014/main" val="10006"/>
+                  </a:ext>
+                </a:extLst>
               </a:tr>
             </a:tbl>
           </a:graphicData>
@@ -14650,7 +14810,7 @@
 </file>
 
 <file path=ppt/slides/slide7.xml><?xml version="1.0" encoding="utf-8"?>
-<p:sld xmlns:a="http://schemas.openxmlformats.org/drawingml/2006/main" xmlns:p="http://schemas.openxmlformats.org/presentationml/2006/main" xmlns:r="http://schemas.openxmlformats.org/officeDocument/2006/relationships">
+<p:sld xmlns:a="http://schemas.openxmlformats.org/drawingml/2006/main" xmlns:r="http://schemas.openxmlformats.org/officeDocument/2006/relationships" xmlns:p="http://schemas.openxmlformats.org/presentationml/2006/main">
   <p:cSld>
     <p:spTree>
       <p:nvGrpSpPr>
@@ -14658,7 +14818,14 @@
         <p:cNvGrpSpPr/>
         <p:nvPr/>
       </p:nvGrpSpPr>
-      <p:grpSpPr/>
+      <p:grpSpPr>
+        <a:xfrm>
+          <a:off x="0" y="0"/>
+          <a:ext cx="0" cy="0"/>
+          <a:chOff x="0" y="0"/>
+          <a:chExt cx="0" cy="0"/>
+        </a:xfrm>
+      </p:grpSpPr>
       <p:sp>
         <p:nvSpPr>
           <p:cNvPr id="2" name="Rectangle 1"/>
@@ -14700,6 +14867,7 @@
           <a:lstStyle/>
           <a:p>
             <a:pPr algn="ctr"/>
+            <a:endParaRPr/>
           </a:p>
         </p:txBody>
       </p:sp>
@@ -14799,6 +14967,7 @@
           <a:lstStyle/>
           <a:p>
             <a:pPr algn="ctr"/>
+            <a:endParaRPr/>
           </a:p>
         </p:txBody>
       </p:sp>
@@ -14811,7 +14980,7 @@
           <p:nvPr/>
         </p:nvPicPr>
         <p:blipFill>
-          <a:blip r:embed="rId2"/>
+          <a:blip r:embed="rId3"/>
           <a:stretch>
             <a:fillRect/>
           </a:stretch>
@@ -14835,7 +15004,7 @@
 </file>
 
 <file path=ppt/slides/slide8.xml><?xml version="1.0" encoding="utf-8"?>
-<p:sld xmlns:a="http://schemas.openxmlformats.org/drawingml/2006/main" xmlns:p="http://schemas.openxmlformats.org/presentationml/2006/main" xmlns:r="http://schemas.openxmlformats.org/officeDocument/2006/relationships">
+<p:sld xmlns:a="http://schemas.openxmlformats.org/drawingml/2006/main" xmlns:r="http://schemas.openxmlformats.org/officeDocument/2006/relationships" xmlns:p="http://schemas.openxmlformats.org/presentationml/2006/main">
   <p:cSld>
     <p:spTree>
       <p:nvGrpSpPr>
@@ -14843,7 +15012,14 @@
         <p:cNvGrpSpPr/>
         <p:nvPr/>
       </p:nvGrpSpPr>
-      <p:grpSpPr/>
+      <p:grpSpPr>
+        <a:xfrm>
+          <a:off x="0" y="0"/>
+          <a:ext cx="0" cy="0"/>
+          <a:chOff x="0" y="0"/>
+          <a:chExt cx="0" cy="0"/>
+        </a:xfrm>
+      </p:grpSpPr>
       <p:sp>
         <p:nvSpPr>
           <p:cNvPr id="2" name="Rectangle 1"/>
@@ -14885,6 +15061,7 @@
           <a:lstStyle/>
           <a:p>
             <a:pPr algn="ctr"/>
+            <a:endParaRPr/>
           </a:p>
         </p:txBody>
       </p:sp>
@@ -14984,6 +15161,7 @@
           <a:lstStyle/>
           <a:p>
             <a:pPr algn="ctr"/>
+            <a:endParaRPr/>
           </a:p>
         </p:txBody>
       </p:sp>
@@ -14996,7 +15174,7 @@
           <p:nvPr/>
         </p:nvPicPr>
         <p:blipFill>
-          <a:blip r:embed="rId2"/>
+          <a:blip r:embed="rId3"/>
           <a:stretch>
             <a:fillRect/>
           </a:stretch>
@@ -15020,7 +15198,7 @@
 </file>
 
 <file path=ppt/slides/slide9.xml><?xml version="1.0" encoding="utf-8"?>
-<p:sld xmlns:a="http://schemas.openxmlformats.org/drawingml/2006/main" xmlns:p="http://schemas.openxmlformats.org/presentationml/2006/main" xmlns:r="http://schemas.openxmlformats.org/officeDocument/2006/relationships">
+<p:sld xmlns:a="http://schemas.openxmlformats.org/drawingml/2006/main" xmlns:r="http://schemas.openxmlformats.org/officeDocument/2006/relationships" xmlns:p="http://schemas.openxmlformats.org/presentationml/2006/main">
   <p:cSld>
     <p:spTree>
       <p:nvGrpSpPr>
@@ -15028,7 +15206,14 @@
         <p:cNvGrpSpPr/>
         <p:nvPr/>
       </p:nvGrpSpPr>
-      <p:grpSpPr/>
+      <p:grpSpPr>
+        <a:xfrm>
+          <a:off x="0" y="0"/>
+          <a:ext cx="0" cy="0"/>
+          <a:chOff x="0" y="0"/>
+          <a:chExt cx="0" cy="0"/>
+        </a:xfrm>
+      </p:grpSpPr>
       <p:sp>
         <p:nvSpPr>
           <p:cNvPr id="2" name="Rectangle 1"/>
@@ -15070,6 +15255,7 @@
           <a:lstStyle/>
           <a:p>
             <a:pPr algn="ctr"/>
+            <a:endParaRPr/>
           </a:p>
         </p:txBody>
       </p:sp>
@@ -15169,6 +15355,7 @@
           <a:lstStyle/>
           <a:p>
             <a:pPr algn="ctr"/>
+            <a:endParaRPr/>
           </a:p>
         </p:txBody>
       </p:sp>
@@ -15181,7 +15368,7 @@
           <p:nvPr/>
         </p:nvPicPr>
         <p:blipFill>
-          <a:blip r:embed="rId2"/>
+          <a:blip r:embed="rId3"/>
           <a:stretch>
             <a:fillRect/>
           </a:stretch>
@@ -15535,44 +15722,44 @@
         <a:sysClr val="window" lastClr="FFFFFF"/>
       </a:lt1>
       <a:dk2>
-        <a:srgbClr val="1F497D"/>
+        <a:srgbClr val="44546A"/>
       </a:dk2>
       <a:lt2>
-        <a:srgbClr val="EEECE1"/>
+        <a:srgbClr val="E7E6E6"/>
       </a:lt2>
       <a:accent1>
-        <a:srgbClr val="4F81BD"/>
+        <a:srgbClr val="4472C4"/>
       </a:accent1>
       <a:accent2>
-        <a:srgbClr val="C0504D"/>
+        <a:srgbClr val="ED7D31"/>
       </a:accent2>
       <a:accent3>
-        <a:srgbClr val="9BBB59"/>
+        <a:srgbClr val="A5A5A5"/>
       </a:accent3>
       <a:accent4>
-        <a:srgbClr val="8064A2"/>
+        <a:srgbClr val="FFC000"/>
       </a:accent4>
       <a:accent5>
-        <a:srgbClr val="4BACC6"/>
+        <a:srgbClr val="5B9BD5"/>
       </a:accent5>
       <a:accent6>
-        <a:srgbClr val="F79646"/>
+        <a:srgbClr val="70AD47"/>
       </a:accent6>
       <a:hlink>
-        <a:srgbClr val="0000FF"/>
+        <a:srgbClr val="0563C1"/>
       </a:hlink>
       <a:folHlink>
-        <a:srgbClr val="800080"/>
+        <a:srgbClr val="954F72"/>
       </a:folHlink>
     </a:clrScheme>
     <a:fontScheme name="Office">
       <a:majorFont>
-        <a:latin typeface="Calibri"/>
+        <a:latin typeface="Calibri Light" panose="020F0302020204030204"/>
         <a:ea typeface=""/>
         <a:cs typeface=""/>
-        <a:font script="Jpan" typeface="ＭＳ Ｐゴシック"/>
+        <a:font script="Jpan" typeface="游ゴシック Light"/>
         <a:font script="Hang" typeface="맑은 고딕"/>
-        <a:font script="Hans" typeface="宋体"/>
+        <a:font script="Hans" typeface="等线 Light"/>
         <a:font script="Hant" typeface="新細明體"/>
         <a:font script="Arab" typeface="Times New Roman"/>
         <a:font script="Hebr" typeface="Times New Roman"/>
@@ -15600,14 +15787,31 @@
         <a:font script="Viet" typeface="Times New Roman"/>
         <a:font script="Uigh" typeface="Microsoft Uighur"/>
         <a:font script="Geor" typeface="Sylfaen"/>
+        <a:font script="Armn" typeface="Arial"/>
+        <a:font script="Bugi" typeface="Leelawadee UI"/>
+        <a:font script="Bopo" typeface="Microsoft JhengHei"/>
+        <a:font script="Java" typeface="Javanese Text"/>
+        <a:font script="Lisu" typeface="Segoe UI"/>
+        <a:font script="Mymr" typeface="Myanmar Text"/>
+        <a:font script="Nkoo" typeface="Ebrima"/>
+        <a:font script="Olck" typeface="Nirmala UI"/>
+        <a:font script="Osma" typeface="Ebrima"/>
+        <a:font script="Phag" typeface="Phagspa"/>
+        <a:font script="Syrn" typeface="Estrangelo Edessa"/>
+        <a:font script="Syrj" typeface="Estrangelo Edessa"/>
+        <a:font script="Syre" typeface="Estrangelo Edessa"/>
+        <a:font script="Sora" typeface="Nirmala UI"/>
+        <a:font script="Tale" typeface="Microsoft Tai Le"/>
+        <a:font script="Talu" typeface="Microsoft New Tai Lue"/>
+        <a:font script="Tfng" typeface="Ebrima"/>
       </a:majorFont>
       <a:minorFont>
-        <a:latin typeface="Calibri"/>
+        <a:latin typeface="Calibri" panose="020F0502020204030204"/>
         <a:ea typeface=""/>
         <a:cs typeface=""/>
-        <a:font script="Jpan" typeface="ＭＳ Ｐゴシック"/>
+        <a:font script="Jpan" typeface="游ゴシック"/>
         <a:font script="Hang" typeface="맑은 고딕"/>
-        <a:font script="Hans" typeface="宋体"/>
+        <a:font script="Hans" typeface="等线"/>
         <a:font script="Hant" typeface="新細明體"/>
         <a:font script="Arab" typeface="Arial"/>
         <a:font script="Hebr" typeface="Arial"/>
@@ -15635,6 +15839,23 @@
         <a:font script="Viet" typeface="Arial"/>
         <a:font script="Uigh" typeface="Microsoft Uighur"/>
         <a:font script="Geor" typeface="Sylfaen"/>
+        <a:font script="Armn" typeface="Arial"/>
+        <a:font script="Bugi" typeface="Leelawadee UI"/>
+        <a:font script="Bopo" typeface="Microsoft JhengHei"/>
+        <a:font script="Java" typeface="Javanese Text"/>
+        <a:font script="Lisu" typeface="Segoe UI"/>
+        <a:font script="Mymr" typeface="Myanmar Text"/>
+        <a:font script="Nkoo" typeface="Ebrima"/>
+        <a:font script="Olck" typeface="Nirmala UI"/>
+        <a:font script="Osma" typeface="Ebrima"/>
+        <a:font script="Phag" typeface="Phagspa"/>
+        <a:font script="Syrn" typeface="Estrangelo Edessa"/>
+        <a:font script="Syrj" typeface="Estrangelo Edessa"/>
+        <a:font script="Syre" typeface="Estrangelo Edessa"/>
+        <a:font script="Sora" typeface="Nirmala UI"/>
+        <a:font script="Tale" typeface="Microsoft Tai Le"/>
+        <a:font script="Talu" typeface="Microsoft New Tai Lue"/>
+        <a:font script="Tfng" typeface="Ebrima"/>
       </a:minorFont>
     </a:fontScheme>
     <a:fmtScheme name="Office">
@@ -15646,200 +15867,141 @@
           <a:gsLst>
             <a:gs pos="0">
               <a:schemeClr val="phClr">
-                <a:tint val="50000"/>
-                <a:satMod val="300000"/>
+                <a:lumMod val="110000"/>
+                <a:satMod val="105000"/>
+                <a:tint val="67000"/>
               </a:schemeClr>
             </a:gs>
-            <a:gs pos="35000">
+            <a:gs pos="50000">
               <a:schemeClr val="phClr">
-                <a:tint val="37000"/>
-                <a:satMod val="300000"/>
+                <a:lumMod val="105000"/>
+                <a:satMod val="103000"/>
+                <a:tint val="73000"/>
               </a:schemeClr>
             </a:gs>
             <a:gs pos="100000">
               <a:schemeClr val="phClr">
-                <a:tint val="15000"/>
-                <a:satMod val="350000"/>
+                <a:lumMod val="105000"/>
+                <a:satMod val="109000"/>
+                <a:tint val="81000"/>
               </a:schemeClr>
             </a:gs>
           </a:gsLst>
-          <a:lin ang="16200000" scaled="1"/>
+          <a:lin ang="5400000" scaled="0"/>
         </a:gradFill>
         <a:gradFill rotWithShape="1">
           <a:gsLst>
             <a:gs pos="0">
               <a:schemeClr val="phClr">
-                <a:tint val="100000"/>
+                <a:satMod val="103000"/>
+                <a:lumMod val="102000"/>
+                <a:tint val="94000"/>
+              </a:schemeClr>
+            </a:gs>
+            <a:gs pos="50000">
+              <a:schemeClr val="phClr">
+                <a:satMod val="110000"/>
+                <a:lumMod val="100000"/>
                 <a:shade val="100000"/>
-                <a:satMod val="130000"/>
               </a:schemeClr>
             </a:gs>
             <a:gs pos="100000">
               <a:schemeClr val="phClr">
-                <a:tint val="50000"/>
-                <a:shade val="100000"/>
-                <a:satMod val="350000"/>
+                <a:lumMod val="99000"/>
+                <a:satMod val="120000"/>
+                <a:shade val="78000"/>
               </a:schemeClr>
             </a:gs>
           </a:gsLst>
-          <a:lin ang="16200000" scaled="0"/>
+          <a:lin ang="5400000" scaled="0"/>
         </a:gradFill>
       </a:fillStyleLst>
       <a:lnStyleLst>
-        <a:ln w="9525" cap="flat" cmpd="sng" algn="ctr">
-          <a:solidFill>
-            <a:schemeClr val="phClr">
-              <a:shade val="95000"/>
-              <a:satMod val="105000"/>
-            </a:schemeClr>
-          </a:solidFill>
-          <a:prstDash val="solid"/>
-        </a:ln>
-        <a:ln w="25400" cap="flat" cmpd="sng" algn="ctr">
+        <a:ln w="6350" cap="flat" cmpd="sng" algn="ctr">
           <a:solidFill>
             <a:schemeClr val="phClr"/>
           </a:solidFill>
           <a:prstDash val="solid"/>
+          <a:miter lim="800000"/>
         </a:ln>
-        <a:ln w="38100" cap="flat" cmpd="sng" algn="ctr">
+        <a:ln w="12700" cap="flat" cmpd="sng" algn="ctr">
           <a:solidFill>
             <a:schemeClr val="phClr"/>
           </a:solidFill>
           <a:prstDash val="solid"/>
+          <a:miter lim="800000"/>
+        </a:ln>
+        <a:ln w="19050" cap="flat" cmpd="sng" algn="ctr">
+          <a:solidFill>
+            <a:schemeClr val="phClr"/>
+          </a:solidFill>
+          <a:prstDash val="solid"/>
+          <a:miter lim="800000"/>
         </a:ln>
       </a:lnStyleLst>
       <a:effectStyleLst>
         <a:effectStyle>
+          <a:effectLst/>
+        </a:effectStyle>
+        <a:effectStyle>
+          <a:effectLst/>
+        </a:effectStyle>
+        <a:effectStyle>
           <a:effectLst>
-            <a:outerShdw blurRad="40000" dist="20000" dir="5400000" rotWithShape="0">
+            <a:outerShdw blurRad="57150" dist="19050" dir="5400000" algn="ctr" rotWithShape="0">
               <a:srgbClr val="000000">
-                <a:alpha val="38000"/>
+                <a:alpha val="63000"/>
               </a:srgbClr>
             </a:outerShdw>
           </a:effectLst>
-        </a:effectStyle>
-        <a:effectStyle>
-          <a:effectLst>
-            <a:outerShdw blurRad="40000" dist="23000" dir="5400000" rotWithShape="0">
-              <a:srgbClr val="000000">
-                <a:alpha val="35000"/>
-              </a:srgbClr>
-            </a:outerShdw>
-          </a:effectLst>
-        </a:effectStyle>
-        <a:effectStyle>
-          <a:effectLst>
-            <a:outerShdw blurRad="40000" dist="23000" dir="5400000" rotWithShape="0">
-              <a:srgbClr val="000000">
-                <a:alpha val="35000"/>
-              </a:srgbClr>
-            </a:outerShdw>
-          </a:effectLst>
-          <a:scene3d>
-            <a:camera prst="orthographicFront">
-              <a:rot lat="0" lon="0" rev="0"/>
-            </a:camera>
-            <a:lightRig rig="threePt" dir="t">
-              <a:rot lat="0" lon="0" rev="1200000"/>
-            </a:lightRig>
-          </a:scene3d>
-          <a:sp3d>
-            <a:bevelT w="63500" h="25400"/>
-          </a:sp3d>
         </a:effectStyle>
       </a:effectStyleLst>
       <a:bgFillStyleLst>
         <a:solidFill>
           <a:schemeClr val="phClr"/>
         </a:solidFill>
+        <a:solidFill>
+          <a:schemeClr val="phClr">
+            <a:tint val="95000"/>
+            <a:satMod val="170000"/>
+          </a:schemeClr>
+        </a:solidFill>
         <a:gradFill rotWithShape="1">
           <a:gsLst>
             <a:gs pos="0">
               <a:schemeClr val="phClr">
-                <a:tint val="40000"/>
-                <a:satMod val="350000"/>
+                <a:tint val="93000"/>
+                <a:satMod val="150000"/>
+                <a:shade val="98000"/>
+                <a:lumMod val="102000"/>
               </a:schemeClr>
             </a:gs>
-            <a:gs pos="40000">
+            <a:gs pos="50000">
               <a:schemeClr val="phClr">
-                <a:tint val="45000"/>
-                <a:shade val="99000"/>
-                <a:satMod val="350000"/>
+                <a:tint val="98000"/>
+                <a:satMod val="130000"/>
+                <a:shade val="90000"/>
+                <a:lumMod val="103000"/>
               </a:schemeClr>
             </a:gs>
             <a:gs pos="100000">
               <a:schemeClr val="phClr">
-                <a:shade val="20000"/>
-                <a:satMod val="255000"/>
+                <a:shade val="63000"/>
+                <a:satMod val="120000"/>
               </a:schemeClr>
             </a:gs>
           </a:gsLst>
-          <a:path path="circle">
-            <a:fillToRect l="50000" t="-80000" r="50000" b="180000"/>
-          </a:path>
-        </a:gradFill>
-        <a:gradFill rotWithShape="1">
-          <a:gsLst>
-            <a:gs pos="0">
-              <a:schemeClr val="phClr">
-                <a:tint val="80000"/>
-                <a:satMod val="300000"/>
-              </a:schemeClr>
-            </a:gs>
-            <a:gs pos="100000">
-              <a:schemeClr val="phClr">
-                <a:shade val="30000"/>
-                <a:satMod val="200000"/>
-              </a:schemeClr>
-            </a:gs>
-          </a:gsLst>
-          <a:path path="circle">
-            <a:fillToRect l="50000" t="50000" r="50000" b="50000"/>
-          </a:path>
+          <a:lin ang="5400000" scaled="0"/>
         </a:gradFill>
       </a:bgFillStyleLst>
     </a:fmtScheme>
   </a:themeElements>
-  <a:objectDefaults>
-    <a:spDef>
-      <a:spPr/>
-      <a:bodyPr/>
-      <a:lstStyle/>
-      <a:style>
-        <a:lnRef idx="1">
-          <a:schemeClr val="accent1"/>
-        </a:lnRef>
-        <a:fillRef idx="3">
-          <a:schemeClr val="accent1"/>
-        </a:fillRef>
-        <a:effectRef idx="2">
-          <a:schemeClr val="accent1"/>
-        </a:effectRef>
-        <a:fontRef idx="minor">
-          <a:schemeClr val="lt1"/>
-        </a:fontRef>
-      </a:style>
-    </a:spDef>
-    <a:lnDef>
-      <a:spPr/>
-      <a:bodyPr/>
-      <a:lstStyle/>
-      <a:style>
-        <a:lnRef idx="2">
-          <a:schemeClr val="accent1"/>
-        </a:lnRef>
-        <a:fillRef idx="0">
-          <a:schemeClr val="accent1"/>
-        </a:fillRef>
-        <a:effectRef idx="1">
-          <a:schemeClr val="accent1"/>
-        </a:effectRef>
-        <a:fontRef idx="minor">
-          <a:schemeClr val="tx1"/>
-        </a:fontRef>
-      </a:style>
-    </a:lnDef>
-  </a:objectDefaults>
+  <a:objectDefaults/>
   <a:extraClrSchemeLst/>
+  <a:extLst>
+    <a:ext uri="{05A4C25C-085E-4340-85A3-A5531E510DB2}">
+      <thm15:themeFamily xmlns:thm15="http://schemas.microsoft.com/office/thememl/2012/main" name="Office Theme" id="{62F939B6-93AF-4DB8-9C6B-D6C7DFDC589F}" vid="{4A3C46E8-61CC-4603-A589-7422A47A8E4A}"/>
+    </a:ext>
+  </a:extLst>
 </a:theme>
 </file>
</xml_diff>

<commit_message>
docs: update review 3 presentation
</commit_message>
<xml_diff>
--- a/docs/Review3_Panel_Presentation.pptx
+++ b/docs/Review3_Panel_Presentation.pptx
@@ -2133,7 +2133,7 @@
           <a:p>
             <a:fld id="{5BCAD085-E8A6-8845-BD4E-CB4CCA059FC4}" type="datetimeFigureOut">
               <a:rPr lang="en-US" smtClean="0"/>
-              <a:t>9/13/2026</a:t>
+              <a:t>9/15/2026</a:t>
             </a:fld>
             <a:endParaRPr lang="en-US"/>
           </a:p>
@@ -2301,7 +2301,7 @@
           <a:p>
             <a:fld id="{5BCAD085-E8A6-8845-BD4E-CB4CCA059FC4}" type="datetimeFigureOut">
               <a:rPr lang="en-US" smtClean="0"/>
-              <a:t>9/13/2026</a:t>
+              <a:t>9/15/2026</a:t>
             </a:fld>
             <a:endParaRPr lang="en-US"/>
           </a:p>
@@ -2479,7 +2479,7 @@
           <a:p>
             <a:fld id="{5BCAD085-E8A6-8845-BD4E-CB4CCA059FC4}" type="datetimeFigureOut">
               <a:rPr lang="en-US" smtClean="0"/>
-              <a:t>9/13/2026</a:t>
+              <a:t>9/15/2026</a:t>
             </a:fld>
             <a:endParaRPr lang="en-US"/>
           </a:p>
@@ -2647,7 +2647,7 @@
           <a:p>
             <a:fld id="{5BCAD085-E8A6-8845-BD4E-CB4CCA059FC4}" type="datetimeFigureOut">
               <a:rPr lang="en-US" smtClean="0"/>
-              <a:t>9/13/2026</a:t>
+              <a:t>9/15/2026</a:t>
             </a:fld>
             <a:endParaRPr lang="en-US"/>
           </a:p>
@@ -2892,7 +2892,7 @@
           <a:p>
             <a:fld id="{5BCAD085-E8A6-8845-BD4E-CB4CCA059FC4}" type="datetimeFigureOut">
               <a:rPr lang="en-US" smtClean="0"/>
-              <a:t>9/13/2026</a:t>
+              <a:t>9/15/2026</a:t>
             </a:fld>
             <a:endParaRPr lang="en-US"/>
           </a:p>
@@ -3177,7 +3177,7 @@
           <a:p>
             <a:fld id="{5BCAD085-E8A6-8845-BD4E-CB4CCA059FC4}" type="datetimeFigureOut">
               <a:rPr lang="en-US" smtClean="0"/>
-              <a:t>9/13/2026</a:t>
+              <a:t>9/15/2026</a:t>
             </a:fld>
             <a:endParaRPr lang="en-US"/>
           </a:p>
@@ -3596,7 +3596,7 @@
           <a:p>
             <a:fld id="{5BCAD085-E8A6-8845-BD4E-CB4CCA059FC4}" type="datetimeFigureOut">
               <a:rPr lang="en-US" smtClean="0"/>
-              <a:t>9/13/2026</a:t>
+              <a:t>9/15/2026</a:t>
             </a:fld>
             <a:endParaRPr lang="en-US"/>
           </a:p>
@@ -3713,7 +3713,7 @@
           <a:p>
             <a:fld id="{5BCAD085-E8A6-8845-BD4E-CB4CCA059FC4}" type="datetimeFigureOut">
               <a:rPr lang="en-US" smtClean="0"/>
-              <a:t>9/13/2026</a:t>
+              <a:t>9/15/2026</a:t>
             </a:fld>
             <a:endParaRPr lang="en-US"/>
           </a:p>
@@ -3808,7 +3808,7 @@
           <a:p>
             <a:fld id="{5BCAD085-E8A6-8845-BD4E-CB4CCA059FC4}" type="datetimeFigureOut">
               <a:rPr lang="en-US" smtClean="0"/>
-              <a:t>9/13/2026</a:t>
+              <a:t>9/15/2026</a:t>
             </a:fld>
             <a:endParaRPr lang="en-US"/>
           </a:p>
@@ -4083,7 +4083,7 @@
           <a:p>
             <a:fld id="{5BCAD085-E8A6-8845-BD4E-CB4CCA059FC4}" type="datetimeFigureOut">
               <a:rPr lang="en-US" smtClean="0"/>
-              <a:t>9/13/2026</a:t>
+              <a:t>9/15/2026</a:t>
             </a:fld>
             <a:endParaRPr lang="en-US"/>
           </a:p>
@@ -4335,7 +4335,7 @@
           <a:p>
             <a:fld id="{5BCAD085-E8A6-8845-BD4E-CB4CCA059FC4}" type="datetimeFigureOut">
               <a:rPr lang="en-US" smtClean="0"/>
-              <a:t>9/13/2026</a:t>
+              <a:t>9/15/2026</a:t>
             </a:fld>
             <a:endParaRPr lang="en-US"/>
           </a:p>
@@ -4546,7 +4546,7 @@
           <a:p>
             <a:fld id="{5BCAD085-E8A6-8845-BD4E-CB4CCA059FC4}" type="datetimeFigureOut">
               <a:rPr lang="en-US" smtClean="0"/>
-              <a:t>9/13/2026</a:t>
+              <a:t>9/15/2026</a:t>
             </a:fld>
             <a:endParaRPr lang="en-US"/>
           </a:p>
@@ -5110,7 +5110,7 @@
               </a:spcAft>
             </a:pPr>
             <a:r>
-              <a:rPr sz="1400" b="0">
+              <a:rPr sz="1400" b="0" dirty="0">
                 <a:solidFill>
                   <a:srgbClr val="101826"/>
                 </a:solidFill>
@@ -5126,7 +5126,7 @@
               </a:spcAft>
             </a:pPr>
             <a:r>
-              <a:rPr sz="1300" b="0">
+              <a:rPr sz="1300" b="0" dirty="0">
                 <a:solidFill>
                   <a:srgbClr val="5A6474"/>
                 </a:solidFill>
@@ -5142,7 +5142,7 @@
               </a:spcAft>
             </a:pPr>
             <a:r>
-              <a:rPr sz="1300" b="0">
+              <a:rPr sz="1300" b="0" dirty="0">
                 <a:solidFill>
                   <a:srgbClr val="5A6474"/>
                 </a:solidFill>
@@ -5186,7 +5186,7 @@
         </p:nvSpPr>
         <p:spPr>
           <a:xfrm>
-            <a:off x="0" y="0"/>
+            <a:off x="19878" y="0"/>
             <a:ext cx="12191695" cy="6858000"/>
           </a:xfrm>
           <a:prstGeom prst="rect">
@@ -5232,7 +5232,7 @@
         <p:spPr>
           <a:xfrm>
             <a:off x="640080" y="384048"/>
-            <a:ext cx="10972800" cy="822960"/>
+            <a:ext cx="10972800" cy="553998"/>
           </a:xfrm>
           <a:prstGeom prst="rect">
             <a:avLst/>
@@ -5251,29 +5251,13 @@
               </a:spcAft>
             </a:pPr>
             <a:r>
-              <a:rPr sz="3000" b="1">
+              <a:rPr sz="3000" b="1" dirty="0">
                 <a:solidFill>
                   <a:srgbClr val="101826"/>
                 </a:solidFill>
                 <a:latin typeface="Segoe UI"/>
               </a:rPr>
               <a:t>The ghost-growth algorithm</a:t>
-            </a:r>
-          </a:p>
-          <a:p>
-            <a:pPr>
-              <a:spcAft>
-                <a:spcPts val="0"/>
-              </a:spcAft>
-            </a:pPr>
-            <a:r>
-              <a:rPr sz="1350" b="0">
-                <a:solidFill>
-                  <a:srgbClr val="1B5FAF"/>
-                </a:solidFill>
-                <a:latin typeface="Segoe UI"/>
-              </a:rPr>
-              <a:t>Each cell is judged against comparably built land in the same city</a:t>
             </a:r>
           </a:p>
         </p:txBody>
@@ -5333,6 +5317,7 @@
         </p:nvPicPr>
         <p:blipFill>
           <a:blip r:embed="rId3"/>
+          <a:srcRect b="11796"/>
           <a:stretch>
             <a:fillRect/>
           </a:stretch>
@@ -5340,7 +5325,7 @@
         <p:spPr>
           <a:xfrm>
             <a:off x="1237535" y="1508760"/>
-            <a:ext cx="9713881" cy="5074920"/>
+            <a:ext cx="9713881" cy="4476253"/>
           </a:xfrm>
           <a:prstGeom prst="rect">
             <a:avLst/>
@@ -5426,7 +5411,7 @@
         <p:spPr>
           <a:xfrm>
             <a:off x="640080" y="384048"/>
-            <a:ext cx="10972800" cy="822960"/>
+            <a:ext cx="10972800" cy="553998"/>
           </a:xfrm>
           <a:prstGeom prst="rect">
             <a:avLst/>
@@ -5445,29 +5430,13 @@
               </a:spcAft>
             </a:pPr>
             <a:r>
-              <a:rPr sz="3000" b="1">
+              <a:rPr sz="3000" b="1" dirty="0">
                 <a:solidFill>
                   <a:srgbClr val="101826"/>
                 </a:solidFill>
                 <a:latin typeface="Segoe UI"/>
               </a:rPr>
               <a:t>Why the light trend is relative to the city</a:t>
-            </a:r>
-          </a:p>
-          <a:p>
-            <a:pPr>
-              <a:spcAft>
-                <a:spcPts val="0"/>
-              </a:spcAft>
-            </a:pPr>
-            <a:r>
-              <a:rPr sz="1350" b="0">
-                <a:solidFill>
-                  <a:srgbClr val="1B5FAF"/>
-                </a:solidFill>
-                <a:latin typeface="Segoe UI"/>
-              </a:rPr>
-              <a:t>Raw radiance rises everywhere; relative to the city, only some cells catch up</a:t>
             </a:r>
           </a:p>
         </p:txBody>
@@ -5527,6 +5496,7 @@
         </p:nvPicPr>
         <p:blipFill>
           <a:blip r:embed="rId3"/>
+          <a:srcRect b="5557"/>
           <a:stretch>
             <a:fillRect/>
           </a:stretch>
@@ -5534,7 +5504,7 @@
         <p:spPr>
           <a:xfrm>
             <a:off x="457200" y="1827707"/>
-            <a:ext cx="11274552" cy="4437025"/>
+            <a:ext cx="11274552" cy="4190437"/>
           </a:xfrm>
           <a:prstGeom prst="rect">
             <a:avLst/>
@@ -5620,7 +5590,7 @@
         <p:spPr>
           <a:xfrm>
             <a:off x="640080" y="384048"/>
-            <a:ext cx="10972800" cy="822960"/>
+            <a:ext cx="10972800" cy="553998"/>
           </a:xfrm>
           <a:prstGeom prst="rect">
             <a:avLst/>
@@ -5639,29 +5609,13 @@
               </a:spcAft>
             </a:pPr>
             <a:r>
-              <a:rPr sz="3000" b="1">
+              <a:rPr sz="3000" b="1" dirty="0">
                 <a:solidFill>
                   <a:srgbClr val="101826"/>
                 </a:solidFill>
                 <a:latin typeface="Segoe UI"/>
               </a:rPr>
               <a:t>Surface heat-island method</a:t>
-            </a:r>
-          </a:p>
-          <a:p>
-            <a:pPr>
-              <a:spcAft>
-                <a:spcPts val="0"/>
-              </a:spcAft>
-            </a:pPr>
-            <a:r>
-              <a:rPr sz="1350" b="0">
-                <a:solidFill>
-                  <a:srgbClr val="1B5FAF"/>
-                </a:solidFill>
-                <a:latin typeface="Segoe UI"/>
-              </a:rPr>
-              <a:t>Land surface temperature minus a rural reference from the same scene</a:t>
             </a:r>
           </a:p>
         </p:txBody>
@@ -5814,7 +5768,7 @@
         <p:spPr>
           <a:xfrm>
             <a:off x="640080" y="384048"/>
-            <a:ext cx="10972800" cy="822960"/>
+            <a:ext cx="10972800" cy="553998"/>
           </a:xfrm>
           <a:prstGeom prst="rect">
             <a:avLst/>
@@ -5833,29 +5787,13 @@
               </a:spcAft>
             </a:pPr>
             <a:r>
-              <a:rPr sz="3000" b="1">
+              <a:rPr sz="3000" b="1" dirty="0">
                 <a:solidFill>
                   <a:srgbClr val="101826"/>
                 </a:solidFill>
                 <a:latin typeface="Segoe UI"/>
               </a:rPr>
               <a:t>Growth-model architecture</a:t>
-            </a:r>
-          </a:p>
-          <a:p>
-            <a:pPr>
-              <a:spcAft>
-                <a:spcPts val="0"/>
-              </a:spcAft>
-            </a:pPr>
-            <a:r>
-              <a:rPr sz="1350" b="0">
-                <a:solidFill>
-                  <a:srgbClr val="1B5FAF"/>
-                </a:solidFill>
-                <a:latin typeface="Segoe UI"/>
-              </a:rPr>
-              <a:t>Learn where the city grew, test on years it never saw, then predict</a:t>
             </a:r>
           </a:p>
         </p:txBody>
@@ -6008,7 +5946,7 @@
         <p:spPr>
           <a:xfrm>
             <a:off x="640080" y="384048"/>
-            <a:ext cx="10972800" cy="822960"/>
+            <a:ext cx="10972800" cy="553998"/>
           </a:xfrm>
           <a:prstGeom prst="rect">
             <a:avLst/>
@@ -6027,29 +5965,13 @@
               </a:spcAft>
             </a:pPr>
             <a:r>
-              <a:rPr sz="3000" b="1">
+              <a:rPr sz="3000" b="1" dirty="0">
                 <a:solidFill>
                   <a:srgbClr val="101826"/>
                 </a:solidFill>
                 <a:latin typeface="Segoe UI"/>
               </a:rPr>
               <a:t>Validation framework</a:t>
-            </a:r>
-          </a:p>
-          <a:p>
-            <a:pPr>
-              <a:spcAft>
-                <a:spcPts val="0"/>
-              </a:spcAft>
-            </a:pPr>
-            <a:r>
-              <a:rPr sz="1350" b="0">
-                <a:solidFill>
-                  <a:srgbClr val="1B5FAF"/>
-                </a:solidFill>
-                <a:latin typeface="Segoe UI"/>
-              </a:rPr>
-              <a:t>Every headline claim is checked against evidence the method never used</a:t>
             </a:r>
           </a:p>
         </p:txBody>
@@ -6109,6 +6031,7 @@
         </p:nvPicPr>
         <p:blipFill>
           <a:blip r:embed="rId3"/>
+          <a:srcRect b="6998"/>
           <a:stretch>
             <a:fillRect/>
           </a:stretch>
@@ -6116,7 +6039,7 @@
         <p:spPr>
           <a:xfrm>
             <a:off x="556117" y="1508760"/>
-            <a:ext cx="11076717" cy="5074920"/>
+            <a:ext cx="11076717" cy="4719762"/>
           </a:xfrm>
           <a:prstGeom prst="rect">
             <a:avLst/>
@@ -6303,6 +6226,7 @@
         </p:nvPicPr>
         <p:blipFill>
           <a:blip r:embed="rId3"/>
+          <a:srcRect b="7098"/>
           <a:stretch>
             <a:fillRect/>
           </a:stretch>
@@ -6310,7 +6234,7 @@
         <p:spPr>
           <a:xfrm>
             <a:off x="640080" y="1554480"/>
-            <a:ext cx="5669280" cy="3896031"/>
+            <a:ext cx="5669280" cy="3619501"/>
           </a:xfrm>
           <a:prstGeom prst="rect">
             <a:avLst/>
@@ -8908,7 +8832,7 @@
         <p:spPr>
           <a:xfrm>
             <a:off x="640080" y="384048"/>
-            <a:ext cx="10972800" cy="822960"/>
+            <a:ext cx="10972800" cy="553998"/>
           </a:xfrm>
           <a:prstGeom prst="rect">
             <a:avLst/>
@@ -8927,29 +8851,13 @@
               </a:spcAft>
             </a:pPr>
             <a:r>
-              <a:rPr sz="3000" b="1">
+              <a:rPr sz="3000" b="1" dirty="0">
                 <a:solidFill>
                   <a:srgbClr val="101826"/>
                 </a:solidFill>
                 <a:latin typeface="Segoe UI"/>
               </a:rPr>
               <a:t>What the system answers</a:t>
-            </a:r>
-          </a:p>
-          <a:p>
-            <a:pPr>
-              <a:spcAft>
-                <a:spcPts val="0"/>
-              </a:spcAft>
-            </a:pPr>
-            <a:r>
-              <a:rPr sz="1350" b="0">
-                <a:solidFill>
-                  <a:srgbClr val="1B5FAF"/>
-                </a:solidFill>
-                <a:latin typeface="Segoe UI"/>
-              </a:rPr>
-              <a:t>Three questions about Varanasi, from open satellite data</a:t>
             </a:r>
           </a:p>
         </p:txBody>
@@ -9074,7 +8982,7 @@
               </a:spcAft>
             </a:pPr>
             <a:r>
-              <a:rPr sz="1600" b="1">
+              <a:rPr sz="1600" b="1" dirty="0">
                 <a:solidFill>
                   <a:srgbClr val="1B5FAF"/>
                 </a:solidFill>
@@ -9090,7 +8998,7 @@
               </a:spcAft>
             </a:pPr>
             <a:r>
-              <a:rPr sz="1350" b="0">
+              <a:rPr sz="1350" b="0" dirty="0">
                 <a:solidFill>
                   <a:srgbClr val="5A6474"/>
                 </a:solidFill>
@@ -9811,45 +9719,6 @@
                 <a:latin typeface="Segoe UI"/>
               </a:rPr>
               <a:t>night-light years</a:t>
-            </a:r>
-          </a:p>
-        </p:txBody>
-      </p:sp>
-      <p:sp>
-        <p:nvSpPr>
-          <p:cNvPr id="21" name="TextBox 20"/>
-          <p:cNvSpPr txBox="1"/>
-          <p:nvPr/>
-        </p:nvSpPr>
-        <p:spPr>
-          <a:xfrm>
-            <a:off x="640080" y="6291072"/>
-            <a:ext cx="10972800" cy="274320"/>
-          </a:xfrm>
-          <a:prstGeom prst="rect">
-            <a:avLst/>
-          </a:prstGeom>
-          <a:noFill/>
-        </p:spPr>
-        <p:txBody>
-          <a:bodyPr wrap="square">
-            <a:spAutoFit/>
-          </a:bodyPr>
-          <a:lstStyle/>
-          <a:p>
-            <a:pPr algn="l">
-              <a:spcAft>
-                <a:spcPts val="0"/>
-              </a:spcAft>
-            </a:pPr>
-            <a:r>
-              <a:rPr sz="950" b="0">
-                <a:solidFill>
-                  <a:srgbClr val="5A6474"/>
-                </a:solidFill>
-                <a:latin typeface="Segoe UI"/>
-              </a:rPr>
-              <a:t>Ghost growth: land that became built-up after 2010 but shows much less activity than comparable built-up land in the same city.</a:t>
             </a:r>
           </a:p>
         </p:txBody>
@@ -11766,7 +11635,7 @@
         <p:spPr>
           <a:xfrm>
             <a:off x="640080" y="384048"/>
-            <a:ext cx="10972800" cy="822960"/>
+            <a:ext cx="10972800" cy="553998"/>
           </a:xfrm>
           <a:prstGeom prst="rect">
             <a:avLst/>
@@ -11785,29 +11654,13 @@
               </a:spcAft>
             </a:pPr>
             <a:r>
-              <a:rPr sz="3000" b="1">
+              <a:rPr sz="3000" b="1" dirty="0">
                 <a:solidFill>
                   <a:srgbClr val="101826"/>
                 </a:solidFill>
                 <a:latin typeface="Segoe UI"/>
               </a:rPr>
               <a:t>What changed since Review 2</a:t>
-            </a:r>
-          </a:p>
-          <a:p>
-            <a:pPr>
-              <a:spcAft>
-                <a:spcPts val="0"/>
-              </a:spcAft>
-            </a:pPr>
-            <a:r>
-              <a:rPr sz="1350" b="0">
-                <a:solidFill>
-                  <a:srgbClr val="1B5FAF"/>
-                </a:solidFill>
-                <a:latin typeface="Segoe UI"/>
-              </a:rPr>
-              <a:t>Three things, in order of importance</a:t>
             </a:r>
           </a:p>
         </p:txBody>
@@ -13062,312 +12915,6 @@
           </a:graphicData>
         </a:graphic>
       </p:graphicFrame>
-      <p:sp>
-        <p:nvSpPr>
-          <p:cNvPr id="6" name="Rectangle 5"/>
-          <p:cNvSpPr/>
-          <p:nvPr/>
-        </p:nvSpPr>
-        <p:spPr>
-          <a:xfrm>
-            <a:off x="640080" y="5029200"/>
-            <a:ext cx="3474720" cy="1005840"/>
-          </a:xfrm>
-          <a:prstGeom prst="rect">
-            <a:avLst/>
-          </a:prstGeom>
-          <a:solidFill>
-            <a:srgbClr val="F1F5FA"/>
-          </a:solidFill>
-          <a:ln w="9525">
-            <a:solidFill>
-              <a:srgbClr val="C3CEDC"/>
-            </a:solidFill>
-          </a:ln>
-          <a:effectLst/>
-        </p:spPr>
-        <p:style>
-          <a:lnRef idx="1">
-            <a:schemeClr val="accent1"/>
-          </a:lnRef>
-          <a:fillRef idx="3">
-            <a:schemeClr val="accent1"/>
-          </a:fillRef>
-          <a:effectRef idx="2">
-            <a:schemeClr val="accent1"/>
-          </a:effectRef>
-          <a:fontRef idx="minor">
-            <a:schemeClr val="lt1"/>
-          </a:fontRef>
-        </p:style>
-        <p:txBody>
-          <a:bodyPr rtlCol="0" anchor="ctr"/>
-          <a:lstStyle/>
-          <a:p>
-            <a:pPr algn="ctr"/>
-            <a:endParaRPr/>
-          </a:p>
-        </p:txBody>
-      </p:sp>
-      <p:sp>
-        <p:nvSpPr>
-          <p:cNvPr id="7" name="TextBox 6"/>
-          <p:cNvSpPr txBox="1"/>
-          <p:nvPr/>
-        </p:nvSpPr>
-        <p:spPr>
-          <a:xfrm>
-            <a:off x="768096" y="5120640"/>
-            <a:ext cx="3218688" cy="822960"/>
-          </a:xfrm>
-          <a:prstGeom prst="rect">
-            <a:avLst/>
-          </a:prstGeom>
-          <a:noFill/>
-        </p:spPr>
-        <p:txBody>
-          <a:bodyPr wrap="square">
-            <a:spAutoFit/>
-          </a:bodyPr>
-          <a:lstStyle/>
-          <a:p>
-            <a:pPr algn="l">
-              <a:spcAft>
-                <a:spcPts val="200"/>
-              </a:spcAft>
-            </a:pPr>
-            <a:r>
-              <a:rPr sz="2000" b="1">
-                <a:solidFill>
-                  <a:srgbClr val="1B5FAF"/>
-                </a:solidFill>
-                <a:latin typeface="Segoe UI"/>
-              </a:rPr>
-              <a:t>41 of 41</a:t>
-            </a:r>
-          </a:p>
-          <a:p>
-            <a:pPr>
-              <a:spcAft>
-                <a:spcPts val="0"/>
-              </a:spcAft>
-            </a:pPr>
-            <a:r>
-              <a:rPr sz="1050" b="0">
-                <a:solidFill>
-                  <a:srgbClr val="5A6474"/>
-                </a:solidFill>
-                <a:latin typeface="Segoe UI"/>
-              </a:rPr>
-              <a:t>automated tests pass; 16 added for Review 3</a:t>
-            </a:r>
-          </a:p>
-        </p:txBody>
-      </p:sp>
-      <p:sp>
-        <p:nvSpPr>
-          <p:cNvPr id="8" name="Rectangle 7"/>
-          <p:cNvSpPr/>
-          <p:nvPr/>
-        </p:nvSpPr>
-        <p:spPr>
-          <a:xfrm>
-            <a:off x="4343400" y="5029200"/>
-            <a:ext cx="3474720" cy="1005840"/>
-          </a:xfrm>
-          <a:prstGeom prst="rect">
-            <a:avLst/>
-          </a:prstGeom>
-          <a:solidFill>
-            <a:srgbClr val="F1F5FA"/>
-          </a:solidFill>
-          <a:ln w="9525">
-            <a:solidFill>
-              <a:srgbClr val="C3CEDC"/>
-            </a:solidFill>
-          </a:ln>
-          <a:effectLst/>
-        </p:spPr>
-        <p:style>
-          <a:lnRef idx="1">
-            <a:schemeClr val="accent1"/>
-          </a:lnRef>
-          <a:fillRef idx="3">
-            <a:schemeClr val="accent1"/>
-          </a:fillRef>
-          <a:effectRef idx="2">
-            <a:schemeClr val="accent1"/>
-          </a:effectRef>
-          <a:fontRef idx="minor">
-            <a:schemeClr val="lt1"/>
-          </a:fontRef>
-        </p:style>
-        <p:txBody>
-          <a:bodyPr rtlCol="0" anchor="ctr"/>
-          <a:lstStyle/>
-          <a:p>
-            <a:pPr algn="ctr"/>
-            <a:endParaRPr/>
-          </a:p>
-        </p:txBody>
-      </p:sp>
-      <p:sp>
-        <p:nvSpPr>
-          <p:cNvPr id="9" name="TextBox 8"/>
-          <p:cNvSpPr txBox="1"/>
-          <p:nvPr/>
-        </p:nvSpPr>
-        <p:spPr>
-          <a:xfrm>
-            <a:off x="4471416" y="5120640"/>
-            <a:ext cx="3218688" cy="822960"/>
-          </a:xfrm>
-          <a:prstGeom prst="rect">
-            <a:avLst/>
-          </a:prstGeom>
-          <a:noFill/>
-        </p:spPr>
-        <p:txBody>
-          <a:bodyPr wrap="square">
-            <a:spAutoFit/>
-          </a:bodyPr>
-          <a:lstStyle/>
-          <a:p>
-            <a:pPr algn="l">
-              <a:spcAft>
-                <a:spcPts val="200"/>
-              </a:spcAft>
-            </a:pPr>
-            <a:r>
-              <a:rPr sz="2000" b="1">
-                <a:solidFill>
-                  <a:srgbClr val="0E7A52"/>
-                </a:solidFill>
-                <a:latin typeface="Segoe UI"/>
-              </a:rPr>
-              <a:t>about 3.5 min</a:t>
-            </a:r>
-          </a:p>
-          <a:p>
-            <a:pPr>
-              <a:spcAft>
-                <a:spcPts val="0"/>
-              </a:spcAft>
-            </a:pPr>
-            <a:r>
-              <a:rPr sz="1050" b="0">
-                <a:solidFill>
-                  <a:srgbClr val="5A6474"/>
-                </a:solidFill>
-                <a:latin typeface="Segoe UI"/>
-              </a:rPr>
-              <a:t>one end-to-end run, tests to figures</a:t>
-            </a:r>
-          </a:p>
-        </p:txBody>
-      </p:sp>
-      <p:sp>
-        <p:nvSpPr>
-          <p:cNvPr id="10" name="Rectangle 9"/>
-          <p:cNvSpPr/>
-          <p:nvPr/>
-        </p:nvSpPr>
-        <p:spPr>
-          <a:xfrm>
-            <a:off x="8046720" y="5029200"/>
-            <a:ext cx="3474720" cy="1005840"/>
-          </a:xfrm>
-          <a:prstGeom prst="rect">
-            <a:avLst/>
-          </a:prstGeom>
-          <a:solidFill>
-            <a:srgbClr val="F1F5FA"/>
-          </a:solidFill>
-          <a:ln w="9525">
-            <a:solidFill>
-              <a:srgbClr val="C3CEDC"/>
-            </a:solidFill>
-          </a:ln>
-          <a:effectLst/>
-        </p:spPr>
-        <p:style>
-          <a:lnRef idx="1">
-            <a:schemeClr val="accent1"/>
-          </a:lnRef>
-          <a:fillRef idx="3">
-            <a:schemeClr val="accent1"/>
-          </a:fillRef>
-          <a:effectRef idx="2">
-            <a:schemeClr val="accent1"/>
-          </a:effectRef>
-          <a:fontRef idx="minor">
-            <a:schemeClr val="lt1"/>
-          </a:fontRef>
-        </p:style>
-        <p:txBody>
-          <a:bodyPr rtlCol="0" anchor="ctr"/>
-          <a:lstStyle/>
-          <a:p>
-            <a:pPr algn="ctr"/>
-            <a:endParaRPr/>
-          </a:p>
-        </p:txBody>
-      </p:sp>
-      <p:sp>
-        <p:nvSpPr>
-          <p:cNvPr id="11" name="TextBox 10"/>
-          <p:cNvSpPr txBox="1"/>
-          <p:nvPr/>
-        </p:nvSpPr>
-        <p:spPr>
-          <a:xfrm>
-            <a:off x="8174736" y="5120640"/>
-            <a:ext cx="3218688" cy="822960"/>
-          </a:xfrm>
-          <a:prstGeom prst="rect">
-            <a:avLst/>
-          </a:prstGeom>
-          <a:noFill/>
-        </p:spPr>
-        <p:txBody>
-          <a:bodyPr wrap="square">
-            <a:spAutoFit/>
-          </a:bodyPr>
-          <a:lstStyle/>
-          <a:p>
-            <a:pPr algn="l">
-              <a:spcAft>
-                <a:spcPts val="200"/>
-              </a:spcAft>
-            </a:pPr>
-            <a:r>
-              <a:rPr sz="2000" b="1">
-                <a:solidFill>
-                  <a:srgbClr val="B26A00"/>
-                </a:solidFill>
-                <a:latin typeface="Segoe UI"/>
-              </a:rPr>
-              <a:t>15 of 15</a:t>
-            </a:r>
-          </a:p>
-          <a:p>
-            <a:pPr>
-              <a:spcAft>
-                <a:spcPts val="0"/>
-              </a:spcAft>
-            </a:pPr>
-            <a:r>
-              <a:rPr sz="1050" b="0">
-                <a:solidFill>
-                  <a:srgbClr val="5A6474"/>
-                </a:solidFill>
-                <a:latin typeface="Segoe UI"/>
-              </a:rPr>
-              <a:t>audit defects fixed</a:t>
-            </a:r>
-          </a:p>
-        </p:txBody>
-      </p:sp>
     </p:spTree>
   </p:cSld>
   <p:clrMapOvr>
@@ -13548,14 +13095,15 @@
         </p:nvPicPr>
         <p:blipFill>
           <a:blip r:embed="rId3"/>
+          <a:srcRect l="1633"/>
           <a:stretch>
             <a:fillRect/>
           </a:stretch>
         </p:blipFill>
         <p:spPr>
           <a:xfrm>
-            <a:off x="1088817" y="1508760"/>
-            <a:ext cx="10011318" cy="5074920"/>
+            <a:off x="1171944" y="1508760"/>
+            <a:ext cx="9847805" cy="5074920"/>
           </a:xfrm>
           <a:prstGeom prst="rect">
             <a:avLst/>
@@ -13641,7 +13189,7 @@
         <p:spPr>
           <a:xfrm>
             <a:off x="640080" y="384048"/>
-            <a:ext cx="10972800" cy="822960"/>
+            <a:ext cx="10972800" cy="553998"/>
           </a:xfrm>
           <a:prstGeom prst="rect">
             <a:avLst/>
@@ -13660,29 +13208,13 @@
               </a:spcAft>
             </a:pPr>
             <a:r>
-              <a:rPr sz="3000" b="1">
+              <a:rPr sz="3000" b="1" dirty="0">
                 <a:solidFill>
                   <a:srgbClr val="101826"/>
                 </a:solidFill>
                 <a:latin typeface="Segoe UI"/>
               </a:rPr>
               <a:t>Datasets</a:t>
-            </a:r>
-          </a:p>
-          <a:p>
-            <a:pPr>
-              <a:spcAft>
-                <a:spcPts val="0"/>
-              </a:spcAft>
-            </a:pPr>
-            <a:r>
-              <a:rPr sz="1350" b="0">
-                <a:solidFill>
-                  <a:srgbClr val="1B5FAF"/>
-                </a:solidFill>
-                <a:latin typeface="Segoe UI"/>
-              </a:rPr>
-              <a:t>Official identifiers; the Indian records are new this review</a:t>
             </a:r>
           </a:p>
         </p:txBody>
@@ -14762,45 +14294,6 @@
           </a:graphicData>
         </a:graphic>
       </p:graphicFrame>
-      <p:sp>
-        <p:nvSpPr>
-          <p:cNvPr id="7" name="TextBox 6"/>
-          <p:cNvSpPr txBox="1"/>
-          <p:nvPr/>
-        </p:nvSpPr>
-        <p:spPr>
-          <a:xfrm>
-            <a:off x="640080" y="6291072"/>
-            <a:ext cx="10972800" cy="274320"/>
-          </a:xfrm>
-          <a:prstGeom prst="rect">
-            <a:avLst/>
-          </a:prstGeom>
-          <a:noFill/>
-        </p:spPr>
-        <p:txBody>
-          <a:bodyPr wrap="square">
-            <a:spAutoFit/>
-          </a:bodyPr>
-          <a:lstStyle/>
-          <a:p>
-            <a:pPr algn="l">
-              <a:spcAft>
-                <a:spcPts val="0"/>
-              </a:spcAft>
-            </a:pPr>
-            <a:r>
-              <a:rPr sz="950" b="0">
-                <a:solidFill>
-                  <a:srgbClr val="5A6474"/>
-                </a:solidFill>
-                <a:latin typeface="Segoe UI"/>
-              </a:rPr>
-              <a:t>SHRUG is used under CC BY-NC-SA 4.0 and cited as Asher, Lunt, Matsuura and Novosad (2021). DES: Directorate of Economics and Statistics.</a:t>
-            </a:r>
-          </a:p>
-        </p:txBody>
-      </p:sp>
     </p:spTree>
   </p:cSld>
   <p:clrMapOvr>
@@ -14880,7 +14373,7 @@
         <p:spPr>
           <a:xfrm>
             <a:off x="640080" y="384048"/>
-            <a:ext cx="10972800" cy="822960"/>
+            <a:ext cx="10972800" cy="553998"/>
           </a:xfrm>
           <a:prstGeom prst="rect">
             <a:avLst/>
@@ -14899,29 +14392,13 @@
               </a:spcAft>
             </a:pPr>
             <a:r>
-              <a:rPr sz="3000" b="1">
+              <a:rPr sz="3000" b="1" dirty="0">
                 <a:solidFill>
                   <a:srgbClr val="101826"/>
                 </a:solidFill>
                 <a:latin typeface="Segoe UI"/>
               </a:rPr>
               <a:t>Processing flow</a:t>
-            </a:r>
-          </a:p>
-          <a:p>
-            <a:pPr>
-              <a:spcAft>
-                <a:spcPts val="0"/>
-              </a:spcAft>
-            </a:pPr>
-            <a:r>
-              <a:rPr sz="1350" b="0">
-                <a:solidFill>
-                  <a:srgbClr val="1B5FAF"/>
-                </a:solidFill>
-                <a:latin typeface="Segoe UI"/>
-              </a:rPr>
-              <a:t>Seven stages; each hands a named layer to the next</a:t>
             </a:r>
           </a:p>
         </p:txBody>
@@ -14981,6 +14458,7 @@
         </p:nvPicPr>
         <p:blipFill>
           <a:blip r:embed="rId3"/>
+          <a:srcRect b="16660"/>
           <a:stretch>
             <a:fillRect/>
           </a:stretch>
@@ -14988,7 +14466,7 @@
         <p:spPr>
           <a:xfrm>
             <a:off x="710829" y="1508760"/>
-            <a:ext cx="10767294" cy="5074920"/>
+            <a:ext cx="10767294" cy="4229431"/>
           </a:xfrm>
           <a:prstGeom prst="rect">
             <a:avLst/>
@@ -15074,7 +14552,7 @@
         <p:spPr>
           <a:xfrm>
             <a:off x="640080" y="384048"/>
-            <a:ext cx="10972800" cy="822960"/>
+            <a:ext cx="10972800" cy="553998"/>
           </a:xfrm>
           <a:prstGeom prst="rect">
             <a:avLst/>
@@ -15093,29 +14571,13 @@
               </a:spcAft>
             </a:pPr>
             <a:r>
-              <a:rPr sz="3000" b="1">
+              <a:rPr sz="3000" b="1" dirty="0">
                 <a:solidFill>
                   <a:srgbClr val="101826"/>
                 </a:solidFill>
                 <a:latin typeface="Segoe UI"/>
               </a:rPr>
               <a:t>Analysis grid and aggregation</a:t>
-            </a:r>
-          </a:p>
-          <a:p>
-            <a:pPr>
-              <a:spcAft>
-                <a:spcPts val="0"/>
-              </a:spcAft>
-            </a:pPr>
-            <a:r>
-              <a:rPr sz="1350" b="0">
-                <a:solidFill>
-                  <a:srgbClr val="1B5FAF"/>
-                </a:solidFill>
-                <a:latin typeface="Segoe UI"/>
-              </a:rPr>
-              <a:t>Analysis at 100 m, reporting at 500 m - the scale night-time light can support</a:t>
             </a:r>
           </a:p>
         </p:txBody>
@@ -15268,7 +14730,7 @@
         <p:spPr>
           <a:xfrm>
             <a:off x="640080" y="384048"/>
-            <a:ext cx="10972800" cy="822960"/>
+            <a:ext cx="10972800" cy="553998"/>
           </a:xfrm>
           <a:prstGeom prst="rect">
             <a:avLst/>
@@ -15287,29 +14749,13 @@
               </a:spcAft>
             </a:pPr>
             <a:r>
-              <a:rPr sz="3000" b="1">
+              <a:rPr sz="3000" b="1" dirty="0">
                 <a:solidFill>
                   <a:srgbClr val="101826"/>
                 </a:solidFill>
                 <a:latin typeface="Segoe UI"/>
               </a:rPr>
               <a:t>Temporal design</a:t>
-            </a:r>
-          </a:p>
-          <a:p>
-            <a:pPr>
-              <a:spcAft>
-                <a:spcPts val="0"/>
-              </a:spcAft>
-            </a:pPr>
-            <a:r>
-              <a:rPr sz="1350" b="0">
-                <a:solidFill>
-                  <a:srgbClr val="1B5FAF"/>
-                </a:solidFill>
-                <a:latin typeface="Segoe UI"/>
-              </a:rPr>
-              <a:t>2020 is the last observed epoch; later years are projections or our own predictions</a:t>
             </a:r>
           </a:p>
         </p:txBody>

</xml_diff>